<commit_message>
Fix sd-10-005: Collection add and remove are optional operations
The lesson, figure and deck said a collection class needs to support adding and removing; the OpenJDK documentation treats them as optional operations that unmodifiable collections reject. Also cite every OpenJDK file behind the compound claims of the metadata.

Co-Authored-By: Claude Sonnet 5.5 <noreply@anthropic.com>
Claude-Session: https://claude.ai/code/session_01E4oCkXXqBf2c7oMUzFxEr2
</commit_message>
<xml_diff>
--- a/system-design-101/vi/lessons/sd-10-005/slides/sd-10-005.pptx
+++ b/system-design-101/vi/lessons/sd-10-005/slides/sd-10-005.pptx
@@ -7142,7 +7142,1291 @@
       </p:sp>
       <p:sp>
         <p:nvSpPr>
-          <p:cNvPr id="5" name="Text richtext-1792335468114-290860052"/>
+          <p:cNvPr id="5" name="Text 3"/>
+          <p:cNvSpPr/>
+          <p:nvPr/>
+        </p:nvSpPr>
+        <p:spPr>
+          <a:xfrm>
+            <a:off x="914400" y="5619750"/>
+            <a:ext cx="4191000" cy="647700"/>
+          </a:xfrm>
+          <a:prstGeom prst="roundRect">
+            <a:avLst>
+              <a:gd name="adj" fmla="val 50000"/>
+            </a:avLst>
+          </a:prstGeom>
+          <a:solidFill>
+            <a:srgbClr val="F3EEE3"/>
+          </a:solidFill>
+          <a:ln/>
+        </p:spPr>
+        <p:txBody>
+          <a:bodyPr wrap="square" lIns="0" tIns="0" rIns="0" bIns="0" rtlCol="0" anchor="ctr"/>
+          <a:lstStyle/>
+          <a:p>
+            <a:pPr algn="ctr" indent="0" marL="0">
+              <a:buNone/>
+            </a:pPr>
+            <a:r>
+              <a:rPr lang="en-US" sz="2100" b="1" dirty="0" spc="-21" kern="0">
+                <a:solidFill>
+                  <a:srgbClr val="14161C"/>
+                </a:solidFill>
+                <a:latin typeface="Be Vietnam Pro" pitchFamily="34" charset="0"/>
+                <a:ea typeface="Be Vietnam Pro" pitchFamily="34" charset="-122"/>
+                <a:cs typeface="Be Vietnam Pro" pitchFamily="34" charset="-120"/>
+              </a:rPr>
+              <a:t>vòng</a:t>
+            </a:r>
+            <a:r>
+              <a:rPr lang="en-US" sz="2100" b="1" dirty="0" spc="0" kern="0">
+                <a:solidFill>
+                  <a:srgbClr val="14161C"/>
+                </a:solidFill>
+                <a:latin typeface="Be Vietnam Pro" pitchFamily="34" charset="0"/>
+                <a:ea typeface="Be Vietnam Pro" pitchFamily="34" charset="-122"/>
+                <a:cs typeface="Be Vietnam Pro" pitchFamily="34" charset="-120"/>
+              </a:rPr>
+              <a:t> lặp</a:t>
+            </a:r>
+            <a:r>
+              <a:rPr lang="en-US" sz="2100" b="1" dirty="0" spc="-13" kern="0">
+                <a:solidFill>
+                  <a:srgbClr val="14161C"/>
+                </a:solidFill>
+                <a:latin typeface="Be Vietnam Pro" pitchFamily="34" charset="0"/>
+                <a:ea typeface="Be Vietnam Pro" pitchFamily="34" charset="-122"/>
+                <a:cs typeface="Be Vietnam Pro" pitchFamily="34" charset="-120"/>
+              </a:rPr>
+              <a:t> for</a:t>
+            </a:r>
+            <a:r>
+              <a:rPr lang="en-US" sz="2100" b="1" dirty="0" spc="-2" kern="0">
+                <a:solidFill>
+                  <a:srgbClr val="14161C"/>
+                </a:solidFill>
+                <a:latin typeface="Be Vietnam Pro" pitchFamily="34" charset="0"/>
+                <a:ea typeface="Be Vietnam Pro" pitchFamily="34" charset="-122"/>
+                <a:cs typeface="Be Vietnam Pro" pitchFamily="34" charset="-120"/>
+              </a:rPr>
+              <a:t> nâng</a:t>
+            </a:r>
+            <a:r>
+              <a:rPr lang="en-US" sz="2100" b="1" dirty="0" spc="-5" kern="0">
+                <a:solidFill>
+                  <a:srgbClr val="14161C"/>
+                </a:solidFill>
+                <a:latin typeface="Be Vietnam Pro" pitchFamily="34" charset="0"/>
+                <a:ea typeface="Be Vietnam Pro" pitchFamily="34" charset="-122"/>
+                <a:cs typeface="Be Vietnam Pro" pitchFamily="34" charset="-120"/>
+              </a:rPr>
+              <a:t> cao</a:t>
+            </a:r>
+            <a:endParaRPr lang="en-US" sz="2100" dirty="0"/>
+          </a:p>
+        </p:txBody>
+      </p:sp>
+      <p:sp>
+        <p:nvSpPr>
+          <p:cNvPr id="6" name="Text 4"/>
+          <p:cNvSpPr/>
+          <p:nvPr/>
+        </p:nvSpPr>
+        <p:spPr>
+          <a:xfrm>
+            <a:off x="5295900" y="5619750"/>
+            <a:ext cx="1905000" cy="647700"/>
+          </a:xfrm>
+          <a:prstGeom prst="roundRect">
+            <a:avLst>
+              <a:gd name="adj" fmla="val 50000"/>
+            </a:avLst>
+          </a:prstGeom>
+          <a:solidFill>
+            <a:srgbClr val="F3EEE3"/>
+          </a:solidFill>
+          <a:ln/>
+        </p:spPr>
+        <p:txBody>
+          <a:bodyPr wrap="square" lIns="0" tIns="0" rIns="0" bIns="0" rtlCol="0" anchor="ctr"/>
+          <a:lstStyle/>
+          <a:p>
+            <a:pPr algn="ctr" indent="0" marL="0">
+              <a:buNone/>
+            </a:pPr>
+            <a:r>
+              <a:rPr lang="en-US" sz="2100" b="1" dirty="0" spc="-15" kern="0">
+                <a:solidFill>
+                  <a:srgbClr val="14161C"/>
+                </a:solidFill>
+                <a:latin typeface="Be Vietnam Pro" pitchFamily="34" charset="0"/>
+                <a:ea typeface="Be Vietnam Pro" pitchFamily="34" charset="-122"/>
+                <a:cs typeface="Be Vietnam Pro" pitchFamily="34" charset="-120"/>
+              </a:rPr>
+              <a:t>iterator</a:t>
+            </a:r>
+            <a:endParaRPr lang="en-US" sz="2100" dirty="0"/>
+          </a:p>
+        </p:txBody>
+      </p:sp>
+      <p:sp>
+        <p:nvSpPr>
+          <p:cNvPr id="7" name="Shape 5"/>
+          <p:cNvSpPr/>
+          <p:nvPr/>
+        </p:nvSpPr>
+        <p:spPr>
+          <a:xfrm>
+            <a:off x="914400" y="6667500"/>
+            <a:ext cx="7620000" cy="2000250"/>
+          </a:xfrm>
+          <a:prstGeom prst="roundRect">
+            <a:avLst>
+              <a:gd name="adj" fmla="val 13333"/>
+            </a:avLst>
+          </a:prstGeom>
+          <a:solidFill>
+            <a:srgbClr val="1E212B"/>
+          </a:solidFill>
+          <a:ln/>
+        </p:spPr>
+      </p:sp>
+      <p:sp>
+        <p:nvSpPr>
+          <p:cNvPr id="8" name="Shape 6"/>
+          <p:cNvSpPr/>
+          <p:nvPr/>
+        </p:nvSpPr>
+        <p:spPr>
+          <a:xfrm>
+            <a:off x="914400" y="6667500"/>
+            <a:ext cx="133350" cy="2000250"/>
+          </a:xfrm>
+          <a:prstGeom prst="roundRect">
+            <a:avLst>
+              <a:gd name="adj" fmla="val 50000"/>
+            </a:avLst>
+          </a:prstGeom>
+          <a:solidFill>
+            <a:srgbClr val="F3EEE3"/>
+          </a:solidFill>
+          <a:ln/>
+        </p:spPr>
+      </p:sp>
+      <p:sp>
+        <p:nvSpPr>
+          <p:cNvPr id="9" name="Text 7"/>
+          <p:cNvSpPr/>
+          <p:nvPr/>
+        </p:nvSpPr>
+        <p:spPr>
+          <a:xfrm>
+            <a:off x="1333500" y="6934200"/>
+            <a:ext cx="5715000" cy="323850"/>
+          </a:xfrm>
+          <a:prstGeom prst="rect">
+            <a:avLst/>
+          </a:prstGeom>
+          <a:noFill/>
+          <a:ln/>
+        </p:spPr>
+        <p:txBody>
+          <a:bodyPr wrap="square" lIns="0" tIns="0" rIns="0" bIns="0" rtlCol="0" anchor="t"/>
+          <a:lstStyle/>
+          <a:p>
+            <a:pPr algn="l" indent="0" marL="0">
+              <a:buNone/>
+            </a:pPr>
+            <a:r>
+              <a:rPr lang="en-US" sz="1800" b="1" spc="225" kern="0" dirty="0">
+                <a:solidFill>
+                  <a:srgbClr val="F3EEE3"/>
+                </a:solidFill>
+                <a:latin typeface="Be Vietnam Pro" pitchFamily="34" charset="0"/>
+                <a:ea typeface="Be Vietnam Pro" pitchFamily="34" charset="-122"/>
+                <a:cs typeface="Be Vietnam Pro" pitchFamily="34" charset="-120"/>
+              </a:rPr>
+              <a:t>GHI</a:t>
+            </a:r>
+            <a:r>
+              <a:rPr lang="en-US" sz="1800" b="1" spc="227" kern="0" dirty="0">
+                <a:solidFill>
+                  <a:srgbClr val="F3EEE3"/>
+                </a:solidFill>
+                <a:latin typeface="Be Vietnam Pro" pitchFamily="34" charset="0"/>
+                <a:ea typeface="Be Vietnam Pro" pitchFamily="34" charset="-122"/>
+                <a:cs typeface="Be Vietnam Pro" pitchFamily="34" charset="-120"/>
+              </a:rPr>
+              <a:t> NHỚ</a:t>
+            </a:r>
+            <a:endParaRPr lang="en-US" sz="1800" dirty="0"/>
+          </a:p>
+        </p:txBody>
+      </p:sp>
+      <p:sp>
+        <p:nvSpPr>
+          <p:cNvPr id="10" name="Shape 8"/>
+          <p:cNvSpPr/>
+          <p:nvPr/>
+        </p:nvSpPr>
+        <p:spPr>
+          <a:xfrm>
+            <a:off x="9144000" y="914400"/>
+            <a:ext cx="8229600" cy="7848600"/>
+          </a:xfrm>
+          <a:prstGeom prst="roundRect">
+            <a:avLst>
+              <a:gd name="adj" fmla="val 3398"/>
+            </a:avLst>
+          </a:prstGeom>
+          <a:solidFill>
+            <a:srgbClr val="1E212B"/>
+          </a:solidFill>
+          <a:ln w="19050">
+            <a:solidFill>
+              <a:srgbClr val="2C3040"/>
+            </a:solidFill>
+            <a:prstDash val="solid"/>
+          </a:ln>
+        </p:spPr>
+      </p:sp>
+      <p:sp>
+        <p:nvSpPr>
+          <p:cNvPr id="11" name="Connector line-1792335468145-224870917"/>
+          <p:cNvSpPr/>
+          <p:nvPr/>
+        </p:nvSpPr>
+        <p:spPr>
+          <a:xfrm flipV="1">
+            <a:off x="13258800" y="2895600"/>
+            <a:ext cx="0" cy="590550"/>
+          </a:xfrm>
+          <a:prstGeom prst="line">
+            <a:avLst/>
+          </a:prstGeom>
+          <a:noFill/>
+          <a:ln w="47625">
+            <a:solidFill>
+              <a:srgbClr val="F3EEE3"/>
+            </a:solidFill>
+            <a:prstDash val="solid"/>
+            <a:headEnd type="none"/>
+            <a:tailEnd type="triangle"/>
+          </a:ln>
+        </p:spPr>
+      </p:sp>
+      <p:sp>
+        <p:nvSpPr>
+          <p:cNvPr id="12" name="Text 10"/>
+          <p:cNvSpPr/>
+          <p:nvPr/>
+        </p:nvSpPr>
+        <p:spPr>
+          <a:xfrm>
+            <a:off x="13487400" y="3028950"/>
+            <a:ext cx="1905000" cy="381000"/>
+          </a:xfrm>
+          <a:prstGeom prst="rect">
+            <a:avLst/>
+          </a:prstGeom>
+          <a:noFill/>
+          <a:ln/>
+        </p:spPr>
+        <p:txBody>
+          <a:bodyPr wrap="square" lIns="0" tIns="0" rIns="0" bIns="0" rtlCol="0" anchor="t"/>
+          <a:lstStyle/>
+          <a:p>
+            <a:pPr algn="l" indent="0" marL="0">
+              <a:buNone/>
+            </a:pPr>
+            <a:r>
+              <a:rPr lang="en-US" sz="1950" dirty="0" spc="-46" kern="0">
+                <a:solidFill>
+                  <a:srgbClr val="9AA0B5"/>
+                </a:solidFill>
+                <a:latin typeface="Be Vietnam Pro" pitchFamily="34" charset="0"/>
+                <a:ea typeface="Be Vietnam Pro" pitchFamily="34" charset="-122"/>
+                <a:cs typeface="Be Vietnam Pro" pitchFamily="34" charset="-120"/>
+              </a:rPr>
+              <a:t>kế</a:t>
+            </a:r>
+            <a:r>
+              <a:rPr lang="en-US" sz="1950" dirty="0" spc="6" kern="0">
+                <a:solidFill>
+                  <a:srgbClr val="9AA0B5"/>
+                </a:solidFill>
+                <a:latin typeface="Be Vietnam Pro" pitchFamily="34" charset="0"/>
+                <a:ea typeface="Be Vietnam Pro" pitchFamily="34" charset="-122"/>
+                <a:cs typeface="Be Vietnam Pro" pitchFamily="34" charset="-120"/>
+              </a:rPr>
+              <a:t> thừa</a:t>
+            </a:r>
+            <a:endParaRPr lang="en-US" sz="1950" dirty="0"/>
+          </a:p>
+        </p:txBody>
+      </p:sp>
+      <p:sp>
+        <p:nvSpPr>
+          <p:cNvPr id="13" name="Connector line-1792335468148-689857458"/>
+          <p:cNvSpPr/>
+          <p:nvPr/>
+        </p:nvSpPr>
+        <p:spPr>
+          <a:xfrm flipH="1">
+            <a:off x="10668000" y="4972050"/>
+            <a:ext cx="2590800" cy="1466850"/>
+          </a:xfrm>
+          <a:prstGeom prst="line">
+            <a:avLst/>
+          </a:prstGeom>
+          <a:noFill/>
+          <a:ln w="47625">
+            <a:solidFill>
+              <a:srgbClr val="7C93FF"/>
+            </a:solidFill>
+            <a:prstDash val="solid"/>
+            <a:headEnd type="none"/>
+            <a:tailEnd type="triangle"/>
+          </a:ln>
+        </p:spPr>
+      </p:sp>
+      <p:sp>
+        <p:nvSpPr>
+          <p:cNvPr id="14" name="Connector line-1792335468148-859502814"/>
+          <p:cNvSpPr/>
+          <p:nvPr/>
+        </p:nvSpPr>
+        <p:spPr>
+          <a:xfrm>
+            <a:off x="13258800" y="4972050"/>
+            <a:ext cx="0" cy="1466850"/>
+          </a:xfrm>
+          <a:prstGeom prst="line">
+            <a:avLst/>
+          </a:prstGeom>
+          <a:noFill/>
+          <a:ln w="47625">
+            <a:solidFill>
+              <a:srgbClr val="3DD6A0"/>
+            </a:solidFill>
+            <a:prstDash val="solid"/>
+            <a:headEnd type="none"/>
+            <a:tailEnd type="triangle"/>
+          </a:ln>
+        </p:spPr>
+      </p:sp>
+      <p:sp>
+        <p:nvSpPr>
+          <p:cNvPr id="15" name="Connector line-1792335468149-617779725"/>
+          <p:cNvSpPr/>
+          <p:nvPr/>
+        </p:nvSpPr>
+        <p:spPr>
+          <a:xfrm>
+            <a:off x="13258800" y="4972050"/>
+            <a:ext cx="2590800" cy="1466850"/>
+          </a:xfrm>
+          <a:prstGeom prst="line">
+            <a:avLst/>
+          </a:prstGeom>
+          <a:noFill/>
+          <a:ln w="47625">
+            <a:solidFill>
+              <a:srgbClr val="FFB454"/>
+            </a:solidFill>
+            <a:prstDash val="solid"/>
+            <a:headEnd type="none"/>
+            <a:tailEnd type="triangle"/>
+          </a:ln>
+        </p:spPr>
+      </p:sp>
+      <p:sp>
+        <p:nvSpPr>
+          <p:cNvPr id="16" name="Shape 14"/>
+          <p:cNvSpPr/>
+          <p:nvPr/>
+        </p:nvSpPr>
+        <p:spPr>
+          <a:xfrm>
+            <a:off x="11353800" y="1619250"/>
+            <a:ext cx="3810000" cy="1238250"/>
+          </a:xfrm>
+          <a:prstGeom prst="roundRect">
+            <a:avLst>
+              <a:gd name="adj" fmla="val 18462"/>
+            </a:avLst>
+          </a:prstGeom>
+          <a:solidFill>
+            <a:srgbClr val="2C3040"/>
+          </a:solidFill>
+          <a:ln w="28575">
+            <a:solidFill>
+              <a:srgbClr val="F3EEE3"/>
+            </a:solidFill>
+            <a:prstDash val="solid"/>
+          </a:ln>
+        </p:spPr>
+      </p:sp>
+      <p:sp>
+        <p:nvSpPr>
+          <p:cNvPr id="17" name="Text 15"/>
+          <p:cNvSpPr/>
+          <p:nvPr/>
+        </p:nvSpPr>
+        <p:spPr>
+          <a:xfrm>
+            <a:off x="11544300" y="1695450"/>
+            <a:ext cx="3429000" cy="666750"/>
+          </a:xfrm>
+          <a:prstGeom prst="rect">
+            <a:avLst/>
+          </a:prstGeom>
+          <a:noFill/>
+          <a:ln/>
+        </p:spPr>
+        <p:txBody>
+          <a:bodyPr wrap="square" lIns="0" tIns="0" rIns="0" bIns="0" rtlCol="0" anchor="ctr"/>
+          <a:lstStyle/>
+          <a:p>
+            <a:pPr algn="ctr" indent="0" marL="0">
+              <a:buNone/>
+            </a:pPr>
+            <a:r>
+              <a:rPr lang="en-US" sz="3600" dirty="0" spc="-14" kern="0">
+                <a:solidFill>
+                  <a:srgbClr val="F3EEE3"/>
+                </a:solidFill>
+                <a:latin typeface="Bricolage Grotesque ExtraBold" pitchFamily="34" charset="0"/>
+                <a:ea typeface="Bricolage Grotesque ExtraBold" pitchFamily="34" charset="-122"/>
+                <a:cs typeface="Bricolage Grotesque ExtraBold" pitchFamily="34" charset="-120"/>
+              </a:rPr>
+              <a:t>Iterable</a:t>
+            </a:r>
+            <a:endParaRPr lang="en-US" sz="3600" dirty="0"/>
+          </a:p>
+        </p:txBody>
+      </p:sp>
+      <p:sp>
+        <p:nvSpPr>
+          <p:cNvPr id="18" name="Text 16"/>
+          <p:cNvSpPr/>
+          <p:nvPr/>
+        </p:nvSpPr>
+        <p:spPr>
+          <a:xfrm>
+            <a:off x="11544300" y="2362200"/>
+            <a:ext cx="3429000" cy="381000"/>
+          </a:xfrm>
+          <a:prstGeom prst="rect">
+            <a:avLst/>
+          </a:prstGeom>
+          <a:noFill/>
+          <a:ln/>
+        </p:spPr>
+        <p:txBody>
+          <a:bodyPr wrap="square" lIns="0" tIns="0" rIns="0" bIns="0" rtlCol="0" anchor="ctr"/>
+          <a:lstStyle/>
+          <a:p>
+            <a:pPr algn="ctr" indent="0" marL="0">
+              <a:buNone/>
+            </a:pPr>
+            <a:r>
+              <a:rPr lang="en-US" sz="1950" dirty="0" spc="-18" kern="0">
+                <a:solidFill>
+                  <a:srgbClr val="C4C8D6"/>
+                </a:solidFill>
+                <a:latin typeface="Be Vietnam Pro" pitchFamily="34" charset="0"/>
+                <a:ea typeface="Be Vietnam Pro" pitchFamily="34" charset="-122"/>
+                <a:cs typeface="Be Vietnam Pro" pitchFamily="34" charset="-120"/>
+              </a:rPr>
+              <a:t>duyệt</a:t>
+            </a:r>
+            <a:r>
+              <a:rPr lang="en-US" sz="1950" dirty="0" spc="17" kern="0">
+                <a:solidFill>
+                  <a:srgbClr val="C4C8D6"/>
+                </a:solidFill>
+                <a:latin typeface="Be Vietnam Pro" pitchFamily="34" charset="0"/>
+                <a:ea typeface="Be Vietnam Pro" pitchFamily="34" charset="-122"/>
+                <a:cs typeface="Be Vietnam Pro" pitchFamily="34" charset="-120"/>
+              </a:rPr>
+              <a:t> từng</a:t>
+            </a:r>
+            <a:r>
+              <a:rPr lang="en-US" sz="1950" dirty="0" spc="-1" kern="0">
+                <a:solidFill>
+                  <a:srgbClr val="C4C8D6"/>
+                </a:solidFill>
+                <a:latin typeface="Be Vietnam Pro" pitchFamily="34" charset="0"/>
+                <a:ea typeface="Be Vietnam Pro" pitchFamily="34" charset="-122"/>
+                <a:cs typeface="Be Vietnam Pro" pitchFamily="34" charset="-120"/>
+              </a:rPr>
+              <a:t> phần</a:t>
+            </a:r>
+            <a:r>
+              <a:rPr lang="en-US" sz="1950" dirty="0" spc="0" kern="0">
+                <a:solidFill>
+                  <a:srgbClr val="C4C8D6"/>
+                </a:solidFill>
+                <a:latin typeface="Be Vietnam Pro" pitchFamily="34" charset="0"/>
+                <a:ea typeface="Be Vietnam Pro" pitchFamily="34" charset="-122"/>
+                <a:cs typeface="Be Vietnam Pro" pitchFamily="34" charset="-120"/>
+              </a:rPr>
+              <a:t> tử</a:t>
+            </a:r>
+            <a:endParaRPr lang="en-US" sz="1950" dirty="0"/>
+          </a:p>
+        </p:txBody>
+      </p:sp>
+      <p:sp>
+        <p:nvSpPr>
+          <p:cNvPr id="19" name="Shape 17"/>
+          <p:cNvSpPr/>
+          <p:nvPr/>
+        </p:nvSpPr>
+        <p:spPr>
+          <a:xfrm>
+            <a:off x="11163300" y="3524250"/>
+            <a:ext cx="4191000" cy="1428750"/>
+          </a:xfrm>
+          <a:prstGeom prst="roundRect">
+            <a:avLst>
+              <a:gd name="adj" fmla="val 16000"/>
+            </a:avLst>
+          </a:prstGeom>
+          <a:solidFill>
+            <a:srgbClr val="F3EEE3"/>
+          </a:solidFill>
+          <a:ln/>
+        </p:spPr>
+      </p:sp>
+      <p:sp>
+        <p:nvSpPr>
+          <p:cNvPr id="20" name="Text 18"/>
+          <p:cNvSpPr/>
+          <p:nvPr/>
+        </p:nvSpPr>
+        <p:spPr>
+          <a:xfrm>
+            <a:off x="11353800" y="3638550"/>
+            <a:ext cx="3810000" cy="666750"/>
+          </a:xfrm>
+          <a:prstGeom prst="rect">
+            <a:avLst/>
+          </a:prstGeom>
+          <a:noFill/>
+          <a:ln/>
+        </p:spPr>
+        <p:txBody>
+          <a:bodyPr wrap="square" lIns="0" tIns="0" rIns="0" bIns="0" rtlCol="0" anchor="ctr"/>
+          <a:lstStyle/>
+          <a:p>
+            <a:pPr algn="ctr" indent="0" marL="0">
+              <a:buNone/>
+            </a:pPr>
+            <a:r>
+              <a:rPr lang="en-US" sz="3600" dirty="0" spc="2" kern="0">
+                <a:solidFill>
+                  <a:srgbClr val="14161C"/>
+                </a:solidFill>
+                <a:latin typeface="Bricolage Grotesque ExtraBold" pitchFamily="34" charset="0"/>
+                <a:ea typeface="Bricolage Grotesque ExtraBold" pitchFamily="34" charset="-122"/>
+                <a:cs typeface="Bricolage Grotesque ExtraBold" pitchFamily="34" charset="-120"/>
+              </a:rPr>
+              <a:t>Collection</a:t>
+            </a:r>
+            <a:endParaRPr lang="en-US" sz="3600" dirty="0"/>
+          </a:p>
+        </p:txBody>
+      </p:sp>
+      <p:sp>
+        <p:nvSpPr>
+          <p:cNvPr id="21" name="Text 19"/>
+          <p:cNvSpPr/>
+          <p:nvPr/>
+        </p:nvSpPr>
+        <p:spPr>
+          <a:xfrm>
+            <a:off x="9525000" y="6477000"/>
+            <a:ext cx="2286000" cy="1238250"/>
+          </a:xfrm>
+          <a:prstGeom prst="roundRect">
+            <a:avLst>
+              <a:gd name="adj" fmla="val 18462"/>
+            </a:avLst>
+          </a:prstGeom>
+          <a:solidFill>
+            <a:srgbClr val="7C93FF"/>
+          </a:solidFill>
+          <a:ln/>
+        </p:spPr>
+        <p:txBody>
+          <a:bodyPr wrap="square" lIns="0" tIns="0" rIns="0" bIns="0" rtlCol="0" anchor="ctr"/>
+          <a:lstStyle/>
+          <a:p>
+            <a:pPr algn="ctr" indent="0" marL="0">
+              <a:buNone/>
+            </a:pPr>
+            <a:r>
+              <a:rPr lang="en-US" sz="3300" dirty="0" spc="-8" kern="0">
+                <a:solidFill>
+                  <a:srgbClr val="14161C"/>
+                </a:solidFill>
+                <a:latin typeface="Be Vietnam Pro ExtraBold" pitchFamily="34" charset="0"/>
+                <a:ea typeface="Be Vietnam Pro ExtraBold" pitchFamily="34" charset="-122"/>
+                <a:cs typeface="Be Vietnam Pro ExtraBold" pitchFamily="34" charset="-120"/>
+              </a:rPr>
+              <a:t>List</a:t>
+            </a:r>
+            <a:endParaRPr lang="en-US" sz="3300" dirty="0"/>
+          </a:p>
+        </p:txBody>
+      </p:sp>
+      <p:sp>
+        <p:nvSpPr>
+          <p:cNvPr id="22" name="Text 20"/>
+          <p:cNvSpPr/>
+          <p:nvPr/>
+        </p:nvSpPr>
+        <p:spPr>
+          <a:xfrm>
+            <a:off x="12115800" y="6477000"/>
+            <a:ext cx="2286000" cy="1238250"/>
+          </a:xfrm>
+          <a:prstGeom prst="roundRect">
+            <a:avLst>
+              <a:gd name="adj" fmla="val 18462"/>
+            </a:avLst>
+          </a:prstGeom>
+          <a:solidFill>
+            <a:srgbClr val="3DD6A0"/>
+          </a:solidFill>
+          <a:ln/>
+        </p:spPr>
+        <p:txBody>
+          <a:bodyPr wrap="square" lIns="0" tIns="0" rIns="0" bIns="0" rtlCol="0" anchor="ctr"/>
+          <a:lstStyle/>
+          <a:p>
+            <a:pPr algn="ctr" indent="0" marL="0">
+              <a:buNone/>
+            </a:pPr>
+            <a:r>
+              <a:rPr lang="en-US" sz="3300" dirty="0" spc="-11" kern="0">
+                <a:solidFill>
+                  <a:srgbClr val="14161C"/>
+                </a:solidFill>
+                <a:latin typeface="Be Vietnam Pro ExtraBold" pitchFamily="34" charset="0"/>
+                <a:ea typeface="Be Vietnam Pro ExtraBold" pitchFamily="34" charset="-122"/>
+                <a:cs typeface="Be Vietnam Pro ExtraBold" pitchFamily="34" charset="-120"/>
+              </a:rPr>
+              <a:t>Set</a:t>
+            </a:r>
+            <a:endParaRPr lang="en-US" sz="3300" dirty="0"/>
+          </a:p>
+        </p:txBody>
+      </p:sp>
+      <p:sp>
+        <p:nvSpPr>
+          <p:cNvPr id="23" name="Text 21"/>
+          <p:cNvSpPr/>
+          <p:nvPr/>
+        </p:nvSpPr>
+        <p:spPr>
+          <a:xfrm>
+            <a:off x="14706600" y="6477000"/>
+            <a:ext cx="2286000" cy="1238250"/>
+          </a:xfrm>
+          <a:prstGeom prst="roundRect">
+            <a:avLst>
+              <a:gd name="adj" fmla="val 18462"/>
+            </a:avLst>
+          </a:prstGeom>
+          <a:solidFill>
+            <a:srgbClr val="FFB454"/>
+          </a:solidFill>
+          <a:ln/>
+        </p:spPr>
+        <p:txBody>
+          <a:bodyPr wrap="square" lIns="0" tIns="0" rIns="0" bIns="0" rtlCol="0" anchor="ctr"/>
+          <a:lstStyle/>
+          <a:p>
+            <a:pPr algn="ctr" indent="0" marL="0">
+              <a:buNone/>
+            </a:pPr>
+            <a:r>
+              <a:rPr lang="en-US" sz="3300" dirty="0" spc="-1" kern="0">
+                <a:solidFill>
+                  <a:srgbClr val="14161C"/>
+                </a:solidFill>
+                <a:latin typeface="Be Vietnam Pro ExtraBold" pitchFamily="34" charset="0"/>
+                <a:ea typeface="Be Vietnam Pro ExtraBold" pitchFamily="34" charset="-122"/>
+                <a:cs typeface="Be Vietnam Pro ExtraBold" pitchFamily="34" charset="-120"/>
+              </a:rPr>
+              <a:t>Queue</a:t>
+            </a:r>
+            <a:endParaRPr lang="en-US" sz="3300" dirty="0"/>
+          </a:p>
+        </p:txBody>
+      </p:sp>
+      <p:sp>
+        <p:nvSpPr>
+          <p:cNvPr id="24" name="Text 22"/>
+          <p:cNvSpPr/>
+          <p:nvPr/>
+        </p:nvSpPr>
+        <p:spPr>
+          <a:xfrm>
+            <a:off x="10096500" y="8115300"/>
+            <a:ext cx="6324600" cy="381000"/>
+          </a:xfrm>
+          <a:prstGeom prst="rect">
+            <a:avLst/>
+          </a:prstGeom>
+          <a:noFill/>
+          <a:ln/>
+        </p:spPr>
+        <p:txBody>
+          <a:bodyPr wrap="square" lIns="0" tIns="0" rIns="0" bIns="0" rtlCol="0" anchor="ctr"/>
+          <a:lstStyle/>
+          <a:p>
+            <a:pPr algn="ctr" indent="0" marL="0">
+              <a:buNone/>
+            </a:pPr>
+            <a:r>
+              <a:rPr lang="en-US" sz="1950" dirty="0" spc="-6" kern="0">
+                <a:solidFill>
+                  <a:srgbClr val="9AA0B5"/>
+                </a:solidFill>
+                <a:latin typeface="Be Vietnam Pro" pitchFamily="34" charset="0"/>
+                <a:ea typeface="Be Vietnam Pro" pitchFamily="34" charset="-122"/>
+                <a:cs typeface="Be Vietnam Pro" pitchFamily="34" charset="-120"/>
+              </a:rPr>
+              <a:t>ba</a:t>
+            </a:r>
+            <a:r>
+              <a:rPr lang="en-US" sz="1950" dirty="0" spc="-10" kern="0">
+                <a:solidFill>
+                  <a:srgbClr val="9AA0B5"/>
+                </a:solidFill>
+                <a:latin typeface="Be Vietnam Pro" pitchFamily="34" charset="0"/>
+                <a:ea typeface="Be Vietnam Pro" pitchFamily="34" charset="-122"/>
+                <a:cs typeface="Be Vietnam Pro" pitchFamily="34" charset="-120"/>
+              </a:rPr>
+              <a:t> interface</a:t>
+            </a:r>
+            <a:r>
+              <a:rPr lang="en-US" sz="1950" dirty="0" spc="0" kern="0">
+                <a:solidFill>
+                  <a:srgbClr val="9AA0B5"/>
+                </a:solidFill>
+                <a:latin typeface="Be Vietnam Pro" pitchFamily="34" charset="0"/>
+                <a:ea typeface="Be Vietnam Pro" pitchFamily="34" charset="-122"/>
+                <a:cs typeface="Be Vietnam Pro" pitchFamily="34" charset="-120"/>
+              </a:rPr>
+              <a:t> con chính</a:t>
+            </a:r>
+            <a:r>
+              <a:rPr lang="en-US" sz="1950" dirty="0" spc="-1" kern="0">
+                <a:solidFill>
+                  <a:srgbClr val="9AA0B5"/>
+                </a:solidFill>
+                <a:latin typeface="Be Vietnam Pro" pitchFamily="34" charset="0"/>
+                <a:ea typeface="Be Vietnam Pro" pitchFamily="34" charset="-122"/>
+                <a:cs typeface="Be Vietnam Pro" pitchFamily="34" charset="-120"/>
+              </a:rPr>
+              <a:t> của Collection</a:t>
+            </a:r>
+            <a:endParaRPr lang="en-US" sz="1950" dirty="0"/>
+          </a:p>
+        </p:txBody>
+      </p:sp>
+      <p:sp>
+        <p:nvSpPr>
+          <p:cNvPr id="25" name="Shape 23"/>
+          <p:cNvSpPr/>
+          <p:nvPr/>
+        </p:nvSpPr>
+        <p:spPr>
+          <a:xfrm>
+            <a:off x="981075" y="9439275"/>
+            <a:ext cx="133350" cy="133350"/>
+          </a:xfrm>
+          <a:prstGeom prst="ellipse">
+            <a:avLst/>
+          </a:prstGeom>
+          <a:solidFill>
+            <a:srgbClr val="F3EEE3"/>
+          </a:solidFill>
+          <a:ln w="19050">
+            <a:solidFill>
+              <a:srgbClr val="F3EEE3"/>
+            </a:solidFill>
+            <a:prstDash val="solid"/>
+          </a:ln>
+        </p:spPr>
+      </p:sp>
+      <p:sp>
+        <p:nvSpPr>
+          <p:cNvPr id="26" name="Shape 24"/>
+          <p:cNvSpPr/>
+          <p:nvPr/>
+        </p:nvSpPr>
+        <p:spPr>
+          <a:xfrm>
+            <a:off x="1323975" y="9439275"/>
+            <a:ext cx="133350" cy="133350"/>
+          </a:xfrm>
+          <a:prstGeom prst="ellipse">
+            <a:avLst/>
+          </a:prstGeom>
+          <a:solidFill>
+            <a:srgbClr val="F3EEE3"/>
+          </a:solidFill>
+          <a:ln w="19050">
+            <a:solidFill>
+              <a:srgbClr val="F3EEE3"/>
+            </a:solidFill>
+            <a:prstDash val="solid"/>
+          </a:ln>
+        </p:spPr>
+      </p:sp>
+      <p:sp>
+        <p:nvSpPr>
+          <p:cNvPr id="27" name="Shape 25"/>
+          <p:cNvSpPr/>
+          <p:nvPr/>
+        </p:nvSpPr>
+        <p:spPr>
+          <a:xfrm>
+            <a:off x="1666875" y="9439275"/>
+            <a:ext cx="133350" cy="133350"/>
+          </a:xfrm>
+          <a:prstGeom prst="ellipse">
+            <a:avLst/>
+          </a:prstGeom>
+          <a:solidFill>
+            <a:srgbClr val="FF6A4D"/>
+          </a:solidFill>
+          <a:ln w="19050">
+            <a:solidFill>
+              <a:srgbClr val="FF6A4D"/>
+            </a:solidFill>
+            <a:prstDash val="solid"/>
+          </a:ln>
+        </p:spPr>
+      </p:sp>
+      <p:sp>
+        <p:nvSpPr>
+          <p:cNvPr id="28" name="Shape 26"/>
+          <p:cNvSpPr/>
+          <p:nvPr/>
+        </p:nvSpPr>
+        <p:spPr>
+          <a:xfrm>
+            <a:off x="2009775" y="9439275"/>
+            <a:ext cx="133350" cy="133350"/>
+          </a:xfrm>
+          <a:prstGeom prst="ellipse">
+            <a:avLst/>
+          </a:prstGeom>
+          <a:solidFill>
+            <a:srgbClr val="14161C"/>
+          </a:solidFill>
+          <a:ln w="19050">
+            <a:solidFill>
+              <a:srgbClr val="9AA0B5"/>
+            </a:solidFill>
+            <a:prstDash val="solid"/>
+          </a:ln>
+        </p:spPr>
+      </p:sp>
+      <p:sp>
+        <p:nvSpPr>
+          <p:cNvPr id="29" name="Shape 27"/>
+          <p:cNvSpPr/>
+          <p:nvPr/>
+        </p:nvSpPr>
+        <p:spPr>
+          <a:xfrm>
+            <a:off x="2352675" y="9439275"/>
+            <a:ext cx="133350" cy="133350"/>
+          </a:xfrm>
+          <a:prstGeom prst="ellipse">
+            <a:avLst/>
+          </a:prstGeom>
+          <a:solidFill>
+            <a:srgbClr val="14161C"/>
+          </a:solidFill>
+          <a:ln w="19050">
+            <a:solidFill>
+              <a:srgbClr val="9AA0B5"/>
+            </a:solidFill>
+            <a:prstDash val="solid"/>
+          </a:ln>
+        </p:spPr>
+      </p:sp>
+      <p:sp>
+        <p:nvSpPr>
+          <p:cNvPr id="30" name="Shape 28"/>
+          <p:cNvSpPr/>
+          <p:nvPr/>
+        </p:nvSpPr>
+        <p:spPr>
+          <a:xfrm>
+            <a:off x="2695575" y="9439275"/>
+            <a:ext cx="133350" cy="133350"/>
+          </a:xfrm>
+          <a:prstGeom prst="ellipse">
+            <a:avLst/>
+          </a:prstGeom>
+          <a:solidFill>
+            <a:srgbClr val="14161C"/>
+          </a:solidFill>
+          <a:ln w="19050">
+            <a:solidFill>
+              <a:srgbClr val="9AA0B5"/>
+            </a:solidFill>
+            <a:prstDash val="solid"/>
+          </a:ln>
+        </p:spPr>
+      </p:sp>
+      <p:sp>
+        <p:nvSpPr>
+          <p:cNvPr id="31" name="Shape 29"/>
+          <p:cNvSpPr/>
+          <p:nvPr/>
+        </p:nvSpPr>
+        <p:spPr>
+          <a:xfrm>
+            <a:off x="3038475" y="9439275"/>
+            <a:ext cx="133350" cy="133350"/>
+          </a:xfrm>
+          <a:prstGeom prst="ellipse">
+            <a:avLst/>
+          </a:prstGeom>
+          <a:solidFill>
+            <a:srgbClr val="14161C"/>
+          </a:solidFill>
+          <a:ln w="19050">
+            <a:solidFill>
+              <a:srgbClr val="9AA0B5"/>
+            </a:solidFill>
+            <a:prstDash val="solid"/>
+          </a:ln>
+        </p:spPr>
+      </p:sp>
+      <p:sp>
+        <p:nvSpPr>
+          <p:cNvPr id="32" name="Shape 30"/>
+          <p:cNvSpPr/>
+          <p:nvPr/>
+        </p:nvSpPr>
+        <p:spPr>
+          <a:xfrm>
+            <a:off x="3381375" y="9439275"/>
+            <a:ext cx="133350" cy="133350"/>
+          </a:xfrm>
+          <a:prstGeom prst="ellipse">
+            <a:avLst/>
+          </a:prstGeom>
+          <a:solidFill>
+            <a:srgbClr val="14161C"/>
+          </a:solidFill>
+          <a:ln w="19050">
+            <a:solidFill>
+              <a:srgbClr val="9AA0B5"/>
+            </a:solidFill>
+            <a:prstDash val="solid"/>
+          </a:ln>
+        </p:spPr>
+      </p:sp>
+      <p:sp>
+        <p:nvSpPr>
+          <p:cNvPr id="33" name="Shape 31"/>
+          <p:cNvSpPr/>
+          <p:nvPr/>
+        </p:nvSpPr>
+        <p:spPr>
+          <a:xfrm>
+            <a:off x="3724275" y="9439275"/>
+            <a:ext cx="133350" cy="133350"/>
+          </a:xfrm>
+          <a:prstGeom prst="ellipse">
+            <a:avLst/>
+          </a:prstGeom>
+          <a:solidFill>
+            <a:srgbClr val="14161C"/>
+          </a:solidFill>
+          <a:ln w="19050">
+            <a:solidFill>
+              <a:srgbClr val="9AA0B5"/>
+            </a:solidFill>
+            <a:prstDash val="solid"/>
+          </a:ln>
+        </p:spPr>
+      </p:sp>
+      <p:sp>
+        <p:nvSpPr>
+          <p:cNvPr id="34" name="Shape 32"/>
+          <p:cNvSpPr/>
+          <p:nvPr/>
+        </p:nvSpPr>
+        <p:spPr>
+          <a:xfrm>
+            <a:off x="4067175" y="9439275"/>
+            <a:ext cx="133350" cy="133350"/>
+          </a:xfrm>
+          <a:prstGeom prst="ellipse">
+            <a:avLst/>
+          </a:prstGeom>
+          <a:solidFill>
+            <a:srgbClr val="14161C"/>
+          </a:solidFill>
+          <a:ln w="19050">
+            <a:solidFill>
+              <a:srgbClr val="9AA0B5"/>
+            </a:solidFill>
+            <a:prstDash val="solid"/>
+          </a:ln>
+        </p:spPr>
+      </p:sp>
+      <p:sp>
+        <p:nvSpPr>
+          <p:cNvPr id="35" name="Text 33"/>
+          <p:cNvSpPr/>
+          <p:nvPr/>
+        </p:nvSpPr>
+        <p:spPr>
+          <a:xfrm>
+            <a:off x="914400" y="9696450"/>
+            <a:ext cx="7620000" cy="323850"/>
+          </a:xfrm>
+          <a:prstGeom prst="rect">
+            <a:avLst/>
+          </a:prstGeom>
+          <a:noFill/>
+          <a:ln/>
+        </p:spPr>
+        <p:txBody>
+          <a:bodyPr wrap="square" lIns="0" tIns="0" rIns="0" bIns="0" rtlCol="0" anchor="t"/>
+          <a:lstStyle/>
+          <a:p>
+            <a:pPr algn="l" indent="0" marL="0">
+              <a:buNone/>
+            </a:pPr>
+            <a:r>
+              <a:rPr lang="en-US" sz="1650" dirty="0" spc="-12" kern="0">
+                <a:solidFill>
+                  <a:srgbClr val="9AA0B5"/>
+                </a:solidFill>
+                <a:latin typeface="Be Vietnam Pro" pitchFamily="34" charset="0"/>
+                <a:ea typeface="Be Vietnam Pro" pitchFamily="34" charset="-122"/>
+                <a:cs typeface="Be Vietnam Pro" pitchFamily="34" charset="-120"/>
+              </a:rPr>
+              <a:t>System</a:t>
+            </a:r>
+            <a:r>
+              <a:rPr lang="en-US" sz="1650" dirty="0" spc="0" kern="0">
+                <a:solidFill>
+                  <a:srgbClr val="9AA0B5"/>
+                </a:solidFill>
+                <a:latin typeface="Be Vietnam Pro" pitchFamily="34" charset="0"/>
+                <a:ea typeface="Be Vietnam Pro" pitchFamily="34" charset="-122"/>
+                <a:cs typeface="Be Vietnam Pro" pitchFamily="34" charset="-120"/>
+              </a:rPr>
+              <a:t> Design</a:t>
+            </a:r>
+            <a:r>
+              <a:rPr lang="en-US" sz="1650" dirty="0" spc="1" kern="0">
+                <a:solidFill>
+                  <a:srgbClr val="9AA0B5"/>
+                </a:solidFill>
+                <a:latin typeface="Be Vietnam Pro" pitchFamily="34" charset="0"/>
+                <a:ea typeface="Be Vietnam Pro" pitchFamily="34" charset="-122"/>
+                <a:cs typeface="Be Vietnam Pro" pitchFamily="34" charset="-120"/>
+              </a:rPr>
+              <a:t> 101</a:t>
+            </a:r>
+            <a:r>
+              <a:rPr lang="en-US" sz="1650" dirty="0" spc="0" kern="0">
+                <a:solidFill>
+                  <a:srgbClr val="9AA0B5"/>
+                </a:solidFill>
+                <a:latin typeface="Be Vietnam Pro" pitchFamily="34" charset="0"/>
+                <a:ea typeface="Be Vietnam Pro" pitchFamily="34" charset="-122"/>
+                <a:cs typeface="Be Vietnam Pro" pitchFamily="34" charset="-120"/>
+              </a:rPr>
+              <a:t> ·</a:t>
+            </a:r>
+            <a:r>
+              <a:rPr lang="en-US" sz="1650" dirty="0" spc="1" kern="0">
+                <a:solidFill>
+                  <a:srgbClr val="9AA0B5"/>
+                </a:solidFill>
+                <a:latin typeface="Be Vietnam Pro" pitchFamily="34" charset="0"/>
+                <a:ea typeface="Be Vietnam Pro" pitchFamily="34" charset="-122"/>
+                <a:cs typeface="Be Vietnam Pro" pitchFamily="34" charset="-120"/>
+              </a:rPr>
+              <a:t> Bài</a:t>
+            </a:r>
+            <a:r>
+              <a:rPr lang="en-US" sz="1650" dirty="0" spc="3" kern="0">
+                <a:solidFill>
+                  <a:srgbClr val="9AA0B5"/>
+                </a:solidFill>
+                <a:latin typeface="Be Vietnam Pro" pitchFamily="34" charset="0"/>
+                <a:ea typeface="Be Vietnam Pro" pitchFamily="34" charset="-122"/>
+                <a:cs typeface="Be Vietnam Pro" pitchFamily="34" charset="-120"/>
+              </a:rPr>
+              <a:t> 05</a:t>
+            </a:r>
+            <a:r>
+              <a:rPr lang="en-US" sz="1650" dirty="0" spc="0" kern="0">
+                <a:solidFill>
+                  <a:srgbClr val="9AA0B5"/>
+                </a:solidFill>
+                <a:latin typeface="Be Vietnam Pro" pitchFamily="34" charset="0"/>
+                <a:ea typeface="Be Vietnam Pro" pitchFamily="34" charset="-122"/>
+                <a:cs typeface="Be Vietnam Pro" pitchFamily="34" charset="-120"/>
+              </a:rPr>
+              <a:t> · 03/10</a:t>
+            </a:r>
+            <a:endParaRPr lang="en-US" sz="1650" dirty="0"/>
+          </a:p>
+        </p:txBody>
+      </p:sp>
+      <p:sp>
+        <p:nvSpPr>
+          <p:cNvPr id="36" name="Text 34"/>
+          <p:cNvSpPr/>
+          <p:nvPr/>
+        </p:nvSpPr>
+        <p:spPr>
+          <a:xfrm>
+            <a:off x="1333500" y="7391400"/>
+            <a:ext cx="7048500" cy="1047750"/>
+          </a:xfrm>
+          <a:prstGeom prst="rect">
+            <a:avLst/>
+          </a:prstGeom>
+          <a:noFill/>
+          <a:ln/>
+        </p:spPr>
+        <p:txBody>
+          <a:bodyPr wrap="square" lIns="0" tIns="10287" rIns="0" bIns="-10287" rtlCol="0" anchor="t"/>
+          <a:lstStyle/>
+          <a:p>
+            <a:pPr algn="l" indent="0" marL="0">
+              <a:lnSpc>
+                <a:spcPts val="3645"/>
+              </a:lnSpc>
+              <a:buNone/>
+            </a:pPr>
+            <a:r>
+              <a:rPr lang="en-US" sz="2700" dirty="0" spc="0" kern="0">
+                <a:solidFill>
+                  <a:srgbClr val="F3EEE3"/>
+                </a:solidFill>
+                <a:latin typeface="Be Vietnam Pro" pitchFamily="34" charset="0"/>
+                <a:ea typeface="Be Vietnam Pro" pitchFamily="34" charset="-122"/>
+                <a:cs typeface="Be Vietnam Pro" pitchFamily="34" charset="-120"/>
+              </a:rPr>
+              <a:t>Collection</a:t>
+            </a:r>
+            <a:r>
+              <a:rPr lang="en-US" sz="2700" dirty="0" spc="-1" kern="0">
+                <a:solidFill>
+                  <a:srgbClr val="F3EEE3"/>
+                </a:solidFill>
+                <a:latin typeface="Be Vietnam Pro" pitchFamily="34" charset="0"/>
+                <a:ea typeface="Be Vietnam Pro" pitchFamily="34" charset="-122"/>
+                <a:cs typeface="Be Vietnam Pro" pitchFamily="34" charset="-120"/>
+              </a:rPr>
+              <a:t> là</a:t>
+            </a:r>
+            <a:r>
+              <a:rPr lang="en-US" sz="2700" dirty="0" spc="-15" kern="0">
+                <a:solidFill>
+                  <a:srgbClr val="F3EEE3"/>
+                </a:solidFill>
+                <a:latin typeface="Be Vietnam Pro" pitchFamily="34" charset="0"/>
+                <a:ea typeface="Be Vietnam Pro" pitchFamily="34" charset="-122"/>
+                <a:cs typeface="Be Vietnam Pro" pitchFamily="34" charset="-120"/>
+              </a:rPr>
+              <a:t> interface</a:t>
+            </a:r>
+            <a:r>
+              <a:rPr lang="en-US" sz="2700" dirty="0" spc="-18" kern="0">
+                <a:solidFill>
+                  <a:srgbClr val="F3EEE3"/>
+                </a:solidFill>
+                <a:latin typeface="Be Vietnam Pro" pitchFamily="34" charset="0"/>
+                <a:ea typeface="Be Vietnam Pro" pitchFamily="34" charset="-122"/>
+                <a:cs typeface="Be Vietnam Pro" pitchFamily="34" charset="-120"/>
+              </a:rPr>
+              <a:t> gốc</a:t>
+            </a:r>
+            <a:endParaRPr lang="en-US" sz="2700" dirty="0"/>
+          </a:p>
+          <a:p>
+            <a:pPr algn="l" indent="0" marL="0">
+              <a:lnSpc>
+                <a:spcPts val="3645"/>
+              </a:lnSpc>
+              <a:buNone/>
+            </a:pPr>
+            <a:r>
+              <a:rPr lang="en-US" sz="2700" dirty="0" spc="-1" kern="0">
+                <a:solidFill>
+                  <a:srgbClr val="F3EEE3"/>
+                </a:solidFill>
+                <a:latin typeface="Be Vietnam Pro" pitchFamily="34" charset="0"/>
+                <a:ea typeface="Be Vietnam Pro" pitchFamily="34" charset="-122"/>
+                <a:cs typeface="Be Vietnam Pro" pitchFamily="34" charset="-120"/>
+              </a:rPr>
+              <a:t>của</a:t>
+            </a:r>
+            <a:r>
+              <a:rPr lang="en-US" sz="2700" dirty="0" spc="2" kern="0">
+                <a:solidFill>
+                  <a:srgbClr val="F3EEE3"/>
+                </a:solidFill>
+                <a:latin typeface="Be Vietnam Pro" pitchFamily="34" charset="0"/>
+                <a:ea typeface="Be Vietnam Pro" pitchFamily="34" charset="-122"/>
+                <a:cs typeface="Be Vietnam Pro" pitchFamily="34" charset="-120"/>
+              </a:rPr>
+              <a:t> các</a:t>
+            </a:r>
+            <a:r>
+              <a:rPr lang="en-US" sz="2700" dirty="0" spc="-14" kern="0">
+                <a:solidFill>
+                  <a:srgbClr val="F3EEE3"/>
+                </a:solidFill>
+                <a:latin typeface="Be Vietnam Pro" pitchFamily="34" charset="0"/>
+                <a:ea typeface="Be Vietnam Pro" pitchFamily="34" charset="-122"/>
+                <a:cs typeface="Be Vietnam Pro" pitchFamily="34" charset="-120"/>
+              </a:rPr>
+              <a:t> tập</a:t>
+            </a:r>
+            <a:r>
+              <a:rPr lang="en-US" sz="2700" dirty="0" spc="-2" kern="0">
+                <a:solidFill>
+                  <a:srgbClr val="F3EEE3"/>
+                </a:solidFill>
+                <a:latin typeface="Be Vietnam Pro" pitchFamily="34" charset="0"/>
+                <a:ea typeface="Be Vietnam Pro" pitchFamily="34" charset="-122"/>
+                <a:cs typeface="Be Vietnam Pro" pitchFamily="34" charset="-120"/>
+              </a:rPr>
+              <a:t> hợp.</a:t>
+            </a:r>
+            <a:endParaRPr lang="en-US" sz="2700" dirty="0"/>
+          </a:p>
+        </p:txBody>
+      </p:sp>
+      <p:sp>
+        <p:nvSpPr>
+          <p:cNvPr id="37" name="Text richtext-1792362711551-511048955"/>
           <p:cNvSpPr/>
           <p:nvPr/>
         </p:nvSpPr>
@@ -7261,6 +8545,28 @@
               <a:t>Collection</a:t>
             </a:r>
             <a:r>
+              <a:rPr lang="en-US" sz="2550" dirty="0" spc="0" kern="0">
+                <a:solidFill>
+                  <a:srgbClr val="C4C8D6"/>
+                </a:solidFill>
+                <a:latin typeface="Be Vietnam Pro" pitchFamily="34" charset="0"/>
+                <a:ea typeface="Be Vietnam Pro" pitchFamily="34" charset="-122"/>
+                <a:cs typeface="Be Vietnam Pro" pitchFamily="34" charset="-120"/>
+              </a:rPr>
+              <a:t> khai</a:t>
+            </a:r>
+            <a:r>
+              <a:rPr lang="en-US" sz="2550" dirty="0" spc="-3" kern="0">
+                <a:solidFill>
+                  <a:srgbClr val="C4C8D6"/>
+                </a:solidFill>
+                <a:latin typeface="Be Vietnam Pro" pitchFamily="34" charset="0"/>
+                <a:ea typeface="Be Vietnam Pro" pitchFamily="34" charset="-122"/>
+                <a:cs typeface="Be Vietnam Pro" pitchFamily="34" charset="-120"/>
+              </a:rPr>
+              <a:t> báo</a:t>
+            </a:r>
+            <a:r>
               <a:rPr lang="en-US" sz="2550" dirty="0" spc="1" kern="0">
                 <a:solidFill>
                   <a:srgbClr val="C4C8D6"/>
@@ -7283,7 +8589,7 @@
               <a:t> xóa</a:t>
             </a:r>
             <a:r>
-              <a:rPr lang="en-US" sz="2550" dirty="0" spc="-19" kern="0">
+              <a:rPr lang="en-US" sz="2550" dirty="0" spc="-2" kern="0">
                 <a:solidFill>
                   <a:srgbClr val="C4C8D6"/>
                 </a:solidFill>
@@ -7291,10 +8597,10 @@
                 <a:ea typeface="Be Vietnam Pro" pitchFamily="34" charset="-122"/>
                 <a:cs typeface="Be Vietnam Pro" pitchFamily="34" charset="-120"/>
               </a:rPr>
-              <a:t> và</a:t>
-            </a:r>
-            <a:r>
-              <a:rPr lang="en-US" sz="2550" dirty="0" spc="-1" kern="0">
+              <a:t> (tùy chọn),</a:t>
+            </a:r>
+            <a:r>
+              <a:rPr lang="en-US" sz="2550" dirty="0" spc="0" kern="0">
                 <a:solidFill>
                   <a:srgbClr val="C4C8D6"/>
                 </a:solidFill>
@@ -7304,51 +8610,25 @@
               </a:rPr>
               <a:t> hỏi</a:t>
             </a:r>
-            <a:r>
-              <a:rPr lang="en-US" sz="2550" dirty="0" spc="0" kern="0">
-                <a:solidFill>
-                  <a:srgbClr val="C4C8D6"/>
-                </a:solidFill>
-                <a:latin typeface="Be Vietnam Pro" pitchFamily="34" charset="0"/>
-                <a:ea typeface="Be Vietnam Pro" pitchFamily="34" charset="-122"/>
-                <a:cs typeface="Be Vietnam Pro" pitchFamily="34" charset="-120"/>
-              </a:rPr>
-              <a:t> phần</a:t>
-            </a:r>
-            <a:r>
-              <a:rPr lang="en-US" sz="2550" dirty="0" spc="-1" kern="0">
-                <a:solidFill>
-                  <a:srgbClr val="C4C8D6"/>
-                </a:solidFill>
-                <a:latin typeface="Be Vietnam Pro" pitchFamily="34" charset="0"/>
-                <a:ea typeface="Be Vietnam Pro" pitchFamily="34" charset="-122"/>
-                <a:cs typeface="Be Vietnam Pro" pitchFamily="34" charset="-120"/>
-              </a:rPr>
-              <a:t> tử</a:t>
-            </a:r>
             <a:endParaRPr lang="en-US" sz="2550" dirty="0"/>
           </a:p>
         </p:txBody>
       </p:sp>
       <p:sp>
         <p:nvSpPr>
-          <p:cNvPr id="6" name="Text 4"/>
-          <p:cNvSpPr/>
-          <p:nvPr/>
-        </p:nvSpPr>
-        <p:spPr>
-          <a:xfrm>
-            <a:off x="914400" y="5619750"/>
-            <a:ext cx="4191000" cy="647700"/>
-          </a:xfrm>
-          <a:prstGeom prst="roundRect">
-            <a:avLst>
-              <a:gd name="adj" fmla="val 50000"/>
-            </a:avLst>
-          </a:prstGeom>
-          <a:solidFill>
-            <a:srgbClr val="F3EEE3"/>
-          </a:solidFill>
+          <p:cNvPr id="38" name="Text 36"/>
+          <p:cNvSpPr/>
+          <p:nvPr/>
+        </p:nvSpPr>
+        <p:spPr>
+          <a:xfrm>
+            <a:off x="11353800" y="4343400"/>
+            <a:ext cx="3810000" cy="381000"/>
+          </a:xfrm>
+          <a:prstGeom prst="rect">
+            <a:avLst/>
+          </a:prstGeom>
+          <a:noFill/>
           <a:ln/>
         </p:spPr>
         <p:txBody>
@@ -7359,7 +8639,7 @@
               <a:buNone/>
             </a:pPr>
             <a:r>
-              <a:rPr lang="en-US" sz="2100" b="1" dirty="0" spc="-21" kern="0">
+              <a:rPr lang="en-US" sz="1950" dirty="0" spc="-1" kern="0">
                 <a:solidFill>
                   <a:srgbClr val="14161C"/>
                 </a:solidFill>
@@ -7367,10 +8647,10 @@
                 <a:ea typeface="Be Vietnam Pro" pitchFamily="34" charset="-122"/>
                 <a:cs typeface="Be Vietnam Pro" pitchFamily="34" charset="-120"/>
               </a:rPr>
-              <a:t>vòng</a:t>
-            </a:r>
-            <a:r>
-              <a:rPr lang="en-US" sz="2100" b="1" dirty="0" spc="0" kern="0">
+              <a:t>hỏi</a:t>
+            </a:r>
+            <a:r>
+              <a:rPr lang="en-US" sz="1950" dirty="0" spc="-2" kern="0">
                 <a:solidFill>
                   <a:srgbClr val="14161C"/>
                 </a:solidFill>
@@ -7378,10 +8658,10 @@
                 <a:ea typeface="Be Vietnam Pro" pitchFamily="34" charset="-122"/>
                 <a:cs typeface="Be Vietnam Pro" pitchFamily="34" charset="-120"/>
               </a:rPr>
-              <a:t> lặp</a:t>
-            </a:r>
-            <a:r>
-              <a:rPr lang="en-US" sz="2100" b="1" dirty="0" spc="-13" kern="0">
+              <a:t> ·</a:t>
+            </a:r>
+            <a:r>
+              <a:rPr lang="en-US" sz="1950" dirty="0" spc="0" kern="0">
                 <a:solidFill>
                   <a:srgbClr val="14161C"/>
                 </a:solidFill>
@@ -7389,10 +8669,10 @@
                 <a:ea typeface="Be Vietnam Pro" pitchFamily="34" charset="-122"/>
                 <a:cs typeface="Be Vietnam Pro" pitchFamily="34" charset="-120"/>
               </a:rPr>
-              <a:t> for</a:t>
-            </a:r>
-            <a:r>
-              <a:rPr lang="en-US" sz="2100" b="1" dirty="0" spc="-2" kern="0">
+              <a:t> thêm</a:t>
+            </a:r>
+            <a:r>
+              <a:rPr lang="en-US" sz="1950" dirty="0" spc="-15" kern="0">
                 <a:solidFill>
                   <a:srgbClr val="14161C"/>
                 </a:solidFill>
@@ -7400,10 +8680,10 @@
                 <a:ea typeface="Be Vietnam Pro" pitchFamily="34" charset="-122"/>
                 <a:cs typeface="Be Vietnam Pro" pitchFamily="34" charset="-120"/>
               </a:rPr>
-              <a:t> nâng</a:t>
-            </a:r>
-            <a:r>
-              <a:rPr lang="en-US" sz="2100" b="1" dirty="0" spc="-5" kern="0">
+              <a:t> và</a:t>
+            </a:r>
+            <a:r>
+              <a:rPr lang="en-US" sz="1950" dirty="0" spc="-17" kern="0">
                 <a:solidFill>
                   <a:srgbClr val="14161C"/>
                 </a:solidFill>
@@ -7411,42 +8691,10 @@
                 <a:ea typeface="Be Vietnam Pro" pitchFamily="34" charset="-122"/>
                 <a:cs typeface="Be Vietnam Pro" pitchFamily="34" charset="-120"/>
               </a:rPr>
-              <a:t> cao</a:t>
-            </a:r>
-            <a:endParaRPr lang="en-US" sz="2100" dirty="0"/>
-          </a:p>
-        </p:txBody>
-      </p:sp>
-      <p:sp>
-        <p:nvSpPr>
-          <p:cNvPr id="7" name="Text 5"/>
-          <p:cNvSpPr/>
-          <p:nvPr/>
-        </p:nvSpPr>
-        <p:spPr>
-          <a:xfrm>
-            <a:off x="5295900" y="5619750"/>
-            <a:ext cx="1905000" cy="647700"/>
-          </a:xfrm>
-          <a:prstGeom prst="roundRect">
-            <a:avLst>
-              <a:gd name="adj" fmla="val 50000"/>
-            </a:avLst>
-          </a:prstGeom>
-          <a:solidFill>
-            <a:srgbClr val="F3EEE3"/>
-          </a:solidFill>
-          <a:ln/>
-        </p:spPr>
-        <p:txBody>
-          <a:bodyPr wrap="square" lIns="0" tIns="0" rIns="0" bIns="0" rtlCol="0" anchor="ctr"/>
-          <a:lstStyle/>
-          <a:p>
-            <a:pPr algn="ctr" indent="0" marL="0">
-              <a:buNone/>
-            </a:pPr>
-            <a:r>
-              <a:rPr lang="en-US" sz="2100" b="1" dirty="0" spc="-15" kern="0">
+              <a:t> xóa</a:t>
+            </a:r>
+            <a:r>
+              <a:rPr lang="en-US" sz="1950" dirty="0" spc="-1" kern="0">
                 <a:solidFill>
                   <a:srgbClr val="14161C"/>
                 </a:solidFill>
@@ -7454,1268 +8702,9 @@
                 <a:ea typeface="Be Vietnam Pro" pitchFamily="34" charset="-122"/>
                 <a:cs typeface="Be Vietnam Pro" pitchFamily="34" charset="-120"/>
               </a:rPr>
-              <a:t>iterator</a:t>
-            </a:r>
-            <a:endParaRPr lang="en-US" sz="2100" dirty="0"/>
-          </a:p>
-        </p:txBody>
-      </p:sp>
-      <p:sp>
-        <p:nvSpPr>
-          <p:cNvPr id="8" name="Shape 6"/>
-          <p:cNvSpPr/>
-          <p:nvPr/>
-        </p:nvSpPr>
-        <p:spPr>
-          <a:xfrm>
-            <a:off x="914400" y="6667500"/>
-            <a:ext cx="7620000" cy="2000250"/>
-          </a:xfrm>
-          <a:prstGeom prst="roundRect">
-            <a:avLst>
-              <a:gd name="adj" fmla="val 13333"/>
-            </a:avLst>
-          </a:prstGeom>
-          <a:solidFill>
-            <a:srgbClr val="1E212B"/>
-          </a:solidFill>
-          <a:ln/>
-        </p:spPr>
-      </p:sp>
-      <p:sp>
-        <p:nvSpPr>
-          <p:cNvPr id="9" name="Shape 7"/>
-          <p:cNvSpPr/>
-          <p:nvPr/>
-        </p:nvSpPr>
-        <p:spPr>
-          <a:xfrm>
-            <a:off x="914400" y="6667500"/>
-            <a:ext cx="133350" cy="2000250"/>
-          </a:xfrm>
-          <a:prstGeom prst="roundRect">
-            <a:avLst>
-              <a:gd name="adj" fmla="val 50000"/>
-            </a:avLst>
-          </a:prstGeom>
-          <a:solidFill>
-            <a:srgbClr val="F3EEE3"/>
-          </a:solidFill>
-          <a:ln/>
-        </p:spPr>
-      </p:sp>
-      <p:sp>
-        <p:nvSpPr>
-          <p:cNvPr id="10" name="Text 8"/>
-          <p:cNvSpPr/>
-          <p:nvPr/>
-        </p:nvSpPr>
-        <p:spPr>
-          <a:xfrm>
-            <a:off x="1333500" y="6934200"/>
-            <a:ext cx="5715000" cy="323850"/>
-          </a:xfrm>
-          <a:prstGeom prst="rect">
-            <a:avLst/>
-          </a:prstGeom>
-          <a:noFill/>
-          <a:ln/>
-        </p:spPr>
-        <p:txBody>
-          <a:bodyPr wrap="square" lIns="0" tIns="0" rIns="0" bIns="0" rtlCol="0" anchor="t"/>
-          <a:lstStyle/>
-          <a:p>
-            <a:pPr algn="l" indent="0" marL="0">
-              <a:buNone/>
-            </a:pPr>
-            <a:r>
-              <a:rPr lang="en-US" sz="1800" b="1" spc="225" kern="0" dirty="0">
-                <a:solidFill>
-                  <a:srgbClr val="F3EEE3"/>
-                </a:solidFill>
-                <a:latin typeface="Be Vietnam Pro" pitchFamily="34" charset="0"/>
-                <a:ea typeface="Be Vietnam Pro" pitchFamily="34" charset="-122"/>
-                <a:cs typeface="Be Vietnam Pro" pitchFamily="34" charset="-120"/>
-              </a:rPr>
-              <a:t>GHI</a:t>
-            </a:r>
-            <a:r>
-              <a:rPr lang="en-US" sz="1800" b="1" spc="227" kern="0" dirty="0">
-                <a:solidFill>
-                  <a:srgbClr val="F3EEE3"/>
-                </a:solidFill>
-                <a:latin typeface="Be Vietnam Pro" pitchFamily="34" charset="0"/>
-                <a:ea typeface="Be Vietnam Pro" pitchFamily="34" charset="-122"/>
-                <a:cs typeface="Be Vietnam Pro" pitchFamily="34" charset="-120"/>
-              </a:rPr>
-              <a:t> NHỚ</a:t>
-            </a:r>
-            <a:endParaRPr lang="en-US" sz="1800" dirty="0"/>
-          </a:p>
-        </p:txBody>
-      </p:sp>
-      <p:sp>
-        <p:nvSpPr>
-          <p:cNvPr id="11" name="Shape 9"/>
-          <p:cNvSpPr/>
-          <p:nvPr/>
-        </p:nvSpPr>
-        <p:spPr>
-          <a:xfrm>
-            <a:off x="9144000" y="914400"/>
-            <a:ext cx="8229600" cy="7848600"/>
-          </a:xfrm>
-          <a:prstGeom prst="roundRect">
-            <a:avLst>
-              <a:gd name="adj" fmla="val 3398"/>
-            </a:avLst>
-          </a:prstGeom>
-          <a:solidFill>
-            <a:srgbClr val="1E212B"/>
-          </a:solidFill>
-          <a:ln w="19050">
-            <a:solidFill>
-              <a:srgbClr val="2C3040"/>
-            </a:solidFill>
-            <a:prstDash val="solid"/>
-          </a:ln>
-        </p:spPr>
-      </p:sp>
-      <p:sp>
-        <p:nvSpPr>
-          <p:cNvPr id="12" name="Connector line-1792335468145-224870917"/>
-          <p:cNvSpPr/>
-          <p:nvPr/>
-        </p:nvSpPr>
-        <p:spPr>
-          <a:xfrm flipV="1">
-            <a:off x="13258800" y="2895600"/>
-            <a:ext cx="0" cy="590550"/>
-          </a:xfrm>
-          <a:prstGeom prst="line">
-            <a:avLst/>
-          </a:prstGeom>
-          <a:noFill/>
-          <a:ln w="47625">
-            <a:solidFill>
-              <a:srgbClr val="F3EEE3"/>
-            </a:solidFill>
-            <a:prstDash val="solid"/>
-            <a:headEnd type="none"/>
-            <a:tailEnd type="triangle"/>
-          </a:ln>
-        </p:spPr>
-      </p:sp>
-      <p:sp>
-        <p:nvSpPr>
-          <p:cNvPr id="13" name="Text 11"/>
-          <p:cNvSpPr/>
-          <p:nvPr/>
-        </p:nvSpPr>
-        <p:spPr>
-          <a:xfrm>
-            <a:off x="13487400" y="3028950"/>
-            <a:ext cx="1905000" cy="381000"/>
-          </a:xfrm>
-          <a:prstGeom prst="rect">
-            <a:avLst/>
-          </a:prstGeom>
-          <a:noFill/>
-          <a:ln/>
-        </p:spPr>
-        <p:txBody>
-          <a:bodyPr wrap="square" lIns="0" tIns="0" rIns="0" bIns="0" rtlCol="0" anchor="t"/>
-          <a:lstStyle/>
-          <a:p>
-            <a:pPr algn="l" indent="0" marL="0">
-              <a:buNone/>
-            </a:pPr>
-            <a:r>
-              <a:rPr lang="en-US" sz="1950" dirty="0" spc="-46" kern="0">
-                <a:solidFill>
-                  <a:srgbClr val="9AA0B5"/>
-                </a:solidFill>
-                <a:latin typeface="Be Vietnam Pro" pitchFamily="34" charset="0"/>
-                <a:ea typeface="Be Vietnam Pro" pitchFamily="34" charset="-122"/>
-                <a:cs typeface="Be Vietnam Pro" pitchFamily="34" charset="-120"/>
-              </a:rPr>
-              <a:t>kế</a:t>
-            </a:r>
-            <a:r>
-              <a:rPr lang="en-US" sz="1950" dirty="0" spc="6" kern="0">
-                <a:solidFill>
-                  <a:srgbClr val="9AA0B5"/>
-                </a:solidFill>
-                <a:latin typeface="Be Vietnam Pro" pitchFamily="34" charset="0"/>
-                <a:ea typeface="Be Vietnam Pro" pitchFamily="34" charset="-122"/>
-                <a:cs typeface="Be Vietnam Pro" pitchFamily="34" charset="-120"/>
-              </a:rPr>
-              <a:t> thừa</a:t>
+              <a:t> tùy chọn</a:t>
             </a:r>
             <a:endParaRPr lang="en-US" sz="1950" dirty="0"/>
-          </a:p>
-        </p:txBody>
-      </p:sp>
-      <p:sp>
-        <p:nvSpPr>
-          <p:cNvPr id="14" name="Connector line-1792335468148-689857458"/>
-          <p:cNvSpPr/>
-          <p:nvPr/>
-        </p:nvSpPr>
-        <p:spPr>
-          <a:xfrm flipH="1">
-            <a:off x="10668000" y="4972050"/>
-            <a:ext cx="2590800" cy="1466850"/>
-          </a:xfrm>
-          <a:prstGeom prst="line">
-            <a:avLst/>
-          </a:prstGeom>
-          <a:noFill/>
-          <a:ln w="47625">
-            <a:solidFill>
-              <a:srgbClr val="7C93FF"/>
-            </a:solidFill>
-            <a:prstDash val="solid"/>
-            <a:headEnd type="none"/>
-            <a:tailEnd type="triangle"/>
-          </a:ln>
-        </p:spPr>
-      </p:sp>
-      <p:sp>
-        <p:nvSpPr>
-          <p:cNvPr id="15" name="Connector line-1792335468148-859502814"/>
-          <p:cNvSpPr/>
-          <p:nvPr/>
-        </p:nvSpPr>
-        <p:spPr>
-          <a:xfrm>
-            <a:off x="13258800" y="4972050"/>
-            <a:ext cx="0" cy="1466850"/>
-          </a:xfrm>
-          <a:prstGeom prst="line">
-            <a:avLst/>
-          </a:prstGeom>
-          <a:noFill/>
-          <a:ln w="47625">
-            <a:solidFill>
-              <a:srgbClr val="3DD6A0"/>
-            </a:solidFill>
-            <a:prstDash val="solid"/>
-            <a:headEnd type="none"/>
-            <a:tailEnd type="triangle"/>
-          </a:ln>
-        </p:spPr>
-      </p:sp>
-      <p:sp>
-        <p:nvSpPr>
-          <p:cNvPr id="16" name="Connector line-1792335468149-617779725"/>
-          <p:cNvSpPr/>
-          <p:nvPr/>
-        </p:nvSpPr>
-        <p:spPr>
-          <a:xfrm>
-            <a:off x="13258800" y="4972050"/>
-            <a:ext cx="2590800" cy="1466850"/>
-          </a:xfrm>
-          <a:prstGeom prst="line">
-            <a:avLst/>
-          </a:prstGeom>
-          <a:noFill/>
-          <a:ln w="47625">
-            <a:solidFill>
-              <a:srgbClr val="FFB454"/>
-            </a:solidFill>
-            <a:prstDash val="solid"/>
-            <a:headEnd type="none"/>
-            <a:tailEnd type="triangle"/>
-          </a:ln>
-        </p:spPr>
-      </p:sp>
-      <p:sp>
-        <p:nvSpPr>
-          <p:cNvPr id="17" name="Shape 15"/>
-          <p:cNvSpPr/>
-          <p:nvPr/>
-        </p:nvSpPr>
-        <p:spPr>
-          <a:xfrm>
-            <a:off x="11353800" y="1619250"/>
-            <a:ext cx="3810000" cy="1238250"/>
-          </a:xfrm>
-          <a:prstGeom prst="roundRect">
-            <a:avLst>
-              <a:gd name="adj" fmla="val 18462"/>
-            </a:avLst>
-          </a:prstGeom>
-          <a:solidFill>
-            <a:srgbClr val="2C3040"/>
-          </a:solidFill>
-          <a:ln w="28575">
-            <a:solidFill>
-              <a:srgbClr val="F3EEE3"/>
-            </a:solidFill>
-            <a:prstDash val="solid"/>
-          </a:ln>
-        </p:spPr>
-      </p:sp>
-      <p:sp>
-        <p:nvSpPr>
-          <p:cNvPr id="18" name="Text 16"/>
-          <p:cNvSpPr/>
-          <p:nvPr/>
-        </p:nvSpPr>
-        <p:spPr>
-          <a:xfrm>
-            <a:off x="11544300" y="1695450"/>
-            <a:ext cx="3429000" cy="666750"/>
-          </a:xfrm>
-          <a:prstGeom prst="rect">
-            <a:avLst/>
-          </a:prstGeom>
-          <a:noFill/>
-          <a:ln/>
-        </p:spPr>
-        <p:txBody>
-          <a:bodyPr wrap="square" lIns="0" tIns="0" rIns="0" bIns="0" rtlCol="0" anchor="ctr"/>
-          <a:lstStyle/>
-          <a:p>
-            <a:pPr algn="ctr" indent="0" marL="0">
-              <a:buNone/>
-            </a:pPr>
-            <a:r>
-              <a:rPr lang="en-US" sz="3600" dirty="0" spc="-14" kern="0">
-                <a:solidFill>
-                  <a:srgbClr val="F3EEE3"/>
-                </a:solidFill>
-                <a:latin typeface="Bricolage Grotesque ExtraBold" pitchFamily="34" charset="0"/>
-                <a:ea typeface="Bricolage Grotesque ExtraBold" pitchFamily="34" charset="-122"/>
-                <a:cs typeface="Bricolage Grotesque ExtraBold" pitchFamily="34" charset="-120"/>
-              </a:rPr>
-              <a:t>Iterable</a:t>
-            </a:r>
-            <a:endParaRPr lang="en-US" sz="3600" dirty="0"/>
-          </a:p>
-        </p:txBody>
-      </p:sp>
-      <p:sp>
-        <p:nvSpPr>
-          <p:cNvPr id="19" name="Text 17"/>
-          <p:cNvSpPr/>
-          <p:nvPr/>
-        </p:nvSpPr>
-        <p:spPr>
-          <a:xfrm>
-            <a:off x="11544300" y="2362200"/>
-            <a:ext cx="3429000" cy="381000"/>
-          </a:xfrm>
-          <a:prstGeom prst="rect">
-            <a:avLst/>
-          </a:prstGeom>
-          <a:noFill/>
-          <a:ln/>
-        </p:spPr>
-        <p:txBody>
-          <a:bodyPr wrap="square" lIns="0" tIns="0" rIns="0" bIns="0" rtlCol="0" anchor="ctr"/>
-          <a:lstStyle/>
-          <a:p>
-            <a:pPr algn="ctr" indent="0" marL="0">
-              <a:buNone/>
-            </a:pPr>
-            <a:r>
-              <a:rPr lang="en-US" sz="1950" dirty="0" spc="-18" kern="0">
-                <a:solidFill>
-                  <a:srgbClr val="C4C8D6"/>
-                </a:solidFill>
-                <a:latin typeface="Be Vietnam Pro" pitchFamily="34" charset="0"/>
-                <a:ea typeface="Be Vietnam Pro" pitchFamily="34" charset="-122"/>
-                <a:cs typeface="Be Vietnam Pro" pitchFamily="34" charset="-120"/>
-              </a:rPr>
-              <a:t>duyệt</a:t>
-            </a:r>
-            <a:r>
-              <a:rPr lang="en-US" sz="1950" dirty="0" spc="17" kern="0">
-                <a:solidFill>
-                  <a:srgbClr val="C4C8D6"/>
-                </a:solidFill>
-                <a:latin typeface="Be Vietnam Pro" pitchFamily="34" charset="0"/>
-                <a:ea typeface="Be Vietnam Pro" pitchFamily="34" charset="-122"/>
-                <a:cs typeface="Be Vietnam Pro" pitchFamily="34" charset="-120"/>
-              </a:rPr>
-              <a:t> từng</a:t>
-            </a:r>
-            <a:r>
-              <a:rPr lang="en-US" sz="1950" dirty="0" spc="-1" kern="0">
-                <a:solidFill>
-                  <a:srgbClr val="C4C8D6"/>
-                </a:solidFill>
-                <a:latin typeface="Be Vietnam Pro" pitchFamily="34" charset="0"/>
-                <a:ea typeface="Be Vietnam Pro" pitchFamily="34" charset="-122"/>
-                <a:cs typeface="Be Vietnam Pro" pitchFamily="34" charset="-120"/>
-              </a:rPr>
-              <a:t> phần</a:t>
-            </a:r>
-            <a:r>
-              <a:rPr lang="en-US" sz="1950" dirty="0" spc="0" kern="0">
-                <a:solidFill>
-                  <a:srgbClr val="C4C8D6"/>
-                </a:solidFill>
-                <a:latin typeface="Be Vietnam Pro" pitchFamily="34" charset="0"/>
-                <a:ea typeface="Be Vietnam Pro" pitchFamily="34" charset="-122"/>
-                <a:cs typeface="Be Vietnam Pro" pitchFamily="34" charset="-120"/>
-              </a:rPr>
-              <a:t> tử</a:t>
-            </a:r>
-            <a:endParaRPr lang="en-US" sz="1950" dirty="0"/>
-          </a:p>
-        </p:txBody>
-      </p:sp>
-      <p:sp>
-        <p:nvSpPr>
-          <p:cNvPr id="20" name="Shape 18"/>
-          <p:cNvSpPr/>
-          <p:nvPr/>
-        </p:nvSpPr>
-        <p:spPr>
-          <a:xfrm>
-            <a:off x="11163300" y="3524250"/>
-            <a:ext cx="4191000" cy="1428750"/>
-          </a:xfrm>
-          <a:prstGeom prst="roundRect">
-            <a:avLst>
-              <a:gd name="adj" fmla="val 16000"/>
-            </a:avLst>
-          </a:prstGeom>
-          <a:solidFill>
-            <a:srgbClr val="F3EEE3"/>
-          </a:solidFill>
-          <a:ln/>
-        </p:spPr>
-      </p:sp>
-      <p:sp>
-        <p:nvSpPr>
-          <p:cNvPr id="21" name="Text 19"/>
-          <p:cNvSpPr/>
-          <p:nvPr/>
-        </p:nvSpPr>
-        <p:spPr>
-          <a:xfrm>
-            <a:off x="11353800" y="3638550"/>
-            <a:ext cx="3810000" cy="666750"/>
-          </a:xfrm>
-          <a:prstGeom prst="rect">
-            <a:avLst/>
-          </a:prstGeom>
-          <a:noFill/>
-          <a:ln/>
-        </p:spPr>
-        <p:txBody>
-          <a:bodyPr wrap="square" lIns="0" tIns="0" rIns="0" bIns="0" rtlCol="0" anchor="ctr"/>
-          <a:lstStyle/>
-          <a:p>
-            <a:pPr algn="ctr" indent="0" marL="0">
-              <a:buNone/>
-            </a:pPr>
-            <a:r>
-              <a:rPr lang="en-US" sz="3600" dirty="0" spc="2" kern="0">
-                <a:solidFill>
-                  <a:srgbClr val="14161C"/>
-                </a:solidFill>
-                <a:latin typeface="Bricolage Grotesque ExtraBold" pitchFamily="34" charset="0"/>
-                <a:ea typeface="Bricolage Grotesque ExtraBold" pitchFamily="34" charset="-122"/>
-                <a:cs typeface="Bricolage Grotesque ExtraBold" pitchFamily="34" charset="-120"/>
-              </a:rPr>
-              <a:t>Collection</a:t>
-            </a:r>
-            <a:endParaRPr lang="en-US" sz="3600" dirty="0"/>
-          </a:p>
-        </p:txBody>
-      </p:sp>
-      <p:sp>
-        <p:nvSpPr>
-          <p:cNvPr id="22" name="Text 20"/>
-          <p:cNvSpPr/>
-          <p:nvPr/>
-        </p:nvSpPr>
-        <p:spPr>
-          <a:xfrm>
-            <a:off x="11353800" y="4343400"/>
-            <a:ext cx="3810000" cy="381000"/>
-          </a:xfrm>
-          <a:prstGeom prst="rect">
-            <a:avLst/>
-          </a:prstGeom>
-          <a:noFill/>
-          <a:ln/>
-        </p:spPr>
-        <p:txBody>
-          <a:bodyPr wrap="square" lIns="0" tIns="0" rIns="0" bIns="0" rtlCol="0" anchor="ctr"/>
-          <a:lstStyle/>
-          <a:p>
-            <a:pPr algn="ctr" indent="0" marL="0">
-              <a:buNone/>
-            </a:pPr>
-            <a:r>
-              <a:rPr lang="en-US" sz="1950" dirty="0" spc="0" kern="0">
-                <a:solidFill>
-                  <a:srgbClr val="14161C"/>
-                </a:solidFill>
-                <a:latin typeface="Be Vietnam Pro" pitchFamily="34" charset="0"/>
-                <a:ea typeface="Be Vietnam Pro" pitchFamily="34" charset="-122"/>
-                <a:cs typeface="Be Vietnam Pro" pitchFamily="34" charset="-120"/>
-              </a:rPr>
-              <a:t>thêm</a:t>
-            </a:r>
-            <a:r>
-              <a:rPr lang="en-US" sz="1950" dirty="0" spc="-2" kern="0">
-                <a:solidFill>
-                  <a:srgbClr val="14161C"/>
-                </a:solidFill>
-                <a:latin typeface="Be Vietnam Pro" pitchFamily="34" charset="0"/>
-                <a:ea typeface="Be Vietnam Pro" pitchFamily="34" charset="-122"/>
-                <a:cs typeface="Be Vietnam Pro" pitchFamily="34" charset="-120"/>
-              </a:rPr>
-              <a:t> ·</a:t>
-            </a:r>
-            <a:r>
-              <a:rPr lang="en-US" sz="1950" dirty="0" spc="-17" kern="0">
-                <a:solidFill>
-                  <a:srgbClr val="14161C"/>
-                </a:solidFill>
-                <a:latin typeface="Be Vietnam Pro" pitchFamily="34" charset="0"/>
-                <a:ea typeface="Be Vietnam Pro" pitchFamily="34" charset="-122"/>
-                <a:cs typeface="Be Vietnam Pro" pitchFamily="34" charset="-120"/>
-              </a:rPr>
-              <a:t> xóa</a:t>
-            </a:r>
-            <a:r>
-              <a:rPr lang="en-US" sz="1950" dirty="0" spc="-3" kern="0">
-                <a:solidFill>
-                  <a:srgbClr val="14161C"/>
-                </a:solidFill>
-                <a:latin typeface="Be Vietnam Pro" pitchFamily="34" charset="0"/>
-                <a:ea typeface="Be Vietnam Pro" pitchFamily="34" charset="-122"/>
-                <a:cs typeface="Be Vietnam Pro" pitchFamily="34" charset="-120"/>
-              </a:rPr>
-              <a:t> ·</a:t>
-            </a:r>
-            <a:r>
-              <a:rPr lang="en-US" sz="1950" dirty="0" spc="-1" kern="0">
-                <a:solidFill>
-                  <a:srgbClr val="14161C"/>
-                </a:solidFill>
-                <a:latin typeface="Be Vietnam Pro" pitchFamily="34" charset="0"/>
-                <a:ea typeface="Be Vietnam Pro" pitchFamily="34" charset="-122"/>
-                <a:cs typeface="Be Vietnam Pro" pitchFamily="34" charset="-120"/>
-              </a:rPr>
-              <a:t> hỏi</a:t>
-            </a:r>
-            <a:r>
-              <a:rPr lang="en-US" sz="1950" dirty="0" spc="0" kern="0">
-                <a:solidFill>
-                  <a:srgbClr val="14161C"/>
-                </a:solidFill>
-                <a:latin typeface="Be Vietnam Pro" pitchFamily="34" charset="0"/>
-                <a:ea typeface="Be Vietnam Pro" pitchFamily="34" charset="-122"/>
-                <a:cs typeface="Be Vietnam Pro" pitchFamily="34" charset="-120"/>
-              </a:rPr>
-              <a:t> phần</a:t>
-            </a:r>
-            <a:r>
-              <a:rPr lang="en-US" sz="1950" dirty="0" spc="-1" kern="0">
-                <a:solidFill>
-                  <a:srgbClr val="14161C"/>
-                </a:solidFill>
-                <a:latin typeface="Be Vietnam Pro" pitchFamily="34" charset="0"/>
-                <a:ea typeface="Be Vietnam Pro" pitchFamily="34" charset="-122"/>
-                <a:cs typeface="Be Vietnam Pro" pitchFamily="34" charset="-120"/>
-              </a:rPr>
-              <a:t> tử</a:t>
-            </a:r>
-            <a:endParaRPr lang="en-US" sz="1950" dirty="0"/>
-          </a:p>
-        </p:txBody>
-      </p:sp>
-      <p:sp>
-        <p:nvSpPr>
-          <p:cNvPr id="23" name="Text 21"/>
-          <p:cNvSpPr/>
-          <p:nvPr/>
-        </p:nvSpPr>
-        <p:spPr>
-          <a:xfrm>
-            <a:off x="9525000" y="6477000"/>
-            <a:ext cx="2286000" cy="1238250"/>
-          </a:xfrm>
-          <a:prstGeom prst="roundRect">
-            <a:avLst>
-              <a:gd name="adj" fmla="val 18462"/>
-            </a:avLst>
-          </a:prstGeom>
-          <a:solidFill>
-            <a:srgbClr val="7C93FF"/>
-          </a:solidFill>
-          <a:ln/>
-        </p:spPr>
-        <p:txBody>
-          <a:bodyPr wrap="square" lIns="0" tIns="0" rIns="0" bIns="0" rtlCol="0" anchor="ctr"/>
-          <a:lstStyle/>
-          <a:p>
-            <a:pPr algn="ctr" indent="0" marL="0">
-              <a:buNone/>
-            </a:pPr>
-            <a:r>
-              <a:rPr lang="en-US" sz="3300" dirty="0" spc="-8" kern="0">
-                <a:solidFill>
-                  <a:srgbClr val="14161C"/>
-                </a:solidFill>
-                <a:latin typeface="Be Vietnam Pro ExtraBold" pitchFamily="34" charset="0"/>
-                <a:ea typeface="Be Vietnam Pro ExtraBold" pitchFamily="34" charset="-122"/>
-                <a:cs typeface="Be Vietnam Pro ExtraBold" pitchFamily="34" charset="-120"/>
-              </a:rPr>
-              <a:t>List</a:t>
-            </a:r>
-            <a:endParaRPr lang="en-US" sz="3300" dirty="0"/>
-          </a:p>
-        </p:txBody>
-      </p:sp>
-      <p:sp>
-        <p:nvSpPr>
-          <p:cNvPr id="24" name="Text 22"/>
-          <p:cNvSpPr/>
-          <p:nvPr/>
-        </p:nvSpPr>
-        <p:spPr>
-          <a:xfrm>
-            <a:off x="12115800" y="6477000"/>
-            <a:ext cx="2286000" cy="1238250"/>
-          </a:xfrm>
-          <a:prstGeom prst="roundRect">
-            <a:avLst>
-              <a:gd name="adj" fmla="val 18462"/>
-            </a:avLst>
-          </a:prstGeom>
-          <a:solidFill>
-            <a:srgbClr val="3DD6A0"/>
-          </a:solidFill>
-          <a:ln/>
-        </p:spPr>
-        <p:txBody>
-          <a:bodyPr wrap="square" lIns="0" tIns="0" rIns="0" bIns="0" rtlCol="0" anchor="ctr"/>
-          <a:lstStyle/>
-          <a:p>
-            <a:pPr algn="ctr" indent="0" marL="0">
-              <a:buNone/>
-            </a:pPr>
-            <a:r>
-              <a:rPr lang="en-US" sz="3300" dirty="0" spc="-11" kern="0">
-                <a:solidFill>
-                  <a:srgbClr val="14161C"/>
-                </a:solidFill>
-                <a:latin typeface="Be Vietnam Pro ExtraBold" pitchFamily="34" charset="0"/>
-                <a:ea typeface="Be Vietnam Pro ExtraBold" pitchFamily="34" charset="-122"/>
-                <a:cs typeface="Be Vietnam Pro ExtraBold" pitchFamily="34" charset="-120"/>
-              </a:rPr>
-              <a:t>Set</a:t>
-            </a:r>
-            <a:endParaRPr lang="en-US" sz="3300" dirty="0"/>
-          </a:p>
-        </p:txBody>
-      </p:sp>
-      <p:sp>
-        <p:nvSpPr>
-          <p:cNvPr id="25" name="Text 23"/>
-          <p:cNvSpPr/>
-          <p:nvPr/>
-        </p:nvSpPr>
-        <p:spPr>
-          <a:xfrm>
-            <a:off x="14706600" y="6477000"/>
-            <a:ext cx="2286000" cy="1238250"/>
-          </a:xfrm>
-          <a:prstGeom prst="roundRect">
-            <a:avLst>
-              <a:gd name="adj" fmla="val 18462"/>
-            </a:avLst>
-          </a:prstGeom>
-          <a:solidFill>
-            <a:srgbClr val="FFB454"/>
-          </a:solidFill>
-          <a:ln/>
-        </p:spPr>
-        <p:txBody>
-          <a:bodyPr wrap="square" lIns="0" tIns="0" rIns="0" bIns="0" rtlCol="0" anchor="ctr"/>
-          <a:lstStyle/>
-          <a:p>
-            <a:pPr algn="ctr" indent="0" marL="0">
-              <a:buNone/>
-            </a:pPr>
-            <a:r>
-              <a:rPr lang="en-US" sz="3300" dirty="0" spc="-1" kern="0">
-                <a:solidFill>
-                  <a:srgbClr val="14161C"/>
-                </a:solidFill>
-                <a:latin typeface="Be Vietnam Pro ExtraBold" pitchFamily="34" charset="0"/>
-                <a:ea typeface="Be Vietnam Pro ExtraBold" pitchFamily="34" charset="-122"/>
-                <a:cs typeface="Be Vietnam Pro ExtraBold" pitchFamily="34" charset="-120"/>
-              </a:rPr>
-              <a:t>Queue</a:t>
-            </a:r>
-            <a:endParaRPr lang="en-US" sz="3300" dirty="0"/>
-          </a:p>
-        </p:txBody>
-      </p:sp>
-      <p:sp>
-        <p:nvSpPr>
-          <p:cNvPr id="26" name="Text 24"/>
-          <p:cNvSpPr/>
-          <p:nvPr/>
-        </p:nvSpPr>
-        <p:spPr>
-          <a:xfrm>
-            <a:off x="10096500" y="8115300"/>
-            <a:ext cx="6324600" cy="381000"/>
-          </a:xfrm>
-          <a:prstGeom prst="rect">
-            <a:avLst/>
-          </a:prstGeom>
-          <a:noFill/>
-          <a:ln/>
-        </p:spPr>
-        <p:txBody>
-          <a:bodyPr wrap="square" lIns="0" tIns="0" rIns="0" bIns="0" rtlCol="0" anchor="ctr"/>
-          <a:lstStyle/>
-          <a:p>
-            <a:pPr algn="ctr" indent="0" marL="0">
-              <a:buNone/>
-            </a:pPr>
-            <a:r>
-              <a:rPr lang="en-US" sz="1950" dirty="0" spc="-6" kern="0">
-                <a:solidFill>
-                  <a:srgbClr val="9AA0B5"/>
-                </a:solidFill>
-                <a:latin typeface="Be Vietnam Pro" pitchFamily="34" charset="0"/>
-                <a:ea typeface="Be Vietnam Pro" pitchFamily="34" charset="-122"/>
-                <a:cs typeface="Be Vietnam Pro" pitchFamily="34" charset="-120"/>
-              </a:rPr>
-              <a:t>ba</a:t>
-            </a:r>
-            <a:r>
-              <a:rPr lang="en-US" sz="1950" dirty="0" spc="-10" kern="0">
-                <a:solidFill>
-                  <a:srgbClr val="9AA0B5"/>
-                </a:solidFill>
-                <a:latin typeface="Be Vietnam Pro" pitchFamily="34" charset="0"/>
-                <a:ea typeface="Be Vietnam Pro" pitchFamily="34" charset="-122"/>
-                <a:cs typeface="Be Vietnam Pro" pitchFamily="34" charset="-120"/>
-              </a:rPr>
-              <a:t> interface</a:t>
-            </a:r>
-            <a:r>
-              <a:rPr lang="en-US" sz="1950" dirty="0" spc="0" kern="0">
-                <a:solidFill>
-                  <a:srgbClr val="9AA0B5"/>
-                </a:solidFill>
-                <a:latin typeface="Be Vietnam Pro" pitchFamily="34" charset="0"/>
-                <a:ea typeface="Be Vietnam Pro" pitchFamily="34" charset="-122"/>
-                <a:cs typeface="Be Vietnam Pro" pitchFamily="34" charset="-120"/>
-              </a:rPr>
-              <a:t> con chính</a:t>
-            </a:r>
-            <a:r>
-              <a:rPr lang="en-US" sz="1950" dirty="0" spc="-1" kern="0">
-                <a:solidFill>
-                  <a:srgbClr val="9AA0B5"/>
-                </a:solidFill>
-                <a:latin typeface="Be Vietnam Pro" pitchFamily="34" charset="0"/>
-                <a:ea typeface="Be Vietnam Pro" pitchFamily="34" charset="-122"/>
-                <a:cs typeface="Be Vietnam Pro" pitchFamily="34" charset="-120"/>
-              </a:rPr>
-              <a:t> của Collection</a:t>
-            </a:r>
-            <a:endParaRPr lang="en-US" sz="1950" dirty="0"/>
-          </a:p>
-        </p:txBody>
-      </p:sp>
-      <p:sp>
-        <p:nvSpPr>
-          <p:cNvPr id="27" name="Shape 25"/>
-          <p:cNvSpPr/>
-          <p:nvPr/>
-        </p:nvSpPr>
-        <p:spPr>
-          <a:xfrm>
-            <a:off x="981075" y="9439275"/>
-            <a:ext cx="133350" cy="133350"/>
-          </a:xfrm>
-          <a:prstGeom prst="ellipse">
-            <a:avLst/>
-          </a:prstGeom>
-          <a:solidFill>
-            <a:srgbClr val="F3EEE3"/>
-          </a:solidFill>
-          <a:ln w="19050">
-            <a:solidFill>
-              <a:srgbClr val="F3EEE3"/>
-            </a:solidFill>
-            <a:prstDash val="solid"/>
-          </a:ln>
-        </p:spPr>
-      </p:sp>
-      <p:sp>
-        <p:nvSpPr>
-          <p:cNvPr id="28" name="Shape 26"/>
-          <p:cNvSpPr/>
-          <p:nvPr/>
-        </p:nvSpPr>
-        <p:spPr>
-          <a:xfrm>
-            <a:off x="1323975" y="9439275"/>
-            <a:ext cx="133350" cy="133350"/>
-          </a:xfrm>
-          <a:prstGeom prst="ellipse">
-            <a:avLst/>
-          </a:prstGeom>
-          <a:solidFill>
-            <a:srgbClr val="F3EEE3"/>
-          </a:solidFill>
-          <a:ln w="19050">
-            <a:solidFill>
-              <a:srgbClr val="F3EEE3"/>
-            </a:solidFill>
-            <a:prstDash val="solid"/>
-          </a:ln>
-        </p:spPr>
-      </p:sp>
-      <p:sp>
-        <p:nvSpPr>
-          <p:cNvPr id="29" name="Shape 27"/>
-          <p:cNvSpPr/>
-          <p:nvPr/>
-        </p:nvSpPr>
-        <p:spPr>
-          <a:xfrm>
-            <a:off x="1666875" y="9439275"/>
-            <a:ext cx="133350" cy="133350"/>
-          </a:xfrm>
-          <a:prstGeom prst="ellipse">
-            <a:avLst/>
-          </a:prstGeom>
-          <a:solidFill>
-            <a:srgbClr val="FF6A4D"/>
-          </a:solidFill>
-          <a:ln w="19050">
-            <a:solidFill>
-              <a:srgbClr val="FF6A4D"/>
-            </a:solidFill>
-            <a:prstDash val="solid"/>
-          </a:ln>
-        </p:spPr>
-      </p:sp>
-      <p:sp>
-        <p:nvSpPr>
-          <p:cNvPr id="30" name="Shape 28"/>
-          <p:cNvSpPr/>
-          <p:nvPr/>
-        </p:nvSpPr>
-        <p:spPr>
-          <a:xfrm>
-            <a:off x="2009775" y="9439275"/>
-            <a:ext cx="133350" cy="133350"/>
-          </a:xfrm>
-          <a:prstGeom prst="ellipse">
-            <a:avLst/>
-          </a:prstGeom>
-          <a:solidFill>
-            <a:srgbClr val="14161C"/>
-          </a:solidFill>
-          <a:ln w="19050">
-            <a:solidFill>
-              <a:srgbClr val="9AA0B5"/>
-            </a:solidFill>
-            <a:prstDash val="solid"/>
-          </a:ln>
-        </p:spPr>
-      </p:sp>
-      <p:sp>
-        <p:nvSpPr>
-          <p:cNvPr id="31" name="Shape 29"/>
-          <p:cNvSpPr/>
-          <p:nvPr/>
-        </p:nvSpPr>
-        <p:spPr>
-          <a:xfrm>
-            <a:off x="2352675" y="9439275"/>
-            <a:ext cx="133350" cy="133350"/>
-          </a:xfrm>
-          <a:prstGeom prst="ellipse">
-            <a:avLst/>
-          </a:prstGeom>
-          <a:solidFill>
-            <a:srgbClr val="14161C"/>
-          </a:solidFill>
-          <a:ln w="19050">
-            <a:solidFill>
-              <a:srgbClr val="9AA0B5"/>
-            </a:solidFill>
-            <a:prstDash val="solid"/>
-          </a:ln>
-        </p:spPr>
-      </p:sp>
-      <p:sp>
-        <p:nvSpPr>
-          <p:cNvPr id="32" name="Shape 30"/>
-          <p:cNvSpPr/>
-          <p:nvPr/>
-        </p:nvSpPr>
-        <p:spPr>
-          <a:xfrm>
-            <a:off x="2695575" y="9439275"/>
-            <a:ext cx="133350" cy="133350"/>
-          </a:xfrm>
-          <a:prstGeom prst="ellipse">
-            <a:avLst/>
-          </a:prstGeom>
-          <a:solidFill>
-            <a:srgbClr val="14161C"/>
-          </a:solidFill>
-          <a:ln w="19050">
-            <a:solidFill>
-              <a:srgbClr val="9AA0B5"/>
-            </a:solidFill>
-            <a:prstDash val="solid"/>
-          </a:ln>
-        </p:spPr>
-      </p:sp>
-      <p:sp>
-        <p:nvSpPr>
-          <p:cNvPr id="33" name="Shape 31"/>
-          <p:cNvSpPr/>
-          <p:nvPr/>
-        </p:nvSpPr>
-        <p:spPr>
-          <a:xfrm>
-            <a:off x="3038475" y="9439275"/>
-            <a:ext cx="133350" cy="133350"/>
-          </a:xfrm>
-          <a:prstGeom prst="ellipse">
-            <a:avLst/>
-          </a:prstGeom>
-          <a:solidFill>
-            <a:srgbClr val="14161C"/>
-          </a:solidFill>
-          <a:ln w="19050">
-            <a:solidFill>
-              <a:srgbClr val="9AA0B5"/>
-            </a:solidFill>
-            <a:prstDash val="solid"/>
-          </a:ln>
-        </p:spPr>
-      </p:sp>
-      <p:sp>
-        <p:nvSpPr>
-          <p:cNvPr id="34" name="Shape 32"/>
-          <p:cNvSpPr/>
-          <p:nvPr/>
-        </p:nvSpPr>
-        <p:spPr>
-          <a:xfrm>
-            <a:off x="3381375" y="9439275"/>
-            <a:ext cx="133350" cy="133350"/>
-          </a:xfrm>
-          <a:prstGeom prst="ellipse">
-            <a:avLst/>
-          </a:prstGeom>
-          <a:solidFill>
-            <a:srgbClr val="14161C"/>
-          </a:solidFill>
-          <a:ln w="19050">
-            <a:solidFill>
-              <a:srgbClr val="9AA0B5"/>
-            </a:solidFill>
-            <a:prstDash val="solid"/>
-          </a:ln>
-        </p:spPr>
-      </p:sp>
-      <p:sp>
-        <p:nvSpPr>
-          <p:cNvPr id="35" name="Shape 33"/>
-          <p:cNvSpPr/>
-          <p:nvPr/>
-        </p:nvSpPr>
-        <p:spPr>
-          <a:xfrm>
-            <a:off x="3724275" y="9439275"/>
-            <a:ext cx="133350" cy="133350"/>
-          </a:xfrm>
-          <a:prstGeom prst="ellipse">
-            <a:avLst/>
-          </a:prstGeom>
-          <a:solidFill>
-            <a:srgbClr val="14161C"/>
-          </a:solidFill>
-          <a:ln w="19050">
-            <a:solidFill>
-              <a:srgbClr val="9AA0B5"/>
-            </a:solidFill>
-            <a:prstDash val="solid"/>
-          </a:ln>
-        </p:spPr>
-      </p:sp>
-      <p:sp>
-        <p:nvSpPr>
-          <p:cNvPr id="36" name="Shape 34"/>
-          <p:cNvSpPr/>
-          <p:nvPr/>
-        </p:nvSpPr>
-        <p:spPr>
-          <a:xfrm>
-            <a:off x="4067175" y="9439275"/>
-            <a:ext cx="133350" cy="133350"/>
-          </a:xfrm>
-          <a:prstGeom prst="ellipse">
-            <a:avLst/>
-          </a:prstGeom>
-          <a:solidFill>
-            <a:srgbClr val="14161C"/>
-          </a:solidFill>
-          <a:ln w="19050">
-            <a:solidFill>
-              <a:srgbClr val="9AA0B5"/>
-            </a:solidFill>
-            <a:prstDash val="solid"/>
-          </a:ln>
-        </p:spPr>
-      </p:sp>
-      <p:sp>
-        <p:nvSpPr>
-          <p:cNvPr id="37" name="Text 35"/>
-          <p:cNvSpPr/>
-          <p:nvPr/>
-        </p:nvSpPr>
-        <p:spPr>
-          <a:xfrm>
-            <a:off x="914400" y="9696450"/>
-            <a:ext cx="7620000" cy="323850"/>
-          </a:xfrm>
-          <a:prstGeom prst="rect">
-            <a:avLst/>
-          </a:prstGeom>
-          <a:noFill/>
-          <a:ln/>
-        </p:spPr>
-        <p:txBody>
-          <a:bodyPr wrap="square" lIns="0" tIns="0" rIns="0" bIns="0" rtlCol="0" anchor="t"/>
-          <a:lstStyle/>
-          <a:p>
-            <a:pPr algn="l" indent="0" marL="0">
-              <a:buNone/>
-            </a:pPr>
-            <a:r>
-              <a:rPr lang="en-US" sz="1650" dirty="0" spc="-12" kern="0">
-                <a:solidFill>
-                  <a:srgbClr val="9AA0B5"/>
-                </a:solidFill>
-                <a:latin typeface="Be Vietnam Pro" pitchFamily="34" charset="0"/>
-                <a:ea typeface="Be Vietnam Pro" pitchFamily="34" charset="-122"/>
-                <a:cs typeface="Be Vietnam Pro" pitchFamily="34" charset="-120"/>
-              </a:rPr>
-              <a:t>System</a:t>
-            </a:r>
-            <a:r>
-              <a:rPr lang="en-US" sz="1650" dirty="0" spc="0" kern="0">
-                <a:solidFill>
-                  <a:srgbClr val="9AA0B5"/>
-                </a:solidFill>
-                <a:latin typeface="Be Vietnam Pro" pitchFamily="34" charset="0"/>
-                <a:ea typeface="Be Vietnam Pro" pitchFamily="34" charset="-122"/>
-                <a:cs typeface="Be Vietnam Pro" pitchFamily="34" charset="-120"/>
-              </a:rPr>
-              <a:t> Design</a:t>
-            </a:r>
-            <a:r>
-              <a:rPr lang="en-US" sz="1650" dirty="0" spc="1" kern="0">
-                <a:solidFill>
-                  <a:srgbClr val="9AA0B5"/>
-                </a:solidFill>
-                <a:latin typeface="Be Vietnam Pro" pitchFamily="34" charset="0"/>
-                <a:ea typeface="Be Vietnam Pro" pitchFamily="34" charset="-122"/>
-                <a:cs typeface="Be Vietnam Pro" pitchFamily="34" charset="-120"/>
-              </a:rPr>
-              <a:t> 101</a:t>
-            </a:r>
-            <a:r>
-              <a:rPr lang="en-US" sz="1650" dirty="0" spc="0" kern="0">
-                <a:solidFill>
-                  <a:srgbClr val="9AA0B5"/>
-                </a:solidFill>
-                <a:latin typeface="Be Vietnam Pro" pitchFamily="34" charset="0"/>
-                <a:ea typeface="Be Vietnam Pro" pitchFamily="34" charset="-122"/>
-                <a:cs typeface="Be Vietnam Pro" pitchFamily="34" charset="-120"/>
-              </a:rPr>
-              <a:t> ·</a:t>
-            </a:r>
-            <a:r>
-              <a:rPr lang="en-US" sz="1650" dirty="0" spc="1" kern="0">
-                <a:solidFill>
-                  <a:srgbClr val="9AA0B5"/>
-                </a:solidFill>
-                <a:latin typeface="Be Vietnam Pro" pitchFamily="34" charset="0"/>
-                <a:ea typeface="Be Vietnam Pro" pitchFamily="34" charset="-122"/>
-                <a:cs typeface="Be Vietnam Pro" pitchFamily="34" charset="-120"/>
-              </a:rPr>
-              <a:t> Bài</a:t>
-            </a:r>
-            <a:r>
-              <a:rPr lang="en-US" sz="1650" dirty="0" spc="3" kern="0">
-                <a:solidFill>
-                  <a:srgbClr val="9AA0B5"/>
-                </a:solidFill>
-                <a:latin typeface="Be Vietnam Pro" pitchFamily="34" charset="0"/>
-                <a:ea typeface="Be Vietnam Pro" pitchFamily="34" charset="-122"/>
-                <a:cs typeface="Be Vietnam Pro" pitchFamily="34" charset="-120"/>
-              </a:rPr>
-              <a:t> 05</a:t>
-            </a:r>
-            <a:r>
-              <a:rPr lang="en-US" sz="1650" dirty="0" spc="0" kern="0">
-                <a:solidFill>
-                  <a:srgbClr val="9AA0B5"/>
-                </a:solidFill>
-                <a:latin typeface="Be Vietnam Pro" pitchFamily="34" charset="0"/>
-                <a:ea typeface="Be Vietnam Pro" pitchFamily="34" charset="-122"/>
-                <a:cs typeface="Be Vietnam Pro" pitchFamily="34" charset="-120"/>
-              </a:rPr>
-              <a:t> · 03/10</a:t>
-            </a:r>
-            <a:endParaRPr lang="en-US" sz="1650" dirty="0"/>
-          </a:p>
-        </p:txBody>
-      </p:sp>
-      <p:sp>
-        <p:nvSpPr>
-          <p:cNvPr id="38" name="Text 36"/>
-          <p:cNvSpPr/>
-          <p:nvPr/>
-        </p:nvSpPr>
-        <p:spPr>
-          <a:xfrm>
-            <a:off x="1333500" y="7391400"/>
-            <a:ext cx="7048500" cy="1047750"/>
-          </a:xfrm>
-          <a:prstGeom prst="rect">
-            <a:avLst/>
-          </a:prstGeom>
-          <a:noFill/>
-          <a:ln/>
-        </p:spPr>
-        <p:txBody>
-          <a:bodyPr wrap="square" lIns="0" tIns="10287" rIns="0" bIns="-10287" rtlCol="0" anchor="t"/>
-          <a:lstStyle/>
-          <a:p>
-            <a:pPr algn="l" indent="0" marL="0">
-              <a:lnSpc>
-                <a:spcPts val="3645"/>
-              </a:lnSpc>
-              <a:buNone/>
-            </a:pPr>
-            <a:r>
-              <a:rPr lang="en-US" sz="2700" dirty="0" spc="0" kern="0">
-                <a:solidFill>
-                  <a:srgbClr val="F3EEE3"/>
-                </a:solidFill>
-                <a:latin typeface="Be Vietnam Pro" pitchFamily="34" charset="0"/>
-                <a:ea typeface="Be Vietnam Pro" pitchFamily="34" charset="-122"/>
-                <a:cs typeface="Be Vietnam Pro" pitchFamily="34" charset="-120"/>
-              </a:rPr>
-              <a:t>Collection</a:t>
-            </a:r>
-            <a:r>
-              <a:rPr lang="en-US" sz="2700" dirty="0" spc="-1" kern="0">
-                <a:solidFill>
-                  <a:srgbClr val="F3EEE3"/>
-                </a:solidFill>
-                <a:latin typeface="Be Vietnam Pro" pitchFamily="34" charset="0"/>
-                <a:ea typeface="Be Vietnam Pro" pitchFamily="34" charset="-122"/>
-                <a:cs typeface="Be Vietnam Pro" pitchFamily="34" charset="-120"/>
-              </a:rPr>
-              <a:t> là</a:t>
-            </a:r>
-            <a:r>
-              <a:rPr lang="en-US" sz="2700" dirty="0" spc="-15" kern="0">
-                <a:solidFill>
-                  <a:srgbClr val="F3EEE3"/>
-                </a:solidFill>
-                <a:latin typeface="Be Vietnam Pro" pitchFamily="34" charset="0"/>
-                <a:ea typeface="Be Vietnam Pro" pitchFamily="34" charset="-122"/>
-                <a:cs typeface="Be Vietnam Pro" pitchFamily="34" charset="-120"/>
-              </a:rPr>
-              <a:t> interface</a:t>
-            </a:r>
-            <a:r>
-              <a:rPr lang="en-US" sz="2700" dirty="0" spc="-18" kern="0">
-                <a:solidFill>
-                  <a:srgbClr val="F3EEE3"/>
-                </a:solidFill>
-                <a:latin typeface="Be Vietnam Pro" pitchFamily="34" charset="0"/>
-                <a:ea typeface="Be Vietnam Pro" pitchFamily="34" charset="-122"/>
-                <a:cs typeface="Be Vietnam Pro" pitchFamily="34" charset="-120"/>
-              </a:rPr>
-              <a:t> gốc</a:t>
-            </a:r>
-            <a:endParaRPr lang="en-US" sz="2700" dirty="0"/>
-          </a:p>
-          <a:p>
-            <a:pPr algn="l" indent="0" marL="0">
-              <a:lnSpc>
-                <a:spcPts val="3645"/>
-              </a:lnSpc>
-              <a:buNone/>
-            </a:pPr>
-            <a:r>
-              <a:rPr lang="en-US" sz="2700" dirty="0" spc="-1" kern="0">
-                <a:solidFill>
-                  <a:srgbClr val="F3EEE3"/>
-                </a:solidFill>
-                <a:latin typeface="Be Vietnam Pro" pitchFamily="34" charset="0"/>
-                <a:ea typeface="Be Vietnam Pro" pitchFamily="34" charset="-122"/>
-                <a:cs typeface="Be Vietnam Pro" pitchFamily="34" charset="-120"/>
-              </a:rPr>
-              <a:t>của</a:t>
-            </a:r>
-            <a:r>
-              <a:rPr lang="en-US" sz="2700" dirty="0" spc="2" kern="0">
-                <a:solidFill>
-                  <a:srgbClr val="F3EEE3"/>
-                </a:solidFill>
-                <a:latin typeface="Be Vietnam Pro" pitchFamily="34" charset="0"/>
-                <a:ea typeface="Be Vietnam Pro" pitchFamily="34" charset="-122"/>
-                <a:cs typeface="Be Vietnam Pro" pitchFamily="34" charset="-120"/>
-              </a:rPr>
-              <a:t> các</a:t>
-            </a:r>
-            <a:r>
-              <a:rPr lang="en-US" sz="2700" dirty="0" spc="-14" kern="0">
-                <a:solidFill>
-                  <a:srgbClr val="F3EEE3"/>
-                </a:solidFill>
-                <a:latin typeface="Be Vietnam Pro" pitchFamily="34" charset="0"/>
-                <a:ea typeface="Be Vietnam Pro" pitchFamily="34" charset="-122"/>
-                <a:cs typeface="Be Vietnam Pro" pitchFamily="34" charset="-120"/>
-              </a:rPr>
-              <a:t> tập</a:t>
-            </a:r>
-            <a:r>
-              <a:rPr lang="en-US" sz="2700" dirty="0" spc="-2" kern="0">
-                <a:solidFill>
-                  <a:srgbClr val="F3EEE3"/>
-                </a:solidFill>
-                <a:latin typeface="Be Vietnam Pro" pitchFamily="34" charset="0"/>
-                <a:ea typeface="Be Vietnam Pro" pitchFamily="34" charset="-122"/>
-                <a:cs typeface="Be Vietnam Pro" pitchFamily="34" charset="-120"/>
-              </a:rPr>
-              <a:t> hợp.</a:t>
-            </a:r>
-            <a:endParaRPr lang="en-US" sz="2700" dirty="0"/>
           </a:p>
         </p:txBody>
       </p:sp>

</xml_diff>

<commit_message>
Slides: say List typically allows duplicates in the sd-10-005 deck
Co-Authored-By: Claude Sonnet 5.5 <noreply@anthropic.com>
Claude-Session: https://claude.ai/code/session_01E4oCkXXqBf2c7oMUzFxEr2
</commit_message>
<xml_diff>
--- a/system-design-101/vi/lessons/sd-10-005/slides/sd-10-005.pptx
+++ b/system-design-101/vi/lessons/sd-10-005/slides/sd-10-005.pptx
@@ -3102,6 +3102,17 @@
               <a:t> trí,</a:t>
             </a:r>
             <a:r>
+              <a:rPr lang="en-US" sz="2100" dirty="0" spc="3" kern="0">
+                <a:solidFill>
+                  <a:srgbClr val="F3EEE3"/>
+                </a:solidFill>
+                <a:latin typeface="Be Vietnam Pro" pitchFamily="34" charset="0"/>
+                <a:ea typeface="Be Vietnam Pro" pitchFamily="34" charset="-122"/>
+                <a:cs typeface="Be Vietnam Pro" pitchFamily="34" charset="-120"/>
+              </a:rPr>
+              <a:t> thường</a:t>
+            </a:r>
+            <a:r>
               <a:rPr lang="en-US" sz="2100" dirty="0" spc="-2" kern="0">
                 <a:solidFill>
                   <a:srgbClr val="F3EEE3"/>
@@ -6171,7 +6182,7 @@
               <a:t> trí,</a:t>
             </a:r>
             <a:r>
-              <a:rPr lang="en-US" sz="2100" dirty="0" spc="-1" kern="0">
+              <a:rPr lang="en-US" sz="2100" dirty="0" spc="3" kern="0">
                 <a:solidFill>
                   <a:srgbClr val="14161C"/>
                 </a:solidFill>
@@ -6179,10 +6190,10 @@
                 <a:ea typeface="Be Vietnam Pro" pitchFamily="34" charset="-122"/>
                 <a:cs typeface="Be Vietnam Pro" pitchFamily="34" charset="-120"/>
               </a:rPr>
-              <a:t> cho</a:t>
-            </a:r>
-            <a:r>
-              <a:rPr lang="en-US" sz="2100" dirty="0" spc="-3" kern="0">
+              <a:t> thường</a:t>
+            </a:r>
+            <a:r>
+              <a:rPr lang="en-US" sz="2100" dirty="0" spc="-2" kern="0">
                 <a:solidFill>
                   <a:srgbClr val="14161C"/>
                 </a:solidFill>
@@ -6190,7 +6201,7 @@
                 <a:ea typeface="Be Vietnam Pro" pitchFamily="34" charset="-122"/>
                 <a:cs typeface="Be Vietnam Pro" pitchFamily="34" charset="-120"/>
               </a:rPr>
-              <a:t> phép</a:t>
+              <a:t> cho phép</a:t>
             </a:r>
             <a:r>
               <a:rPr lang="en-US" sz="2100" dirty="0" spc="0" kern="0">
@@ -9163,7 +9174,7 @@
         <p:spPr>
           <a:xfrm>
             <a:off x="3771900" y="5143500"/>
-            <a:ext cx="3143250" cy="685800"/>
+            <a:ext cx="3810000" cy="685800"/>
           </a:xfrm>
           <a:prstGeom prst="roundRect">
             <a:avLst>
@@ -9183,7 +9194,7 @@
               <a:buNone/>
             </a:pPr>
             <a:r>
-              <a:rPr lang="en-US" sz="2250" b="1" dirty="0" spc="0" kern="0">
+              <a:rPr lang="en-US" sz="2250" b="1" dirty="0" spc="5" kern="0">
                 <a:solidFill>
                   <a:srgbClr val="F3EEE3"/>
                 </a:solidFill>
@@ -9191,7 +9202,18 @@
                 <a:ea typeface="Be Vietnam Pro" pitchFamily="34" charset="-122"/>
                 <a:cs typeface="Be Vietnam Pro" pitchFamily="34" charset="-120"/>
               </a:rPr>
-              <a:t>cho</a:t>
+              <a:t>thường</a:t>
+            </a:r>
+            <a:r>
+              <a:rPr lang="en-US" sz="2250" b="1" dirty="0" spc="1" kern="0">
+                <a:solidFill>
+                  <a:srgbClr val="F3EEE3"/>
+                </a:solidFill>
+                <a:latin typeface="Be Vietnam Pro" pitchFamily="34" charset="0"/>
+                <a:ea typeface="Be Vietnam Pro" pitchFamily="34" charset="-122"/>
+                <a:cs typeface="Be Vietnam Pro" pitchFamily="34" charset="-120"/>
+              </a:rPr>
+              <a:t> cho</a:t>
             </a:r>
             <a:r>
               <a:rPr lang="en-US" sz="2250" b="1" dirty="0" spc="-4" kern="0">
@@ -9418,6 +9440,17 @@
               <a:t> và</a:t>
             </a:r>
             <a:r>
+              <a:rPr lang="en-US" sz="2700" dirty="0" spc="6" kern="0">
+                <a:solidFill>
+                  <a:srgbClr val="14161C"/>
+                </a:solidFill>
+                <a:latin typeface="Be Vietnam Pro" pitchFamily="34" charset="0"/>
+                <a:ea typeface="Be Vietnam Pro" pitchFamily="34" charset="-122"/>
+                <a:cs typeface="Be Vietnam Pro" pitchFamily="34" charset="-120"/>
+              </a:rPr>
+              <a:t> thường</a:t>
+            </a:r>
+            <a:r>
               <a:rPr lang="en-US" sz="2700" dirty="0" spc="-1" kern="0">
                 <a:solidFill>
                   <a:srgbClr val="14161C"/>
@@ -9559,6 +9592,17 @@
                 <a:cs typeface="Be Vietnam Pro" pitchFamily="34" charset="-120"/>
               </a:rPr>
               <a:t> TRÍ,</a:t>
+            </a:r>
+            <a:r>
+              <a:rPr lang="en-US" sz="1800" b="1" spc="226" kern="0" dirty="0">
+                <a:solidFill>
+                  <a:srgbClr val="6B6A66"/>
+                </a:solidFill>
+                <a:latin typeface="Be Vietnam Pro" pitchFamily="34" charset="0"/>
+                <a:ea typeface="Be Vietnam Pro" pitchFamily="34" charset="-122"/>
+                <a:cs typeface="Be Vietnam Pro" pitchFamily="34" charset="-120"/>
+              </a:rPr>
+              <a:t> THƯỜNG</a:t>
             </a:r>
             <a:r>
               <a:rPr lang="en-US" sz="1800" b="1" spc="229" kern="0" dirty="0">
@@ -10144,7 +10188,7 @@
               <a:t>trùng</a:t>
             </a:r>
             <a:r>
-              <a:rPr lang="en-US" sz="2100" b="1" dirty="0" spc="-11" kern="0">
+              <a:rPr lang="en-US" sz="2100" b="1" dirty="0" spc="4" kern="0">
                 <a:solidFill>
                   <a:srgbClr val="1F3FD1"/>
                 </a:solidFill>
@@ -10152,10 +10196,10 @@
                 <a:ea typeface="Be Vietnam Pro" pitchFamily="34" charset="-122"/>
                 <a:cs typeface="Be Vietnam Pro" pitchFamily="34" charset="-120"/>
               </a:rPr>
-              <a:t> vẫn</a:t>
-            </a:r>
-            <a:r>
-              <a:rPr lang="en-US" sz="2100" b="1" dirty="0" spc="7" kern="0">
+              <a:t> thường</a:t>
+            </a:r>
+            <a:r>
+              <a:rPr lang="en-US" sz="2100" b="1" dirty="0" spc="6" kern="0">
                 <a:solidFill>
                   <a:srgbClr val="1F3FD1"/>
                 </a:solidFill>
@@ -10166,7 +10210,7 @@
               <a:t> được</a:t>
             </a:r>
             <a:r>
-              <a:rPr lang="en-US" sz="2100" b="1" dirty="0" spc="-8" kern="0">
+              <a:rPr lang="en-US" sz="2100" b="1" dirty="0" spc="-7" kern="0">
                 <a:solidFill>
                   <a:srgbClr val="1F3FD1"/>
                 </a:solidFill>
@@ -16795,6 +16839,9 @@
               <a:lnSpc>
                 <a:spcPts val="3443"/>
               </a:lnSpc>
+              <a:spcAft>
+                <a:spcPts val="1050"/>
+              </a:spcAft>
               <a:buSzPct val="100000"/>
               <a:buFont typeface="Arial"/>
               <a:buChar char="•"/>
@@ -16875,6 +16922,149 @@
                 <a:cs typeface="Be Vietnam Pro" pitchFamily="34" charset="-120"/>
               </a:rPr>
               <a:t> khác</a:t>
+            </a:r>
+            <a:endParaRPr lang="en-US" sz="2550" dirty="0"/>
+          </a:p>
+          <a:p>
+            <a:pPr algn="l" marL="323850" indent="-231371">
+              <a:lnSpc>
+                <a:spcPts val="3443"/>
+              </a:lnSpc>
+              <a:buSzPct val="100000"/>
+              <a:buFont typeface="Arial"/>
+              <a:buChar char="•"/>
+            </a:pPr>
+            <a:r>
+              <a:rPr lang="en-US" sz="2550" dirty="0" spc="-6" kern="0">
+                <a:solidFill>
+                  <a:srgbClr val="14161C"/>
+                </a:solidFill>
+                <a:latin typeface="Be Vietnam Pro" pitchFamily="34" charset="0"/>
+                <a:ea typeface="Be Vietnam Pro" pitchFamily="34" charset="-122"/>
+                <a:cs typeface="Be Vietnam Pro" pitchFamily="34" charset="-120"/>
+              </a:rPr>
+              <a:t>List</a:t>
+            </a:r>
+            <a:r>
+              <a:rPr lang="en-US" sz="2550" dirty="0" spc="1" kern="0">
+                <a:solidFill>
+                  <a:srgbClr val="14161C"/>
+                </a:solidFill>
+                <a:latin typeface="Be Vietnam Pro" pitchFamily="34" charset="0"/>
+                <a:ea typeface="Be Vietnam Pro" pitchFamily="34" charset="-122"/>
+                <a:cs typeface="Be Vietnam Pro" pitchFamily="34" charset="-120"/>
+              </a:rPr>
+              <a:t> chỉ</a:t>
+            </a:r>
+            <a:r>
+              <a:rPr lang="en-US" sz="2550" dirty="0" spc="5" kern="0">
+                <a:solidFill>
+                  <a:srgbClr val="14161C"/>
+                </a:solidFill>
+                <a:latin typeface="Be Vietnam Pro" pitchFamily="34" charset="0"/>
+                <a:ea typeface="Be Vietnam Pro" pitchFamily="34" charset="-122"/>
+                <a:cs typeface="Be Vietnam Pro" pitchFamily="34" charset="-120"/>
+              </a:rPr>
+              <a:t> thường</a:t>
+            </a:r>
+            <a:r>
+              <a:rPr lang="en-US" sz="2550" dirty="0" spc="-1" kern="0">
+                <a:solidFill>
+                  <a:srgbClr val="14161C"/>
+                </a:solidFill>
+                <a:latin typeface="Be Vietnam Pro" pitchFamily="34" charset="0"/>
+                <a:ea typeface="Be Vietnam Pro" pitchFamily="34" charset="-122"/>
+                <a:cs typeface="Be Vietnam Pro" pitchFamily="34" charset="-120"/>
+              </a:rPr>
+              <a:t> cho</a:t>
+            </a:r>
+            <a:r>
+              <a:rPr lang="en-US" sz="2550" dirty="0" spc="0" kern="0">
+                <a:solidFill>
+                  <a:srgbClr val="14161C"/>
+                </a:solidFill>
+                <a:latin typeface="Be Vietnam Pro" pitchFamily="34" charset="0"/>
+                <a:ea typeface="Be Vietnam Pro" pitchFamily="34" charset="-122"/>
+                <a:cs typeface="Be Vietnam Pro" pitchFamily="34" charset="-120"/>
+              </a:rPr>
+              <a:t> phép trùng;</a:t>
+            </a:r>
+            <a:r>
+              <a:rPr lang="en-US" sz="2550" dirty="0" spc="-6" kern="0">
+                <a:solidFill>
+                  <a:srgbClr val="14161C"/>
+                </a:solidFill>
+                <a:latin typeface="Be Vietnam Pro" pitchFamily="34" charset="0"/>
+                <a:ea typeface="Be Vietnam Pro" pitchFamily="34" charset="-122"/>
+                <a:cs typeface="Be Vietnam Pro" pitchFamily="34" charset="-120"/>
+              </a:rPr>
+              <a:t> một</a:t>
+            </a:r>
+            <a:r>
+              <a:rPr lang="en-US" sz="2550" dirty="0" spc="0" kern="0">
+                <a:solidFill>
+                  <a:srgbClr val="14161C"/>
+                </a:solidFill>
+                <a:latin typeface="Be Vietnam Pro" pitchFamily="34" charset="0"/>
+                <a:ea typeface="Be Vietnam Pro" pitchFamily="34" charset="-122"/>
+                <a:cs typeface="Be Vietnam Pro" pitchFamily="34" charset="-120"/>
+              </a:rPr>
+              <a:t> cài</a:t>
+            </a:r>
+            <a:r>
+              <a:rPr lang="en-US" sz="2550" dirty="0" spc="2" kern="0">
+                <a:solidFill>
+                  <a:srgbClr val="14161C"/>
+                </a:solidFill>
+                <a:latin typeface="Be Vietnam Pro" pitchFamily="34" charset="0"/>
+                <a:ea typeface="Be Vietnam Pro" pitchFamily="34" charset="-122"/>
+                <a:cs typeface="Be Vietnam Pro" pitchFamily="34" charset="-120"/>
+              </a:rPr>
+              <a:t> đặt</a:t>
+            </a:r>
+            <a:r>
+              <a:rPr lang="en-US" sz="2550" dirty="0" spc="0" kern="0">
+                <a:solidFill>
+                  <a:srgbClr val="14161C"/>
+                </a:solidFill>
+                <a:latin typeface="Be Vietnam Pro" pitchFamily="34" charset="0"/>
+                <a:ea typeface="Be Vietnam Pro" pitchFamily="34" charset="-122"/>
+                <a:cs typeface="Be Vietnam Pro" pitchFamily="34" charset="-120"/>
+              </a:rPr>
+              <a:t> có</a:t>
+            </a:r>
+            <a:r>
+              <a:rPr lang="en-US" sz="2550" dirty="0" spc="1" kern="0">
+                <a:solidFill>
+                  <a:srgbClr val="14161C"/>
+                </a:solidFill>
+                <a:latin typeface="Be Vietnam Pro" pitchFamily="34" charset="0"/>
+                <a:ea typeface="Be Vietnam Pro" pitchFamily="34" charset="-122"/>
+                <a:cs typeface="Be Vietnam Pro" pitchFamily="34" charset="-120"/>
+              </a:rPr>
+              <a:t> thể</a:t>
+            </a:r>
+            <a:r>
+              <a:rPr lang="en-US" sz="2550" dirty="0" spc="-1" kern="0">
+                <a:solidFill>
+                  <a:srgbClr val="14161C"/>
+                </a:solidFill>
+                <a:latin typeface="Be Vietnam Pro" pitchFamily="34" charset="0"/>
+                <a:ea typeface="Be Vietnam Pro" pitchFamily="34" charset="-122"/>
+                <a:cs typeface="Be Vietnam Pro" pitchFamily="34" charset="-120"/>
+              </a:rPr>
+              <a:t> từ</a:t>
+            </a:r>
+            <a:r>
+              <a:rPr lang="en-US" sz="2550" dirty="0" spc="0" kern="0">
+                <a:solidFill>
+                  <a:srgbClr val="14161C"/>
+                </a:solidFill>
+                <a:latin typeface="Be Vietnam Pro" pitchFamily="34" charset="0"/>
+                <a:ea typeface="Be Vietnam Pro" pitchFamily="34" charset="-122"/>
+                <a:cs typeface="Be Vietnam Pro" pitchFamily="34" charset="-120"/>
+              </a:rPr>
+              <a:t> chối.</a:t>
             </a:r>
             <a:endParaRPr lang="en-US" sz="2550" dirty="0"/>
           </a:p>

</xml_diff>

<commit_message>
Lesson sd-10-005: rebuild the Collection explanations from the OpenJDK class comments
Co-Authored-By: Claude Sonnet 5.5 <noreply@anthropic.com>
Claude-Session: https://claude.ai/code/session_01E4oCkXXqBf2c7oMUzFxEr2
</commit_message>
<xml_diff>
--- a/system-design-101/vi/lessons/sd-10-005/slides/sd-10-005.pptx
+++ b/system-design-101/vi/lessons/sd-10-005/slides/sd-10-005.pptx
@@ -1908,7 +1908,7 @@
               <a:buNone/>
             </a:pPr>
             <a:r>
-              <a:rPr lang="en-US" sz="3000" dirty="0" spc="-3" kern="0">
+              <a:rPr lang="en-US" sz="3000" dirty="0" spc="2" kern="0">
                 <a:solidFill>
                   <a:srgbClr val="C4C8D6"/>
                 </a:solidFill>
@@ -1916,10 +1916,10 @@
                 <a:ea typeface="Be Vietnam Pro" pitchFamily="34" charset="-122"/>
                 <a:cs typeface="Be Vietnam Pro" pitchFamily="34" charset="-120"/>
               </a:rPr>
-              <a:t>Nên</a:t>
-            </a:r>
-            <a:r>
-              <a:rPr lang="en-US" sz="3000" dirty="0" spc="1" kern="0">
+              <a:t>Mỗi</a:t>
+            </a:r>
+            <a:r>
+              <a:rPr lang="en-US" sz="3000" dirty="0" spc="-2" kern="0">
                 <a:solidFill>
                   <a:srgbClr val="C4C8D6"/>
                 </a:solidFill>
@@ -1927,10 +1927,10 @@
                 <a:ea typeface="Be Vietnam Pro" pitchFamily="34" charset="-122"/>
                 <a:cs typeface="Be Vietnam Pro" pitchFamily="34" charset="-120"/>
               </a:rPr>
-              <a:t> chọn</a:t>
-            </a:r>
-            <a:r>
-              <a:rPr lang="en-US" sz="3000" dirty="0" spc="-1" kern="0">
+              <a:t> nhánh</a:t>
+            </a:r>
+            <a:r>
+              <a:rPr lang="en-US" sz="3000" dirty="0" spc="11" kern="0">
                 <a:solidFill>
                   <a:srgbClr val="C4C8D6"/>
                 </a:solidFill>
@@ -1938,7 +1938,29 @@
                 <a:ea typeface="Be Vietnam Pro" pitchFamily="34" charset="-122"/>
                 <a:cs typeface="Be Vietnam Pro" pitchFamily="34" charset="-120"/>
               </a:rPr>
-              <a:t> cấu</a:t>
+              <a:t> hứa</a:t>
+            </a:r>
+            <a:r>
+              <a:rPr lang="en-US" sz="3000" dirty="0" spc="-5" kern="0">
+                <a:solidFill>
+                  <a:srgbClr val="C4C8D6"/>
+                </a:solidFill>
+                <a:latin typeface="Be Vietnam Pro" pitchFamily="34" charset="0"/>
+                <a:ea typeface="Be Vietnam Pro" pitchFamily="34" charset="-122"/>
+                <a:cs typeface="Be Vietnam Pro" pitchFamily="34" charset="-120"/>
+              </a:rPr>
+              <a:t> một</a:t>
+            </a:r>
+            <a:r>
+              <a:rPr lang="en-US" sz="3000" dirty="0" spc="25" kern="0">
+                <a:solidFill>
+                  <a:srgbClr val="C4C8D6"/>
+                </a:solidFill>
+                <a:latin typeface="Be Vietnam Pro" pitchFamily="34" charset="0"/>
+                <a:ea typeface="Be Vietnam Pro" pitchFamily="34" charset="-122"/>
+                <a:cs typeface="Be Vietnam Pro" pitchFamily="34" charset="-120"/>
+              </a:rPr>
+              <a:t> điều</a:t>
             </a:r>
             <a:r>
               <a:rPr lang="en-US" sz="3000" dirty="0" spc="0" kern="0">
@@ -1949,10 +1971,10 @@
                 <a:ea typeface="Be Vietnam Pro" pitchFamily="34" charset="-122"/>
                 <a:cs typeface="Be Vietnam Pro" pitchFamily="34" charset="-120"/>
               </a:rPr>
-              <a:t> trúc</a:t>
-            </a:r>
-            <a:r>
-              <a:rPr lang="en-US" sz="3000" dirty="0" spc="3" kern="0">
+              <a:t> khác</a:t>
+            </a:r>
+            <a:r>
+              <a:rPr lang="en-US" sz="3000" dirty="0" spc="-2" kern="0">
                 <a:solidFill>
                   <a:srgbClr val="C4C8D6"/>
                 </a:solidFill>
@@ -1960,84 +1982,7 @@
                 <a:ea typeface="Be Vietnam Pro" pitchFamily="34" charset="-122"/>
                 <a:cs typeface="Be Vietnam Pro" pitchFamily="34" charset="-120"/>
               </a:rPr>
-              <a:t> dữ</a:t>
-            </a:r>
-            <a:r>
-              <a:rPr lang="en-US" sz="3000" dirty="0" spc="2" kern="0">
-                <a:solidFill>
-                  <a:srgbClr val="C4C8D6"/>
-                </a:solidFill>
-                <a:latin typeface="Be Vietnam Pro" pitchFamily="34" charset="0"/>
-                <a:ea typeface="Be Vietnam Pro" pitchFamily="34" charset="-122"/>
-                <a:cs typeface="Be Vietnam Pro" pitchFamily="34" charset="-120"/>
-              </a:rPr>
-              <a:t> liệu</a:t>
-            </a:r>
-            <a:r>
-              <a:rPr lang="en-US" sz="3000" dirty="0" spc="-2" kern="0">
-                <a:solidFill>
-                  <a:srgbClr val="C4C8D6"/>
-                </a:solidFill>
-                <a:latin typeface="Be Vietnam Pro" pitchFamily="34" charset="0"/>
-                <a:ea typeface="Be Vietnam Pro" pitchFamily="34" charset="-122"/>
-                <a:cs typeface="Be Vietnam Pro" pitchFamily="34" charset="-120"/>
-              </a:rPr>
-              <a:t> nào</a:t>
-            </a:r>
-            <a:r>
-              <a:rPr lang="en-US" sz="3000" dirty="0" spc="1" kern="0">
-                <a:solidFill>
-                  <a:srgbClr val="C4C8D6"/>
-                </a:solidFill>
-                <a:latin typeface="Be Vietnam Pro" pitchFamily="34" charset="0"/>
-                <a:ea typeface="Be Vietnam Pro" pitchFamily="34" charset="-122"/>
-                <a:cs typeface="Be Vietnam Pro" pitchFamily="34" charset="-120"/>
-              </a:rPr>
-              <a:t> cho</a:t>
-            </a:r>
-            <a:r>
-              <a:rPr lang="en-US" sz="3000" dirty="0" spc="-1" kern="0">
-                <a:solidFill>
-                  <a:srgbClr val="C4C8D6"/>
-                </a:solidFill>
-                <a:latin typeface="Be Vietnam Pro" pitchFamily="34" charset="0"/>
-                <a:ea typeface="Be Vietnam Pro" pitchFamily="34" charset="-122"/>
-                <a:cs typeface="Be Vietnam Pro" pitchFamily="34" charset="-120"/>
-              </a:rPr>
-              <a:t> bài</a:t>
-            </a:r>
-            <a:r>
-              <a:rPr lang="en-US" sz="3000" dirty="0" spc="-17" kern="0">
-                <a:solidFill>
-                  <a:srgbClr val="C4C8D6"/>
-                </a:solidFill>
-                <a:latin typeface="Be Vietnam Pro" pitchFamily="34" charset="0"/>
-                <a:ea typeface="Be Vietnam Pro" pitchFamily="34" charset="-122"/>
-                <a:cs typeface="Be Vietnam Pro" pitchFamily="34" charset="-120"/>
-              </a:rPr>
-              <a:t> toán</a:t>
-            </a:r>
-            <a:r>
-              <a:rPr lang="en-US" sz="3000" dirty="0" spc="0" kern="0">
-                <a:solidFill>
-                  <a:srgbClr val="C4C8D6"/>
-                </a:solidFill>
-                <a:latin typeface="Be Vietnam Pro" pitchFamily="34" charset="0"/>
-                <a:ea typeface="Be Vietnam Pro" pitchFamily="34" charset="-122"/>
-                <a:cs typeface="Be Vietnam Pro" pitchFamily="34" charset="-120"/>
-              </a:rPr>
-              <a:t> của</a:t>
-            </a:r>
-            <a:r>
-              <a:rPr lang="en-US" sz="3000" dirty="0" spc="-4" kern="0">
-                <a:solidFill>
-                  <a:srgbClr val="C4C8D6"/>
-                </a:solidFill>
-                <a:latin typeface="Be Vietnam Pro" pitchFamily="34" charset="0"/>
-                <a:ea typeface="Be Vietnam Pro" pitchFamily="34" charset="-122"/>
-                <a:cs typeface="Be Vietnam Pro" pitchFamily="34" charset="-120"/>
-              </a:rPr>
-              <a:t> bạn?</a:t>
+              <a:t> nhau.</a:t>
             </a:r>
             <a:endParaRPr lang="en-US" sz="3000" dirty="0"/>
           </a:p>
@@ -2146,6 +2091,28 @@
               <a:buNone/>
             </a:pPr>
             <a:r>
+              <a:rPr lang="en-US" sz="1950" dirty="0" spc="-3" kern="0">
+                <a:solidFill>
+                  <a:srgbClr val="C4C8D6"/>
+                </a:solidFill>
+                <a:latin typeface="Be Vietnam Pro" pitchFamily="34" charset="0"/>
+                <a:ea typeface="Be Vietnam Pro" pitchFamily="34" charset="-122"/>
+                <a:cs typeface="Be Vietnam Pro" pitchFamily="34" charset="-120"/>
+              </a:rPr>
+              <a:t>hợp</a:t>
+            </a:r>
+            <a:r>
+              <a:rPr lang="en-US" sz="1950" dirty="0" spc="9" kern="0">
+                <a:solidFill>
+                  <a:srgbClr val="C4C8D6"/>
+                </a:solidFill>
+                <a:latin typeface="Be Vietnam Pro" pitchFamily="34" charset="0"/>
+                <a:ea typeface="Be Vietnam Pro" pitchFamily="34" charset="-122"/>
+                <a:cs typeface="Be Vietnam Pro" pitchFamily="34" charset="-120"/>
+              </a:rPr>
+              <a:t> đồng</a:t>
+            </a:r>
+            <a:r>
               <a:rPr lang="en-US" sz="1950" dirty="0" spc="1" kern="0">
                 <a:solidFill>
                   <a:srgbClr val="C4C8D6"/>
@@ -2154,18 +2121,7 @@
                 <a:ea typeface="Be Vietnam Pro" pitchFamily="34" charset="-122"/>
                 <a:cs typeface="Be Vietnam Pro" pitchFamily="34" charset="-120"/>
               </a:rPr>
-              <a:t>nhánh</a:t>
-            </a:r>
-            <a:r>
-              <a:rPr lang="en-US" sz="1950" dirty="0" spc="0" kern="0">
-                <a:solidFill>
-                  <a:srgbClr val="C4C8D6"/>
-                </a:solidFill>
-                <a:latin typeface="Be Vietnam Pro" pitchFamily="34" charset="0"/>
-                <a:ea typeface="Be Vietnam Pro" pitchFamily="34" charset="-122"/>
-                <a:cs typeface="Be Vietnam Pro" pitchFamily="34" charset="-120"/>
-              </a:rPr>
-              <a:t> chính</a:t>
+              <a:t> con</a:t>
             </a:r>
             <a:endParaRPr lang="en-US" sz="1950" dirty="0"/>
           </a:p>
@@ -3036,7 +2992,7 @@
               <a:buNone/>
             </a:pPr>
             <a:r>
-              <a:rPr lang="en-US" sz="2100" dirty="0" spc="-3" kern="0">
+              <a:rPr lang="en-US" sz="2100" dirty="0" spc="0" kern="0">
                 <a:solidFill>
                   <a:srgbClr val="F3EEE3"/>
                 </a:solidFill>
@@ -3044,7 +3000,29 @@
                 <a:ea typeface="Be Vietnam Pro" pitchFamily="34" charset="-122"/>
                 <a:cs typeface="Be Vietnam Pro" pitchFamily="34" charset="-120"/>
               </a:rPr>
-              <a:t>có</a:t>
+              <a:t>mỗi</a:t>
+            </a:r>
+            <a:r>
+              <a:rPr lang="en-US" sz="2100" dirty="0" spc="-2" kern="0">
+                <a:solidFill>
+                  <a:srgbClr val="F3EEE3"/>
+                </a:solidFill>
+                <a:latin typeface="Be Vietnam Pro" pitchFamily="34" charset="0"/>
+                <a:ea typeface="Be Vietnam Pro" pitchFamily="34" charset="-122"/>
+                <a:cs typeface="Be Vietnam Pro" pitchFamily="34" charset="-120"/>
+              </a:rPr>
+              <a:t> phần tử</a:t>
+            </a:r>
+            <a:r>
+              <a:rPr lang="en-US" sz="2100" dirty="0" spc="-8" kern="0">
+                <a:solidFill>
+                  <a:srgbClr val="F3EEE3"/>
+                </a:solidFill>
+                <a:latin typeface="Be Vietnam Pro" pitchFamily="34" charset="0"/>
+                <a:ea typeface="Be Vietnam Pro" pitchFamily="34" charset="-122"/>
+                <a:cs typeface="Be Vietnam Pro" pitchFamily="34" charset="-120"/>
+              </a:rPr>
+              <a:t> một</a:t>
             </a:r>
             <a:r>
               <a:rPr lang="en-US" sz="2100" dirty="0" spc="-1" kern="0">
@@ -3055,7 +3033,40 @@
                 <a:ea typeface="Be Vietnam Pro" pitchFamily="34" charset="-122"/>
                 <a:cs typeface="Be Vietnam Pro" pitchFamily="34" charset="-120"/>
               </a:rPr>
-              <a:t> thứ</a:t>
+              <a:t> vị</a:t>
+            </a:r>
+            <a:r>
+              <a:rPr lang="en-US" sz="2100" dirty="0" spc="8" kern="0">
+                <a:solidFill>
+                  <a:srgbClr val="F3EEE3"/>
+                </a:solidFill>
+                <a:latin typeface="Be Vietnam Pro" pitchFamily="34" charset="0"/>
+                <a:ea typeface="Be Vietnam Pro" pitchFamily="34" charset="-122"/>
+                <a:cs typeface="Be Vietnam Pro" pitchFamily="34" charset="-120"/>
+              </a:rPr>
+              <a:t> trí,</a:t>
+            </a:r>
+            <a:r>
+              <a:rPr lang="en-US" sz="2100" dirty="0" spc="6" kern="0">
+                <a:solidFill>
+                  <a:srgbClr val="F3EEE3"/>
+                </a:solidFill>
+                <a:latin typeface="Be Vietnam Pro" pitchFamily="34" charset="0"/>
+                <a:ea typeface="Be Vietnam Pro" pitchFamily="34" charset="-122"/>
+                <a:cs typeface="Be Vietnam Pro" pitchFamily="34" charset="-120"/>
+              </a:rPr>
+              <a:t> đọc</a:t>
+            </a:r>
+            <a:r>
+              <a:rPr lang="en-US" sz="2100" dirty="0" spc="-5" kern="0">
+                <a:solidFill>
+                  <a:srgbClr val="F3EEE3"/>
+                </a:solidFill>
+                <a:latin typeface="Be Vietnam Pro" pitchFamily="34" charset="0"/>
+                <a:ea typeface="Be Vietnam Pro" pitchFamily="34" charset="-122"/>
+                <a:cs typeface="Be Vietnam Pro" pitchFamily="34" charset="-120"/>
+              </a:rPr>
+              <a:t> theo</a:t>
             </a:r>
             <a:r>
               <a:rPr lang="en-US" sz="2100" dirty="0" spc="0" kern="0">
@@ -3066,10 +3077,10 @@
                 <a:ea typeface="Be Vietnam Pro" pitchFamily="34" charset="-122"/>
                 <a:cs typeface="Be Vietnam Pro" pitchFamily="34" charset="-120"/>
               </a:rPr>
-              <a:t> tự</a:t>
-            </a:r>
-            <a:r>
-              <a:rPr lang="en-US" sz="2100" dirty="0" spc="-5" kern="0">
+              <a:t> chỉ</a:t>
+            </a:r>
+            <a:r>
+              <a:rPr lang="en-US" sz="2100" dirty="0" spc="-9" kern="0">
                 <a:solidFill>
                   <a:srgbClr val="F3EEE3"/>
                 </a:solidFill>
@@ -3077,73 +3088,7 @@
                 <a:ea typeface="Be Vietnam Pro" pitchFamily="34" charset="-122"/>
                 <a:cs typeface="Be Vietnam Pro" pitchFamily="34" charset="-120"/>
               </a:rPr>
-              <a:t> theo</a:t>
-            </a:r>
-            <a:r>
-              <a:rPr lang="en-US" sz="2100" dirty="0" spc="-1" kern="0">
-                <a:solidFill>
-                  <a:srgbClr val="F3EEE3"/>
-                </a:solidFill>
-                <a:latin typeface="Be Vietnam Pro" pitchFamily="34" charset="0"/>
-                <a:ea typeface="Be Vietnam Pro" pitchFamily="34" charset="-122"/>
-                <a:cs typeface="Be Vietnam Pro" pitchFamily="34" charset="-120"/>
-              </a:rPr>
-              <a:t> vị</a:t>
-            </a:r>
-            <a:r>
-              <a:rPr lang="en-US" sz="2100" dirty="0" spc="8" kern="0">
-                <a:solidFill>
-                  <a:srgbClr val="F3EEE3"/>
-                </a:solidFill>
-                <a:latin typeface="Be Vietnam Pro" pitchFamily="34" charset="0"/>
-                <a:ea typeface="Be Vietnam Pro" pitchFamily="34" charset="-122"/>
-                <a:cs typeface="Be Vietnam Pro" pitchFamily="34" charset="-120"/>
-              </a:rPr>
-              <a:t> trí,</a:t>
-            </a:r>
-            <a:r>
-              <a:rPr lang="en-US" sz="2100" dirty="0" spc="3" kern="0">
-                <a:solidFill>
-                  <a:srgbClr val="F3EEE3"/>
-                </a:solidFill>
-                <a:latin typeface="Be Vietnam Pro" pitchFamily="34" charset="0"/>
-                <a:ea typeface="Be Vietnam Pro" pitchFamily="34" charset="-122"/>
-                <a:cs typeface="Be Vietnam Pro" pitchFamily="34" charset="-120"/>
-              </a:rPr>
-              <a:t> thường</a:t>
-            </a:r>
-            <a:r>
-              <a:rPr lang="en-US" sz="2100" dirty="0" spc="-2" kern="0">
-                <a:solidFill>
-                  <a:srgbClr val="F3EEE3"/>
-                </a:solidFill>
-                <a:latin typeface="Be Vietnam Pro" pitchFamily="34" charset="0"/>
-                <a:ea typeface="Be Vietnam Pro" pitchFamily="34" charset="-122"/>
-                <a:cs typeface="Be Vietnam Pro" pitchFamily="34" charset="-120"/>
-              </a:rPr>
-              <a:t> cho</a:t>
-            </a:r>
-            <a:r>
-              <a:rPr lang="en-US" sz="2100" dirty="0" spc="-3" kern="0">
-                <a:solidFill>
-                  <a:srgbClr val="F3EEE3"/>
-                </a:solidFill>
-                <a:latin typeface="Be Vietnam Pro" pitchFamily="34" charset="0"/>
-                <a:ea typeface="Be Vietnam Pro" pitchFamily="34" charset="-122"/>
-                <a:cs typeface="Be Vietnam Pro" pitchFamily="34" charset="-120"/>
-              </a:rPr>
-              <a:t> phép</a:t>
-            </a:r>
-            <a:r>
-              <a:rPr lang="en-US" sz="2100" dirty="0" spc="0" kern="0">
-                <a:solidFill>
-                  <a:srgbClr val="F3EEE3"/>
-                </a:solidFill>
-                <a:latin typeface="Be Vietnam Pro" pitchFamily="34" charset="0"/>
-                <a:ea typeface="Be Vietnam Pro" pitchFamily="34" charset="-122"/>
-                <a:cs typeface="Be Vietnam Pro" pitchFamily="34" charset="-120"/>
-              </a:rPr>
-              <a:t> trùng</a:t>
+              <a:t> số</a:t>
             </a:r>
             <a:endParaRPr lang="en-US" sz="2100" dirty="0"/>
           </a:p>
@@ -3224,7 +3169,7 @@
               <a:t>không</a:t>
             </a:r>
             <a:r>
-              <a:rPr lang="en-US" sz="2100" dirty="0" spc="6" kern="0">
+              <a:rPr lang="en-US" sz="2100" dirty="0" spc="-1" kern="0">
                 <a:solidFill>
                   <a:srgbClr val="F3EEE3"/>
                 </a:solidFill>
@@ -3232,10 +3177,10 @@
                 <a:ea typeface="Be Vietnam Pro" pitchFamily="34" charset="-122"/>
                 <a:cs typeface="Be Vietnam Pro" pitchFamily="34" charset="-120"/>
               </a:rPr>
-              <a:t> chứa</a:t>
-            </a:r>
-            <a:r>
-              <a:rPr lang="en-US" sz="2100" dirty="0" spc="-3" kern="0">
+              <a:t> hai</a:t>
+            </a:r>
+            <a:r>
+              <a:rPr lang="en-US" sz="2100" dirty="0" spc="-2" kern="0">
                 <a:solidFill>
                   <a:srgbClr val="F3EEE3"/>
                 </a:solidFill>
@@ -3246,6 +3191,28 @@
               <a:t> phần</a:t>
             </a:r>
             <a:r>
+              <a:rPr lang="en-US" sz="2100" dirty="0" spc="-1" kern="0">
+                <a:solidFill>
+                  <a:srgbClr val="F3EEE3"/>
+                </a:solidFill>
+                <a:latin typeface="Be Vietnam Pro" pitchFamily="34" charset="0"/>
+                <a:ea typeface="Be Vietnam Pro" pitchFamily="34" charset="-122"/>
+                <a:cs typeface="Be Vietnam Pro" pitchFamily="34" charset="-120"/>
+              </a:rPr>
+              <a:t> tử</a:t>
+            </a:r>
+            <a:r>
+              <a:rPr lang="en-US" sz="2100" dirty="0" spc="-4" kern="0">
+                <a:solidFill>
+                  <a:srgbClr val="F3EEE3"/>
+                </a:solidFill>
+                <a:latin typeface="Be Vietnam Pro" pitchFamily="34" charset="0"/>
+                <a:ea typeface="Be Vietnam Pro" pitchFamily="34" charset="-122"/>
+                <a:cs typeface="Be Vietnam Pro" pitchFamily="34" charset="-120"/>
+              </a:rPr>
+              <a:t> bằng</a:t>
+            </a:r>
+            <a:r>
               <a:rPr lang="en-US" sz="2100" dirty="0" spc="0" kern="0">
                 <a:solidFill>
                   <a:srgbClr val="F3EEE3"/>
@@ -3254,7 +3221,7 @@
                 <a:ea typeface="Be Vietnam Pro" pitchFamily="34" charset="-122"/>
                 <a:cs typeface="Be Vietnam Pro" pitchFamily="34" charset="-120"/>
               </a:rPr>
-              <a:t> tử trùng</a:t>
+              <a:t> nhau</a:t>
             </a:r>
             <a:endParaRPr lang="en-US" sz="2100" dirty="0"/>
           </a:p>
@@ -3663,7 +3630,7 @@
               <a:buNone/>
             </a:pPr>
             <a:r>
-              <a:rPr lang="en-US" sz="9000" dirty="0" kern="0">
+              <a:rPr lang="en-US" sz="9000" dirty="0" spc="9" kern="0">
                 <a:solidFill>
                   <a:srgbClr val="F3EEE3"/>
                 </a:solidFill>
@@ -3671,7 +3638,7 @@
                 <a:ea typeface="Bricolage Grotesque ExtraBold" pitchFamily="34" charset="-122"/>
                 <a:cs typeface="Bricolage Grotesque ExtraBold" pitchFamily="34" charset="-120"/>
               </a:rPr>
-              <a:t>JCF</a:t>
+              <a:t>equals</a:t>
             </a:r>
             <a:endParaRPr lang="en-US" sz="9000" dirty="0"/>
           </a:p>
@@ -3879,7 +3846,7 @@
               <a:t> ·</a:t>
             </a:r>
             <a:r>
-              <a:rPr lang="en-US" sz="2550" dirty="0" spc="-9" kern="0">
+              <a:rPr lang="en-US" sz="2550" dirty="0" spc="1" kern="0">
                 <a:solidFill>
                   <a:srgbClr val="F3EEE3"/>
                 </a:solidFill>
@@ -3887,7 +3854,40 @@
                 <a:ea typeface="Be Vietnam Pro" pitchFamily="34" charset="-122"/>
                 <a:cs typeface="Be Vietnam Pro" pitchFamily="34" charset="-120"/>
               </a:rPr>
-              <a:t> system-design-101</a:t>
+              <a:t> chỉ</a:t>
+            </a:r>
+            <a:r>
+              <a:rPr lang="en-US" sz="2550" dirty="0" spc="-10" kern="0">
+                <a:solidFill>
+                  <a:srgbClr val="F3EEE3"/>
+                </a:solidFill>
+                <a:latin typeface="Be Vietnam Pro" pitchFamily="34" charset="0"/>
+                <a:ea typeface="Be Vietnam Pro" pitchFamily="34" charset="-122"/>
+                <a:cs typeface="Be Vietnam Pro" pitchFamily="34" charset="-120"/>
+              </a:rPr>
+              <a:t> lấy</a:t>
+            </a:r>
+            <a:r>
+              <a:rPr lang="en-US" sz="2550" dirty="0" spc="-11" kern="0">
+                <a:solidFill>
+                  <a:srgbClr val="F3EEE3"/>
+                </a:solidFill>
+                <a:latin typeface="Be Vietnam Pro" pitchFamily="34" charset="0"/>
+                <a:ea typeface="Be Vietnam Pro" pitchFamily="34" charset="-122"/>
+                <a:cs typeface="Be Vietnam Pro" pitchFamily="34" charset="-120"/>
+              </a:rPr>
+              <a:t> tên</a:t>
+            </a:r>
+            <a:r>
+              <a:rPr lang="en-US" sz="2550" dirty="0" spc="0" kern="0">
+                <a:solidFill>
+                  <a:srgbClr val="F3EEE3"/>
+                </a:solidFill>
+                <a:latin typeface="Be Vietnam Pro" pitchFamily="34" charset="0"/>
+                <a:ea typeface="Be Vietnam Pro" pitchFamily="34" charset="-122"/>
+                <a:cs typeface="Be Vietnam Pro" pitchFamily="34" charset="-120"/>
+              </a:rPr>
+              <a:t> lớp</a:t>
             </a:r>
             <a:endParaRPr lang="en-US" sz="2550" dirty="0"/>
           </a:p>
@@ -4238,7 +4238,7 @@
               <a:t> ngày</a:t>
             </a:r>
             <a:r>
-              <a:rPr lang="en-US" sz="2100" dirty="0" spc="-1" kern="0">
+              <a:rPr lang="en-US" sz="2100" dirty="0" spc="0" kern="0">
                 <a:solidFill>
                   <a:srgbClr val="C4C8D6"/>
                 </a:solidFill>
@@ -4246,10 +4246,10 @@
                 <a:ea typeface="Be Vietnam Pro" pitchFamily="34" charset="-122"/>
                 <a:cs typeface="Be Vietnam Pro" pitchFamily="34" charset="-120"/>
               </a:rPr>
-              <a:t> 2026-10-18.</a:t>
-            </a:r>
-            <a:r>
-              <a:rPr lang="en-US" sz="2100" dirty="0" spc="0" kern="0">
+              <a:t> 2026-10-19. Hình minh</a:t>
+            </a:r>
+            <a:r>
+              <a:rPr lang="en-US" sz="2100" dirty="0" spc="-5" kern="0">
                 <a:solidFill>
                   <a:srgbClr val="C4C8D6"/>
                 </a:solidFill>
@@ -4257,10 +4257,10 @@
                 <a:ea typeface="Be Vietnam Pro" pitchFamily="34" charset="-122"/>
                 <a:cs typeface="Be Vietnam Pro" pitchFamily="34" charset="-120"/>
               </a:rPr>
-              <a:t> Hình</a:t>
-            </a:r>
-            <a:r>
-              <a:rPr lang="en-US" sz="2100" dirty="0" spc="1" kern="0">
+              <a:t> họa</a:t>
+            </a:r>
+            <a:r>
+              <a:rPr lang="en-US" sz="2100" dirty="0" spc="-4" kern="0">
                 <a:solidFill>
                   <a:srgbClr val="C4C8D6"/>
                 </a:solidFill>
@@ -4268,10 +4268,10 @@
                 <a:ea typeface="Be Vietnam Pro" pitchFamily="34" charset="-122"/>
                 <a:cs typeface="Be Vietnam Pro" pitchFamily="34" charset="-120"/>
               </a:rPr>
-              <a:t> minh</a:t>
-            </a:r>
-            <a:r>
-              <a:rPr lang="en-US" sz="2100" dirty="0" spc="-6" kern="0">
+              <a:t> là</a:t>
+            </a:r>
+            <a:r>
+              <a:rPr lang="en-US" sz="2100" dirty="0" spc="-3" kern="0">
                 <a:solidFill>
                   <a:srgbClr val="C4C8D6"/>
                 </a:solidFill>
@@ -4279,32 +4279,10 @@
                 <a:ea typeface="Be Vietnam Pro" pitchFamily="34" charset="-122"/>
                 <a:cs typeface="Be Vietnam Pro" pitchFamily="34" charset="-120"/>
               </a:rPr>
-              <a:t> họa</a:t>
-            </a:r>
-            <a:r>
-              <a:rPr lang="en-US" sz="2100" dirty="0" spc="-3" kern="0">
-                <a:solidFill>
-                  <a:srgbClr val="C4C8D6"/>
-                </a:solidFill>
-                <a:latin typeface="Be Vietnam Pro" pitchFamily="34" charset="0"/>
-                <a:ea typeface="Be Vietnam Pro" pitchFamily="34" charset="-122"/>
-                <a:cs typeface="Be Vietnam Pro" pitchFamily="34" charset="-120"/>
-              </a:rPr>
-              <a:t> là</a:t>
-            </a:r>
-            <a:r>
-              <a:rPr lang="en-US" sz="2100" dirty="0" spc="-4" kern="0">
-                <a:solidFill>
-                  <a:srgbClr val="C4C8D6"/>
-                </a:solidFill>
-                <a:latin typeface="Be Vietnam Pro" pitchFamily="34" charset="0"/>
-                <a:ea typeface="Be Vietnam Pro" pitchFamily="34" charset="-122"/>
-                <a:cs typeface="Be Vietnam Pro" pitchFamily="34" charset="-120"/>
-              </a:rPr>
               <a:t> thiết</a:t>
             </a:r>
             <a:r>
-              <a:rPr lang="en-US" sz="2100" dirty="0" spc="-30" kern="0">
+              <a:rPr lang="en-US" sz="2100" dirty="0" spc="-31" kern="0">
                 <a:solidFill>
                   <a:srgbClr val="C4C8D6"/>
                 </a:solidFill>
@@ -4720,7 +4698,7 @@
               <a:buNone/>
             </a:pPr>
             <a:r>
-              <a:rPr lang="en-US" sz="2250" b="1" dirty="0" spc="-22" kern="0">
+              <a:rPr lang="en-US" sz="2250" b="1" dirty="0" spc="5" kern="0">
                 <a:solidFill>
                   <a:srgbClr val="9AA0B5"/>
                 </a:solidFill>
@@ -4728,10 +4706,10 @@
                 <a:ea typeface="Be Vietnam Pro" pitchFamily="34" charset="-122"/>
                 <a:cs typeface="Be Vietnam Pro" pitchFamily="34" charset="-120"/>
               </a:rPr>
-              <a:t>Java</a:t>
-            </a:r>
-            <a:r>
-              <a:rPr lang="en-US" sz="2250" b="1" dirty="0" spc="-3" kern="0">
+              <a:t>Phương</a:t>
+            </a:r>
+            <a:r>
+              <a:rPr lang="en-US" sz="2250" b="1" dirty="0" spc="13" kern="0">
                 <a:solidFill>
                   <a:srgbClr val="9AA0B5"/>
                 </a:solidFill>
@@ -4739,10 +4717,10 @@
                 <a:ea typeface="Be Vietnam Pro" pitchFamily="34" charset="-122"/>
                 <a:cs typeface="Be Vietnam Pro" pitchFamily="34" charset="-120"/>
               </a:rPr>
-              <a:t> Collections</a:t>
-            </a:r>
-            <a:r>
-              <a:rPr lang="en-US" sz="2250" b="1" dirty="0" spc="-25" kern="0">
+              <a:t> thức</a:t>
+            </a:r>
+            <a:r>
+              <a:rPr lang="en-US" sz="2250" b="1" dirty="0" spc="0" kern="0">
                 <a:solidFill>
                   <a:srgbClr val="9AA0B5"/>
                 </a:solidFill>
@@ -4750,7 +4728,7 @@
                 <a:ea typeface="Be Vietnam Pro" pitchFamily="34" charset="-122"/>
                 <a:cs typeface="Be Vietnam Pro" pitchFamily="34" charset="-120"/>
               </a:rPr>
-              <a:t> Framework</a:t>
+              <a:t> equals</a:t>
             </a:r>
             <a:endParaRPr lang="en-US" sz="2250" dirty="0"/>
           </a:p>
@@ -4784,6 +4762,39 @@
               <a:buNone/>
             </a:pPr>
             <a:r>
+              <a:rPr lang="en-US" sz="2550" dirty="0" spc="-21" kern="0">
+                <a:solidFill>
+                  <a:srgbClr val="F3EEE3"/>
+                </a:solidFill>
+                <a:latin typeface="Be Vietnam Pro" pitchFamily="34" charset="0"/>
+                <a:ea typeface="Be Vietnam Pro" pitchFamily="34" charset="-122"/>
+                <a:cs typeface="Be Vietnam Pro" pitchFamily="34" charset="-120"/>
+              </a:rPr>
+              <a:t>Quyết</a:t>
+            </a:r>
+            <a:r>
+              <a:rPr lang="en-US" sz="2550" dirty="0" spc="20" kern="0">
+                <a:solidFill>
+                  <a:srgbClr val="F3EEE3"/>
+                </a:solidFill>
+                <a:latin typeface="Be Vietnam Pro" pitchFamily="34" charset="0"/>
+                <a:ea typeface="Be Vietnam Pro" pitchFamily="34" charset="-122"/>
+                <a:cs typeface="Be Vietnam Pro" pitchFamily="34" charset="-120"/>
+              </a:rPr>
+              <a:t> định</a:t>
+            </a:r>
+            <a:r>
+              <a:rPr lang="en-US" sz="2550" dirty="0" spc="-1" kern="0">
+                <a:solidFill>
+                  <a:srgbClr val="F3EEE3"/>
+                </a:solidFill>
+                <a:latin typeface="Be Vietnam Pro" pitchFamily="34" charset="0"/>
+                <a:ea typeface="Be Vietnam Pro" pitchFamily="34" charset="-122"/>
+                <a:cs typeface="Be Vietnam Pro" pitchFamily="34" charset="-120"/>
+              </a:rPr>
+              <a:t> hai</a:t>
+            </a:r>
+            <a:r>
               <a:rPr lang="en-US" sz="2550" dirty="0" spc="0" kern="0">
                 <a:solidFill>
                   <a:srgbClr val="F3EEE3"/>
@@ -4792,10 +4803,10 @@
                 <a:ea typeface="Be Vietnam Pro" pitchFamily="34" charset="-122"/>
                 <a:cs typeface="Be Vietnam Pro" pitchFamily="34" charset="-120"/>
               </a:rPr>
-              <a:t>Khung</a:t>
-            </a:r>
-            <a:r>
-              <a:rPr lang="en-US" sz="2550" dirty="0" spc="-11" kern="0">
+              <a:t> phần</a:t>
+            </a:r>
+            <a:r>
+              <a:rPr lang="en-US" sz="2550" dirty="0" spc="-1" kern="0">
                 <a:solidFill>
                   <a:srgbClr val="F3EEE3"/>
                 </a:solidFill>
@@ -4803,29 +4814,7 @@
                 <a:ea typeface="Be Vietnam Pro" pitchFamily="34" charset="-122"/>
                 <a:cs typeface="Be Vietnam Pro" pitchFamily="34" charset="-120"/>
               </a:rPr>
-              <a:t> tập</a:t>
-            </a:r>
-            <a:r>
-              <a:rPr lang="en-US" sz="2550" dirty="0" spc="-1" kern="0">
-                <a:solidFill>
-                  <a:srgbClr val="F3EEE3"/>
-                </a:solidFill>
-                <a:latin typeface="Be Vietnam Pro" pitchFamily="34" charset="0"/>
-                <a:ea typeface="Be Vietnam Pro" pitchFamily="34" charset="-122"/>
-                <a:cs typeface="Be Vietnam Pro" pitchFamily="34" charset="-120"/>
-              </a:rPr>
-              <a:t> hợp của</a:t>
-            </a:r>
-            <a:r>
-              <a:rPr lang="en-US" sz="2550" dirty="0" spc="-18" kern="0">
-                <a:solidFill>
-                  <a:srgbClr val="F3EEE3"/>
-                </a:solidFill>
-                <a:latin typeface="Be Vietnam Pro" pitchFamily="34" charset="0"/>
-                <a:ea typeface="Be Vietnam Pro" pitchFamily="34" charset="-122"/>
-                <a:cs typeface="Be Vietnam Pro" pitchFamily="34" charset="-120"/>
-              </a:rPr>
-              <a:t> Java:</a:t>
+              <a:t> tử</a:t>
             </a:r>
             <a:endParaRPr lang="en-US" sz="2550" dirty="0"/>
           </a:p>
@@ -4837,7 +4826,7 @@
               <a:buNone/>
             </a:pPr>
             <a:r>
-              <a:rPr lang="en-US" sz="2550" dirty="0" spc="-17" kern="0">
+              <a:rPr lang="en-US" sz="2550" dirty="0" spc="0" kern="0">
                 <a:solidFill>
                   <a:srgbClr val="F3EEE3"/>
                 </a:solidFill>
@@ -4845,10 +4834,10 @@
                 <a:ea typeface="Be Vietnam Pro" pitchFamily="34" charset="-122"/>
                 <a:cs typeface="Be Vietnam Pro" pitchFamily="34" charset="-120"/>
               </a:rPr>
-              <a:t>interface</a:t>
-            </a:r>
-            <a:r>
-              <a:rPr lang="en-US" sz="2550" dirty="0" spc="-18" kern="0">
+              <a:t>có trùng</a:t>
+            </a:r>
+            <a:r>
+              <a:rPr lang="en-US" sz="2550" dirty="0" spc="-11" kern="0">
                 <a:solidFill>
                   <a:srgbClr val="F3EEE3"/>
                 </a:solidFill>
@@ -4856,10 +4845,10 @@
                 <a:ea typeface="Be Vietnam Pro" pitchFamily="34" charset="-122"/>
                 <a:cs typeface="Be Vietnam Pro" pitchFamily="34" charset="-120"/>
               </a:rPr>
-              <a:t> và</a:t>
-            </a:r>
-            <a:r>
-              <a:rPr lang="en-US" sz="2550" dirty="0" spc="0" kern="0">
+              <a:t> hay</a:t>
+            </a:r>
+            <a:r>
+              <a:rPr lang="en-US" sz="2550" dirty="0" spc="1" kern="0">
                 <a:solidFill>
                   <a:srgbClr val="F3EEE3"/>
                 </a:solidFill>
@@ -4867,18 +4856,7 @@
                 <a:ea typeface="Be Vietnam Pro" pitchFamily="34" charset="-122"/>
                 <a:cs typeface="Be Vietnam Pro" pitchFamily="34" charset="-120"/>
               </a:rPr>
-              <a:t> lớp có</a:t>
-            </a:r>
-            <a:r>
-              <a:rPr lang="en-US" sz="2550" dirty="0" spc="-5" kern="0">
-                <a:solidFill>
-                  <a:srgbClr val="F3EEE3"/>
-                </a:solidFill>
-                <a:latin typeface="Be Vietnam Pro" pitchFamily="34" charset="0"/>
-                <a:ea typeface="Be Vietnam Pro" pitchFamily="34" charset="-122"/>
-                <a:cs typeface="Be Vietnam Pro" pitchFamily="34" charset="-120"/>
-              </a:rPr>
-              <a:t> sẵn.</a:t>
+              <a:t> không.</a:t>
             </a:r>
             <a:endParaRPr lang="en-US" sz="2550" dirty="0"/>
           </a:p>
@@ -5369,6 +5347,105 @@
               <a:buNone/>
             </a:pPr>
             <a:r>
+              <a:rPr lang="en-US" sz="2850" dirty="0" spc="-2" kern="0">
+                <a:solidFill>
+                  <a:srgbClr val="14161C"/>
+                </a:solidFill>
+                <a:latin typeface="Be Vietnam Pro" pitchFamily="34" charset="0"/>
+                <a:ea typeface="Be Vietnam Pro" pitchFamily="34" charset="-122"/>
+                <a:cs typeface="Be Vietnam Pro" pitchFamily="34" charset="-120"/>
+              </a:rPr>
+              <a:t>Collection</a:t>
+            </a:r>
+            <a:r>
+              <a:rPr lang="en-US" sz="2850" dirty="0" spc="2" kern="0">
+                <a:solidFill>
+                  <a:srgbClr val="14161C"/>
+                </a:solidFill>
+                <a:latin typeface="Be Vietnam Pro" pitchFamily="34" charset="0"/>
+                <a:ea typeface="Be Vietnam Pro" pitchFamily="34" charset="-122"/>
+                <a:cs typeface="Be Vietnam Pro" pitchFamily="34" charset="-120"/>
+              </a:rPr>
+              <a:t> là</a:t>
+            </a:r>
+            <a:r>
+              <a:rPr lang="en-US" sz="2850" dirty="0" spc="-1" kern="0">
+                <a:solidFill>
+                  <a:srgbClr val="14161C"/>
+                </a:solidFill>
+                <a:latin typeface="Be Vietnam Pro" pitchFamily="34" charset="0"/>
+                <a:ea typeface="Be Vietnam Pro" pitchFamily="34" charset="-122"/>
+                <a:cs typeface="Be Vietnam Pro" pitchFamily="34" charset="-120"/>
+              </a:rPr>
+              <a:t> hợp</a:t>
+            </a:r>
+            <a:r>
+              <a:rPr lang="en-US" sz="2850" dirty="0" spc="9" kern="0">
+                <a:solidFill>
+                  <a:srgbClr val="14161C"/>
+                </a:solidFill>
+                <a:latin typeface="Be Vietnam Pro" pitchFamily="34" charset="0"/>
+                <a:ea typeface="Be Vietnam Pro" pitchFamily="34" charset="-122"/>
+                <a:cs typeface="Be Vietnam Pro" pitchFamily="34" charset="-120"/>
+              </a:rPr>
+              <a:t> đồng</a:t>
+            </a:r>
+            <a:r>
+              <a:rPr lang="en-US" sz="2850" dirty="0" spc="-1" kern="0">
+                <a:solidFill>
+                  <a:srgbClr val="14161C"/>
+                </a:solidFill>
+                <a:latin typeface="Be Vietnam Pro" pitchFamily="34" charset="0"/>
+                <a:ea typeface="Be Vietnam Pro" pitchFamily="34" charset="-122"/>
+                <a:cs typeface="Be Vietnam Pro" pitchFamily="34" charset="-120"/>
+              </a:rPr>
+              <a:t> chung;</a:t>
+            </a:r>
+            <a:r>
+              <a:rPr lang="en-US" sz="2850" dirty="0" spc="-2" kern="0">
+                <a:solidFill>
+                  <a:srgbClr val="14161C"/>
+                </a:solidFill>
+                <a:latin typeface="Be Vietnam Pro" pitchFamily="34" charset="0"/>
+                <a:ea typeface="Be Vietnam Pro" pitchFamily="34" charset="-122"/>
+                <a:cs typeface="Be Vietnam Pro" pitchFamily="34" charset="-120"/>
+              </a:rPr>
+              <a:t> ba</a:t>
+            </a:r>
+            <a:r>
+              <a:rPr lang="en-US" sz="2850" dirty="0" spc="-18" kern="0">
+                <a:solidFill>
+                  <a:srgbClr val="14161C"/>
+                </a:solidFill>
+                <a:latin typeface="Be Vietnam Pro" pitchFamily="34" charset="0"/>
+                <a:ea typeface="Be Vietnam Pro" pitchFamily="34" charset="-122"/>
+                <a:cs typeface="Be Vietnam Pro" pitchFamily="34" charset="-120"/>
+              </a:rPr>
+              <a:t> interface</a:t>
+            </a:r>
+            <a:r>
+              <a:rPr lang="en-US" sz="2850" dirty="0" spc="2" kern="0">
+                <a:solidFill>
+                  <a:srgbClr val="14161C"/>
+                </a:solidFill>
+                <a:latin typeface="Be Vietnam Pro" pitchFamily="34" charset="0"/>
+                <a:ea typeface="Be Vietnam Pro" pitchFamily="34" charset="-122"/>
+                <a:cs typeface="Be Vietnam Pro" pitchFamily="34" charset="-120"/>
+              </a:rPr>
+              <a:t> con</a:t>
+            </a:r>
+            <a:r>
+              <a:rPr lang="en-US" sz="2850" dirty="0" spc="12" kern="0">
+                <a:solidFill>
+                  <a:srgbClr val="14161C"/>
+                </a:solidFill>
+                <a:latin typeface="Be Vietnam Pro" pitchFamily="34" charset="0"/>
+                <a:ea typeface="Be Vietnam Pro" pitchFamily="34" charset="-122"/>
+                <a:cs typeface="Be Vietnam Pro" pitchFamily="34" charset="-120"/>
+              </a:rPr>
+              <a:t> hứa</a:t>
+            </a:r>
+            <a:r>
               <a:rPr lang="en-US" sz="2850" dirty="0" spc="-3" kern="0">
                 <a:solidFill>
                   <a:srgbClr val="14161C"/>
@@ -5377,7 +5454,117 @@
                 <a:ea typeface="Be Vietnam Pro" pitchFamily="34" charset="-122"/>
                 <a:cs typeface="Be Vietnam Pro" pitchFamily="34" charset="-120"/>
               </a:rPr>
-              <a:t>Các</a:t>
+              <a:t> ba</a:t>
+            </a:r>
+            <a:r>
+              <a:rPr lang="en-US" sz="2850" dirty="0" spc="24" kern="0">
+                <a:solidFill>
+                  <a:srgbClr val="14161C"/>
+                </a:solidFill>
+                <a:latin typeface="Be Vietnam Pro" pitchFamily="34" charset="0"/>
+                <a:ea typeface="Be Vietnam Pro" pitchFamily="34" charset="-122"/>
+                <a:cs typeface="Be Vietnam Pro" pitchFamily="34" charset="-120"/>
+              </a:rPr>
+              <a:t> điều</a:t>
+            </a:r>
+            <a:r>
+              <a:rPr lang="en-US" sz="2850" dirty="0" spc="-1" kern="0">
+                <a:solidFill>
+                  <a:srgbClr val="14161C"/>
+                </a:solidFill>
+                <a:latin typeface="Be Vietnam Pro" pitchFamily="34" charset="0"/>
+                <a:ea typeface="Be Vietnam Pro" pitchFamily="34" charset="-122"/>
+                <a:cs typeface="Be Vietnam Pro" pitchFamily="34" charset="-120"/>
+              </a:rPr>
+              <a:t> khác</a:t>
+            </a:r>
+            <a:r>
+              <a:rPr lang="en-US" sz="2850" dirty="0" spc="1" kern="0">
+                <a:solidFill>
+                  <a:srgbClr val="14161C"/>
+                </a:solidFill>
+                <a:latin typeface="Be Vietnam Pro" pitchFamily="34" charset="0"/>
+                <a:ea typeface="Be Vietnam Pro" pitchFamily="34" charset="-122"/>
+                <a:cs typeface="Be Vietnam Pro" pitchFamily="34" charset="-120"/>
+              </a:rPr>
+              <a:t> nhau</a:t>
+            </a:r>
+            <a:r>
+              <a:rPr lang="en-US" sz="2850" dirty="0" spc="-17" kern="0">
+                <a:solidFill>
+                  <a:srgbClr val="14161C"/>
+                </a:solidFill>
+                <a:latin typeface="Be Vietnam Pro" pitchFamily="34" charset="0"/>
+                <a:ea typeface="Be Vietnam Pro" pitchFamily="34" charset="-122"/>
+                <a:cs typeface="Be Vietnam Pro" pitchFamily="34" charset="-120"/>
+              </a:rPr>
+              <a:t> về</a:t>
+            </a:r>
+            <a:r>
+              <a:rPr lang="en-US" sz="2850" dirty="0" spc="3" kern="0">
+                <a:solidFill>
+                  <a:srgbClr val="14161C"/>
+                </a:solidFill>
+                <a:latin typeface="Be Vietnam Pro" pitchFamily="34" charset="0"/>
+                <a:ea typeface="Be Vietnam Pro" pitchFamily="34" charset="-122"/>
+                <a:cs typeface="Be Vietnam Pro" pitchFamily="34" charset="-120"/>
+              </a:rPr>
+              <a:t> vị</a:t>
+            </a:r>
+            <a:r>
+              <a:rPr lang="en-US" sz="2850" dirty="0" spc="13" kern="0">
+                <a:solidFill>
+                  <a:srgbClr val="14161C"/>
+                </a:solidFill>
+                <a:latin typeface="Be Vietnam Pro" pitchFamily="34" charset="0"/>
+                <a:ea typeface="Be Vietnam Pro" pitchFamily="34" charset="-122"/>
+                <a:cs typeface="Be Vietnam Pro" pitchFamily="34" charset="-120"/>
+              </a:rPr>
+              <a:t> trí,</a:t>
+            </a:r>
+            <a:r>
+              <a:rPr lang="en-US" sz="2850" dirty="0" spc="-2" kern="0">
+                <a:solidFill>
+                  <a:srgbClr val="14161C"/>
+                </a:solidFill>
+                <a:latin typeface="Be Vietnam Pro" pitchFamily="34" charset="0"/>
+                <a:ea typeface="Be Vietnam Pro" pitchFamily="34" charset="-122"/>
+                <a:cs typeface="Be Vietnam Pro" pitchFamily="34" charset="-120"/>
+              </a:rPr>
+              <a:t> trùng</a:t>
+            </a:r>
+            <a:r>
+              <a:rPr lang="en-US" sz="2850" dirty="0" spc="1" kern="0">
+                <a:solidFill>
+                  <a:srgbClr val="14161C"/>
+                </a:solidFill>
+                <a:latin typeface="Be Vietnam Pro" pitchFamily="34" charset="0"/>
+                <a:ea typeface="Be Vietnam Pro" pitchFamily="34" charset="-122"/>
+                <a:cs typeface="Be Vietnam Pro" pitchFamily="34" charset="-120"/>
+              </a:rPr>
+              <a:t> lặp</a:t>
+            </a:r>
+            <a:r>
+              <a:rPr lang="en-US" sz="2850" dirty="0" spc="-16" kern="0">
+                <a:solidFill>
+                  <a:srgbClr val="14161C"/>
+                </a:solidFill>
+                <a:latin typeface="Be Vietnam Pro" pitchFamily="34" charset="0"/>
+                <a:ea typeface="Be Vietnam Pro" pitchFamily="34" charset="-122"/>
+                <a:cs typeface="Be Vietnam Pro" pitchFamily="34" charset="-120"/>
+              </a:rPr>
+              <a:t> và</a:t>
+            </a:r>
+            <a:r>
+              <a:rPr lang="en-US" sz="2850" dirty="0" spc="-1" kern="0">
+                <a:solidFill>
+                  <a:srgbClr val="14161C"/>
+                </a:solidFill>
+                <a:latin typeface="Be Vietnam Pro" pitchFamily="34" charset="0"/>
+                <a:ea typeface="Be Vietnam Pro" pitchFamily="34" charset="-122"/>
+                <a:cs typeface="Be Vietnam Pro" pitchFamily="34" charset="-120"/>
+              </a:rPr>
+              <a:t> thứ</a:t>
             </a:r>
             <a:r>
               <a:rPr lang="en-US" sz="2850" dirty="0" spc="0" kern="0">
@@ -5388,172 +5575,7 @@
                 <a:ea typeface="Be Vietnam Pro" pitchFamily="34" charset="-122"/>
                 <a:cs typeface="Be Vietnam Pro" pitchFamily="34" charset="-120"/>
               </a:rPr>
-              <a:t> kiểu</a:t>
-            </a:r>
-            <a:r>
-              <a:rPr lang="en-US" sz="2850" dirty="0" spc="-15" kern="0">
-                <a:solidFill>
-                  <a:srgbClr val="14161C"/>
-                </a:solidFill>
-                <a:latin typeface="Be Vietnam Pro" pitchFamily="34" charset="0"/>
-                <a:ea typeface="Be Vietnam Pro" pitchFamily="34" charset="-122"/>
-                <a:cs typeface="Be Vietnam Pro" pitchFamily="34" charset="-120"/>
-              </a:rPr>
-              <a:t> tập</a:t>
-            </a:r>
-            <a:r>
-              <a:rPr lang="en-US" sz="2850" dirty="0" spc="-1" kern="0">
-                <a:solidFill>
-                  <a:srgbClr val="14161C"/>
-                </a:solidFill>
-                <a:latin typeface="Be Vietnam Pro" pitchFamily="34" charset="0"/>
-                <a:ea typeface="Be Vietnam Pro" pitchFamily="34" charset="-122"/>
-                <a:cs typeface="Be Vietnam Pro" pitchFamily="34" charset="-120"/>
-              </a:rPr>
-              <a:t> hợp</a:t>
-            </a:r>
-            <a:r>
-              <a:rPr lang="en-US" sz="2850" dirty="0" spc="-19" kern="0">
-                <a:solidFill>
-                  <a:srgbClr val="14161C"/>
-                </a:solidFill>
-                <a:latin typeface="Be Vietnam Pro" pitchFamily="34" charset="0"/>
-                <a:ea typeface="Be Vietnam Pro" pitchFamily="34" charset="-122"/>
-                <a:cs typeface="Be Vietnam Pro" pitchFamily="34" charset="-120"/>
-              </a:rPr>
-              <a:t> trong Java</a:t>
-            </a:r>
-            <a:r>
-              <a:rPr lang="en-US" sz="2850" dirty="0" spc="-2" kern="0">
-                <a:solidFill>
-                  <a:srgbClr val="14161C"/>
-                </a:solidFill>
-                <a:latin typeface="Be Vietnam Pro" pitchFamily="34" charset="0"/>
-                <a:ea typeface="Be Vietnam Pro" pitchFamily="34" charset="-122"/>
-                <a:cs typeface="Be Vietnam Pro" pitchFamily="34" charset="-120"/>
-              </a:rPr>
-              <a:t> cùng</a:t>
-            </a:r>
-            <a:r>
-              <a:rPr lang="en-US" sz="2850" dirty="0" spc="-10" kern="0">
-                <a:solidFill>
-                  <a:srgbClr val="14161C"/>
-                </a:solidFill>
-                <a:latin typeface="Be Vietnam Pro" pitchFamily="34" charset="0"/>
-                <a:ea typeface="Be Vietnam Pro" pitchFamily="34" charset="-122"/>
-                <a:cs typeface="Be Vietnam Pro" pitchFamily="34" charset="-120"/>
-              </a:rPr>
-              <a:t> xuất</a:t>
-            </a:r>
-            <a:r>
-              <a:rPr lang="en-US" sz="2850" dirty="0" spc="-13" kern="0">
-                <a:solidFill>
-                  <a:srgbClr val="14161C"/>
-                </a:solidFill>
-                <a:latin typeface="Be Vietnam Pro" pitchFamily="34" charset="0"/>
-                <a:ea typeface="Be Vietnam Pro" pitchFamily="34" charset="-122"/>
-                <a:cs typeface="Be Vietnam Pro" pitchFamily="34" charset="-120"/>
-              </a:rPr>
-              <a:t> phát</a:t>
-            </a:r>
-            <a:r>
-              <a:rPr lang="en-US" sz="2850" dirty="0" spc="-1" kern="0">
-                <a:solidFill>
-                  <a:srgbClr val="14161C"/>
-                </a:solidFill>
-                <a:latin typeface="Be Vietnam Pro" pitchFamily="34" charset="0"/>
-                <a:ea typeface="Be Vietnam Pro" pitchFamily="34" charset="-122"/>
-                <a:cs typeface="Be Vietnam Pro" pitchFamily="34" charset="-120"/>
-              </a:rPr>
-              <a:t> từ</a:t>
-            </a:r>
-            <a:r>
-              <a:rPr lang="en-US" sz="2850" dirty="0" spc="-18" kern="0">
-                <a:solidFill>
-                  <a:srgbClr val="14161C"/>
-                </a:solidFill>
-                <a:latin typeface="Be Vietnam Pro" pitchFamily="34" charset="0"/>
-                <a:ea typeface="Be Vietnam Pro" pitchFamily="34" charset="-122"/>
-                <a:cs typeface="Be Vietnam Pro" pitchFamily="34" charset="-120"/>
-              </a:rPr>
-              <a:t> interface</a:t>
-            </a:r>
-            <a:r>
-              <a:rPr lang="en-US" sz="2850" dirty="0" spc="-1" kern="0">
-                <a:solidFill>
-                  <a:srgbClr val="14161C"/>
-                </a:solidFill>
-                <a:latin typeface="Be Vietnam Pro" pitchFamily="34" charset="0"/>
-                <a:ea typeface="Be Vietnam Pro" pitchFamily="34" charset="-122"/>
-                <a:cs typeface="Be Vietnam Pro" pitchFamily="34" charset="-120"/>
-              </a:rPr>
-              <a:t> Collection,</a:t>
-            </a:r>
-            <a:r>
-              <a:rPr lang="en-US" sz="2850" dirty="0" spc="-26" kern="0">
-                <a:solidFill>
-                  <a:srgbClr val="14161C"/>
-                </a:solidFill>
-                <a:latin typeface="Be Vietnam Pro" pitchFamily="34" charset="0"/>
-                <a:ea typeface="Be Vietnam Pro" pitchFamily="34" charset="-122"/>
-                <a:cs typeface="Be Vietnam Pro" pitchFamily="34" charset="-120"/>
-              </a:rPr>
-              <a:t> rồi</a:t>
-            </a:r>
-            <a:r>
-              <a:rPr lang="en-US" sz="2850" dirty="0" spc="-13" kern="0">
-                <a:solidFill>
-                  <a:srgbClr val="14161C"/>
-                </a:solidFill>
-                <a:latin typeface="Be Vietnam Pro" pitchFamily="34" charset="0"/>
-                <a:ea typeface="Be Vietnam Pro" pitchFamily="34" charset="-122"/>
-                <a:cs typeface="Be Vietnam Pro" pitchFamily="34" charset="-120"/>
-              </a:rPr>
-              <a:t> tách</a:t>
-            </a:r>
-            <a:r>
-              <a:rPr lang="en-US" sz="2850" dirty="0" spc="-1" kern="0">
-                <a:solidFill>
-                  <a:srgbClr val="14161C"/>
-                </a:solidFill>
-                <a:latin typeface="Be Vietnam Pro" pitchFamily="34" charset="0"/>
-                <a:ea typeface="Be Vietnam Pro" pitchFamily="34" charset="-122"/>
-                <a:cs typeface="Be Vietnam Pro" pitchFamily="34" charset="-120"/>
-              </a:rPr>
-              <a:t> thành</a:t>
-            </a:r>
-            <a:r>
-              <a:rPr lang="en-US" sz="2850" dirty="0" spc="-3" kern="0">
-                <a:solidFill>
-                  <a:srgbClr val="14161C"/>
-                </a:solidFill>
-                <a:latin typeface="Be Vietnam Pro" pitchFamily="34" charset="0"/>
-                <a:ea typeface="Be Vietnam Pro" pitchFamily="34" charset="-122"/>
-                <a:cs typeface="Be Vietnam Pro" pitchFamily="34" charset="-120"/>
-              </a:rPr>
-              <a:t> ba</a:t>
-            </a:r>
-            <a:r>
-              <a:rPr lang="en-US" sz="2850" dirty="0" spc="-1" kern="0">
-                <a:solidFill>
-                  <a:srgbClr val="14161C"/>
-                </a:solidFill>
-                <a:latin typeface="Be Vietnam Pro" pitchFamily="34" charset="0"/>
-                <a:ea typeface="Be Vietnam Pro" pitchFamily="34" charset="-122"/>
-                <a:cs typeface="Be Vietnam Pro" pitchFamily="34" charset="-120"/>
-              </a:rPr>
-              <a:t> nhánh</a:t>
-            </a:r>
-            <a:r>
-              <a:rPr lang="en-US" sz="2850" dirty="0" spc="0" kern="0">
-                <a:solidFill>
-                  <a:srgbClr val="14161C"/>
-                </a:solidFill>
-                <a:latin typeface="Be Vietnam Pro" pitchFamily="34" charset="0"/>
-                <a:ea typeface="Be Vietnam Pro" pitchFamily="34" charset="-122"/>
-                <a:cs typeface="Be Vietnam Pro" pitchFamily="34" charset="-120"/>
-              </a:rPr>
-              <a:t> chính.</a:t>
+              <a:t> tự.</a:t>
             </a:r>
             <a:endParaRPr lang="en-US" sz="2850" dirty="0"/>
           </a:p>
@@ -5659,6 +5681,17 @@
               <a:buNone/>
             </a:pPr>
             <a:r>
+              <a:rPr lang="en-US" sz="2850" b="1" dirty="0" spc="-4" kern="0">
+                <a:solidFill>
+                  <a:srgbClr val="14161C"/>
+                </a:solidFill>
+                <a:latin typeface="Be Vietnam Pro" pitchFamily="34" charset="0"/>
+                <a:ea typeface="Be Vietnam Pro" pitchFamily="34" charset="-122"/>
+                <a:cs typeface="Be Vietnam Pro" pitchFamily="34" charset="-120"/>
+              </a:rPr>
+              <a:t>Đọc</a:t>
+            </a:r>
+            <a:r>
               <a:rPr lang="en-US" sz="2850" b="1" dirty="0" spc="-9" kern="0">
                 <a:solidFill>
                   <a:srgbClr val="14161C"/>
@@ -5667,7 +5700,73 @@
                 <a:ea typeface="Be Vietnam Pro" pitchFamily="34" charset="-122"/>
                 <a:cs typeface="Be Vietnam Pro" pitchFamily="34" charset="-120"/>
               </a:rPr>
-              <a:t>Chọn</a:t>
+              <a:t> cây</a:t>
+            </a:r>
+            <a:r>
+              <a:rPr lang="en-US" sz="2850" b="1" dirty="0" spc="1" kern="0">
+                <a:solidFill>
+                  <a:srgbClr val="14161C"/>
+                </a:solidFill>
+                <a:latin typeface="Be Vietnam Pro" pitchFamily="34" charset="0"/>
+                <a:ea typeface="Be Vietnam Pro" pitchFamily="34" charset="-122"/>
+                <a:cs typeface="Be Vietnam Pro" pitchFamily="34" charset="-120"/>
+              </a:rPr>
+              <a:t> như</a:t>
+            </a:r>
+            <a:r>
+              <a:rPr lang="en-US" sz="2850" b="1" dirty="0" spc="-2" kern="0">
+                <a:solidFill>
+                  <a:srgbClr val="14161C"/>
+                </a:solidFill>
+                <a:latin typeface="Be Vietnam Pro" pitchFamily="34" charset="0"/>
+                <a:ea typeface="Be Vietnam Pro" pitchFamily="34" charset="-122"/>
+                <a:cs typeface="Be Vietnam Pro" pitchFamily="34" charset="-120"/>
+              </a:rPr>
+              <a:t> bộ</a:t>
+            </a:r>
+            <a:r>
+              <a:rPr lang="en-US" sz="2850" b="1" dirty="0" spc="-3" kern="0">
+                <a:solidFill>
+                  <a:srgbClr val="14161C"/>
+                </a:solidFill>
+                <a:latin typeface="Be Vietnam Pro" pitchFamily="34" charset="0"/>
+                <a:ea typeface="Be Vietnam Pro" pitchFamily="34" charset="-122"/>
+                <a:cs typeface="Be Vietnam Pro" pitchFamily="34" charset="-120"/>
+              </a:rPr>
+              <a:t> hợp</a:t>
+            </a:r>
+            <a:r>
+              <a:rPr lang="en-US" sz="2850" b="1" dirty="0" spc="0" kern="0">
+                <a:solidFill>
+                  <a:srgbClr val="14161C"/>
+                </a:solidFill>
+                <a:latin typeface="Be Vietnam Pro" pitchFamily="34" charset="0"/>
+                <a:ea typeface="Be Vietnam Pro" pitchFamily="34" charset="-122"/>
+                <a:cs typeface="Be Vietnam Pro" pitchFamily="34" charset="-120"/>
+              </a:rPr>
+              <a:t> đồng</a:t>
+            </a:r>
+            <a:r>
+              <a:rPr lang="en-US" sz="2850" b="1" dirty="0" spc="10" kern="0">
+                <a:solidFill>
+                  <a:srgbClr val="14161C"/>
+                </a:solidFill>
+                <a:latin typeface="Be Vietnam Pro" pitchFamily="34" charset="0"/>
+                <a:ea typeface="Be Vietnam Pro" pitchFamily="34" charset="-122"/>
+                <a:cs typeface="Be Vietnam Pro" pitchFamily="34" charset="-120"/>
+              </a:rPr>
+              <a:t> để</a:t>
+            </a:r>
+            <a:r>
+              <a:rPr lang="en-US" sz="2850" b="1" dirty="0" spc="-5" kern="0">
+                <a:solidFill>
+                  <a:srgbClr val="14161C"/>
+                </a:solidFill>
+                <a:latin typeface="Be Vietnam Pro" pitchFamily="34" charset="0"/>
+                <a:ea typeface="Be Vietnam Pro" pitchFamily="34" charset="-122"/>
+                <a:cs typeface="Be Vietnam Pro" pitchFamily="34" charset="-120"/>
+              </a:rPr>
+              <a:t> chọn</a:t>
             </a:r>
             <a:r>
               <a:rPr lang="en-US" sz="2850" b="1" dirty="0" spc="-1" kern="0">
@@ -5681,7 +5780,7 @@
               <a:t> đúng</a:t>
             </a:r>
             <a:r>
-              <a:rPr lang="en-US" sz="2850" b="1" dirty="0" spc="3" kern="0">
+              <a:rPr lang="en-US" sz="2850" b="1" dirty="0" spc="2" kern="0">
                 <a:solidFill>
                   <a:srgbClr val="14161C"/>
                 </a:solidFill>
@@ -5689,84 +5788,7 @@
                 <a:ea typeface="Be Vietnam Pro" pitchFamily="34" charset="-122"/>
                 <a:cs typeface="Be Vietnam Pro" pitchFamily="34" charset="-120"/>
               </a:rPr>
-              <a:t> cấu</a:t>
-            </a:r>
-            <a:r>
-              <a:rPr lang="en-US" sz="2850" b="1" dirty="0" spc="2" kern="0">
-                <a:solidFill>
-                  <a:srgbClr val="14161C"/>
-                </a:solidFill>
-                <a:latin typeface="Be Vietnam Pro" pitchFamily="34" charset="0"/>
-                <a:ea typeface="Be Vietnam Pro" pitchFamily="34" charset="-122"/>
-                <a:cs typeface="Be Vietnam Pro" pitchFamily="34" charset="-120"/>
-              </a:rPr>
-              <a:t> trúc</a:t>
-            </a:r>
-            <a:r>
-              <a:rPr lang="en-US" sz="2850" b="1" dirty="0" spc="3" kern="0">
-                <a:solidFill>
-                  <a:srgbClr val="14161C"/>
-                </a:solidFill>
-                <a:latin typeface="Be Vietnam Pro" pitchFamily="34" charset="0"/>
-                <a:ea typeface="Be Vietnam Pro" pitchFamily="34" charset="-122"/>
-                <a:cs typeface="Be Vietnam Pro" pitchFamily="34" charset="-120"/>
-              </a:rPr>
-              <a:t> dữ</a:t>
-            </a:r>
-            <a:r>
-              <a:rPr lang="en-US" sz="2850" b="1" dirty="0" spc="1" kern="0">
-                <a:solidFill>
-                  <a:srgbClr val="14161C"/>
-                </a:solidFill>
-                <a:latin typeface="Be Vietnam Pro" pitchFamily="34" charset="0"/>
-                <a:ea typeface="Be Vietnam Pro" pitchFamily="34" charset="-122"/>
-                <a:cs typeface="Be Vietnam Pro" pitchFamily="34" charset="-120"/>
-              </a:rPr>
-              <a:t> liệu</a:t>
-            </a:r>
-            <a:r>
-              <a:rPr lang="en-US" sz="2850" b="1" dirty="0" spc="-2" kern="0">
-                <a:solidFill>
-                  <a:srgbClr val="14161C"/>
-                </a:solidFill>
-                <a:latin typeface="Be Vietnam Pro" pitchFamily="34" charset="0"/>
-                <a:ea typeface="Be Vietnam Pro" pitchFamily="34" charset="-122"/>
-                <a:cs typeface="Be Vietnam Pro" pitchFamily="34" charset="-120"/>
-              </a:rPr>
-              <a:t> cho</a:t>
-            </a:r>
-            <a:r>
-              <a:rPr lang="en-US" sz="2850" b="1" dirty="0" spc="28" kern="0">
-                <a:solidFill>
-                  <a:srgbClr val="14161C"/>
-                </a:solidFill>
-                <a:latin typeface="Be Vietnam Pro" pitchFamily="34" charset="0"/>
-                <a:ea typeface="Be Vietnam Pro" pitchFamily="34" charset="-122"/>
-                <a:cs typeface="Be Vietnam Pro" pitchFamily="34" charset="-120"/>
-              </a:rPr>
-              <a:t> từng</a:t>
-            </a:r>
-            <a:r>
-              <a:rPr lang="en-US" sz="2850" b="1" dirty="0" spc="3" kern="0">
-                <a:solidFill>
-                  <a:srgbClr val="14161C"/>
-                </a:solidFill>
-                <a:latin typeface="Be Vietnam Pro" pitchFamily="34" charset="0"/>
-                <a:ea typeface="Be Vietnam Pro" pitchFamily="34" charset="-122"/>
-                <a:cs typeface="Be Vietnam Pro" pitchFamily="34" charset="-120"/>
-              </a:rPr>
-              <a:t> bài</a:t>
-            </a:r>
-            <a:r>
-              <a:rPr lang="en-US" sz="2850" b="1" dirty="0" spc="-2" kern="0">
-                <a:solidFill>
-                  <a:srgbClr val="14161C"/>
-                </a:solidFill>
-                <a:latin typeface="Be Vietnam Pro" pitchFamily="34" charset="0"/>
-                <a:ea typeface="Be Vietnam Pro" pitchFamily="34" charset="-122"/>
-                <a:cs typeface="Be Vietnam Pro" pitchFamily="34" charset="-120"/>
-              </a:rPr>
-              <a:t> toán.</a:t>
+              <a:t> kiểu.</a:t>
             </a:r>
             <a:endParaRPr lang="en-US" sz="2850" dirty="0"/>
           </a:p>
@@ -5835,7 +5857,7 @@
               <a:t>CHỌN</a:t>
             </a:r>
             <a:r>
-              <a:rPr lang="en-US" sz="1800" b="1" spc="204" kern="0" dirty="0">
+              <a:rPr lang="en-US" sz="1800" b="1" spc="223" kern="0" dirty="0">
                 <a:solidFill>
                   <a:srgbClr val="6B6A66"/>
                 </a:solidFill>
@@ -5843,10 +5865,10 @@
                 <a:ea typeface="Be Vietnam Pro" pitchFamily="34" charset="-122"/>
                 <a:cs typeface="Be Vietnam Pro" pitchFamily="34" charset="-120"/>
               </a:rPr>
-              <a:t> MỘT</a:t>
-            </a:r>
-            <a:r>
-              <a:rPr lang="en-US" sz="1800" b="1" spc="214" kern="0" dirty="0">
+              <a:t> THEO</a:t>
+            </a:r>
+            <a:r>
+              <a:rPr lang="en-US" sz="1800" b="1" spc="203" kern="0" dirty="0">
                 <a:solidFill>
                   <a:srgbClr val="6B6A66"/>
                 </a:solidFill>
@@ -5854,10 +5876,10 @@
                 <a:ea typeface="Be Vietnam Pro" pitchFamily="34" charset="-122"/>
                 <a:cs typeface="Be Vietnam Pro" pitchFamily="34" charset="-120"/>
               </a:rPr>
-              <a:t> TRONG</a:t>
-            </a:r>
-            <a:r>
-              <a:rPr lang="en-US" sz="1800" b="1" spc="219" kern="0" dirty="0">
+              <a:t> LỜI</a:t>
+            </a:r>
+            <a:r>
+              <a:rPr lang="en-US" sz="1800" b="1" spc="227" kern="0" dirty="0">
                 <a:solidFill>
                   <a:srgbClr val="6B6A66"/>
                 </a:solidFill>
@@ -5865,18 +5887,7 @@
                 <a:ea typeface="Be Vietnam Pro" pitchFamily="34" charset="-122"/>
                 <a:cs typeface="Be Vietnam Pro" pitchFamily="34" charset="-120"/>
               </a:rPr>
-              <a:t> BA</a:t>
-            </a:r>
-            <a:r>
-              <a:rPr lang="en-US" sz="1800" b="1" spc="226" kern="0" dirty="0">
-                <a:solidFill>
-                  <a:srgbClr val="6B6A66"/>
-                </a:solidFill>
-                <a:latin typeface="Be Vietnam Pro" pitchFamily="34" charset="0"/>
-                <a:ea typeface="Be Vietnam Pro" pitchFamily="34" charset="-122"/>
-                <a:cs typeface="Be Vietnam Pro" pitchFamily="34" charset="-120"/>
-              </a:rPr>
-              <a:t> NHÁNH</a:t>
+              <a:t> HỨA</a:t>
             </a:r>
             <a:endParaRPr lang="en-US" sz="1800" dirty="0"/>
           </a:p>
@@ -6135,10 +6146,10 @@
                 <a:ea typeface="Be Vietnam Pro" pitchFamily="34" charset="-122"/>
                 <a:cs typeface="Be Vietnam Pro" pitchFamily="34" charset="-120"/>
               </a:rPr>
-              <a:t>thứ</a:t>
-            </a:r>
-            <a:r>
-              <a:rPr lang="en-US" sz="2100" dirty="0" spc="-1" kern="0">
+              <a:t>vị</a:t>
+            </a:r>
+            <a:r>
+              <a:rPr lang="en-US" sz="2100" dirty="0" spc="10" kern="0">
                 <a:solidFill>
                   <a:srgbClr val="14161C"/>
                 </a:solidFill>
@@ -6146,10 +6157,10 @@
                 <a:ea typeface="Be Vietnam Pro" pitchFamily="34" charset="-122"/>
                 <a:cs typeface="Be Vietnam Pro" pitchFamily="34" charset="-120"/>
               </a:rPr>
-              <a:t> tự</a:t>
-            </a:r>
-            <a:r>
-              <a:rPr lang="en-US" sz="2100" dirty="0" spc="-5" kern="0">
+              <a:t> trí</a:t>
+            </a:r>
+            <a:r>
+              <a:rPr lang="en-US" sz="2100" dirty="0" spc="-18" kern="0">
                 <a:solidFill>
                   <a:srgbClr val="14161C"/>
                 </a:solidFill>
@@ -6157,7 +6168,7 @@
                 <a:ea typeface="Be Vietnam Pro" pitchFamily="34" charset="-122"/>
                 <a:cs typeface="Be Vietnam Pro" pitchFamily="34" charset="-120"/>
               </a:rPr>
-              <a:t> theo</a:t>
+              <a:t> và</a:t>
             </a:r>
             <a:r>
               <a:rPr lang="en-US" sz="2100" dirty="0" spc="0" kern="0">
@@ -6168,10 +6179,10 @@
                 <a:ea typeface="Be Vietnam Pro" pitchFamily="34" charset="-122"/>
                 <a:cs typeface="Be Vietnam Pro" pitchFamily="34" charset="-120"/>
               </a:rPr>
-              <a:t> vị</a:t>
-            </a:r>
-            <a:r>
-              <a:rPr lang="en-US" sz="2100" dirty="0" spc="7" kern="0">
+              <a:t> chỉ</a:t>
+            </a:r>
+            <a:r>
+              <a:rPr lang="en-US" sz="2100" dirty="0" spc="-9" kern="0">
                 <a:solidFill>
                   <a:srgbClr val="14161C"/>
                 </a:solidFill>
@@ -6179,40 +6190,7 @@
                 <a:ea typeface="Be Vietnam Pro" pitchFamily="34" charset="-122"/>
                 <a:cs typeface="Be Vietnam Pro" pitchFamily="34" charset="-120"/>
               </a:rPr>
-              <a:t> trí,</a:t>
-            </a:r>
-            <a:r>
-              <a:rPr lang="en-US" sz="2100" dirty="0" spc="3" kern="0">
-                <a:solidFill>
-                  <a:srgbClr val="14161C"/>
-                </a:solidFill>
-                <a:latin typeface="Be Vietnam Pro" pitchFamily="34" charset="0"/>
-                <a:ea typeface="Be Vietnam Pro" pitchFamily="34" charset="-122"/>
-                <a:cs typeface="Be Vietnam Pro" pitchFamily="34" charset="-120"/>
-              </a:rPr>
-              <a:t> thường</a:t>
-            </a:r>
-            <a:r>
-              <a:rPr lang="en-US" sz="2100" dirty="0" spc="-2" kern="0">
-                <a:solidFill>
-                  <a:srgbClr val="14161C"/>
-                </a:solidFill>
-                <a:latin typeface="Be Vietnam Pro" pitchFamily="34" charset="0"/>
-                <a:ea typeface="Be Vietnam Pro" pitchFamily="34" charset="-122"/>
-                <a:cs typeface="Be Vietnam Pro" pitchFamily="34" charset="-120"/>
-              </a:rPr>
-              <a:t> cho phép</a:t>
-            </a:r>
-            <a:r>
-              <a:rPr lang="en-US" sz="2100" dirty="0" spc="0" kern="0">
-                <a:solidFill>
-                  <a:srgbClr val="14161C"/>
-                </a:solidFill>
-                <a:latin typeface="Be Vietnam Pro" pitchFamily="34" charset="0"/>
-                <a:ea typeface="Be Vietnam Pro" pitchFamily="34" charset="-122"/>
-                <a:cs typeface="Be Vietnam Pro" pitchFamily="34" charset="-120"/>
-              </a:rPr>
-              <a:t> trùng</a:t>
+              <a:t> số</a:t>
             </a:r>
             <a:endParaRPr lang="en-US" sz="2100" dirty="0"/>
           </a:p>
@@ -6323,7 +6301,7 @@
               <a:t>không</a:t>
             </a:r>
             <a:r>
-              <a:rPr lang="en-US" sz="2100" dirty="0" spc="6" kern="0">
+              <a:rPr lang="en-US" sz="2100" dirty="0" spc="-3" kern="0">
                 <a:solidFill>
                   <a:srgbClr val="14161C"/>
                 </a:solidFill>
@@ -6331,10 +6309,10 @@
                 <a:ea typeface="Be Vietnam Pro" pitchFamily="34" charset="-122"/>
                 <a:cs typeface="Be Vietnam Pro" pitchFamily="34" charset="-120"/>
               </a:rPr>
-              <a:t> chứa</a:t>
-            </a:r>
-            <a:r>
-              <a:rPr lang="en-US" sz="2100" dirty="0" spc="-3" kern="0">
+              <a:t> có</a:t>
+            </a:r>
+            <a:r>
+              <a:rPr lang="en-US" sz="2100" dirty="0" spc="-1" kern="0">
                 <a:solidFill>
                   <a:srgbClr val="14161C"/>
                 </a:solidFill>
@@ -6342,10 +6320,21 @@
                 <a:ea typeface="Be Vietnam Pro" pitchFamily="34" charset="-122"/>
                 <a:cs typeface="Be Vietnam Pro" pitchFamily="34" charset="-120"/>
               </a:rPr>
+              <a:t> hai</a:t>
+            </a:r>
+            <a:r>
+              <a:rPr lang="en-US" sz="2100" dirty="0" spc="-2" kern="0">
+                <a:solidFill>
+                  <a:srgbClr val="14161C"/>
+                </a:solidFill>
+                <a:latin typeface="Be Vietnam Pro" pitchFamily="34" charset="0"/>
+                <a:ea typeface="Be Vietnam Pro" pitchFamily="34" charset="-122"/>
+                <a:cs typeface="Be Vietnam Pro" pitchFamily="34" charset="-120"/>
+              </a:rPr>
               <a:t> phần</a:t>
             </a:r>
             <a:r>
-              <a:rPr lang="en-US" sz="2100" dirty="0" spc="0" kern="0">
+              <a:rPr lang="en-US" sz="2100" dirty="0" spc="-1" kern="0">
                 <a:solidFill>
                   <a:srgbClr val="14161C"/>
                 </a:solidFill>
@@ -6353,7 +6342,29 @@
                 <a:ea typeface="Be Vietnam Pro" pitchFamily="34" charset="-122"/>
                 <a:cs typeface="Be Vietnam Pro" pitchFamily="34" charset="-120"/>
               </a:rPr>
-              <a:t> tử trùng</a:t>
+              <a:t> tử</a:t>
+            </a:r>
+            <a:r>
+              <a:rPr lang="en-US" sz="2100" dirty="0" spc="-4" kern="0">
+                <a:solidFill>
+                  <a:srgbClr val="14161C"/>
+                </a:solidFill>
+                <a:latin typeface="Be Vietnam Pro" pitchFamily="34" charset="0"/>
+                <a:ea typeface="Be Vietnam Pro" pitchFamily="34" charset="-122"/>
+                <a:cs typeface="Be Vietnam Pro" pitchFamily="34" charset="-120"/>
+              </a:rPr>
+              <a:t> bằng</a:t>
+            </a:r>
+            <a:r>
+              <a:rPr lang="en-US" sz="2100" dirty="0" spc="-1" kern="0">
+                <a:solidFill>
+                  <a:srgbClr val="14161C"/>
+                </a:solidFill>
+                <a:latin typeface="Be Vietnam Pro" pitchFamily="34" charset="0"/>
+                <a:ea typeface="Be Vietnam Pro" pitchFamily="34" charset="-122"/>
+                <a:cs typeface="Be Vietnam Pro" pitchFamily="34" charset="-120"/>
+              </a:rPr>
+              <a:t> nhau</a:t>
             </a:r>
             <a:endParaRPr lang="en-US" sz="2100" dirty="0"/>
           </a:p>
@@ -7267,7 +7278,7 @@
               <a:buNone/>
             </a:pPr>
             <a:r>
-              <a:rPr lang="en-US" sz="2100" b="1" dirty="0" spc="-15" kern="0">
+              <a:rPr lang="en-US" sz="2100" b="1" dirty="0" spc="-18" kern="0">
                 <a:solidFill>
                   <a:srgbClr val="14161C"/>
                 </a:solidFill>
@@ -7275,7 +7286,29 @@
                 <a:ea typeface="Be Vietnam Pro" pitchFamily="34" charset="-122"/>
                 <a:cs typeface="Be Vietnam Pro" pitchFamily="34" charset="-120"/>
               </a:rPr>
-              <a:t>iterator</a:t>
+              <a:t>duyệt</a:t>
+            </a:r>
+            <a:r>
+              <a:rPr lang="en-US" sz="2100" b="1" dirty="0" spc="1" kern="0">
+                <a:solidFill>
+                  <a:srgbClr val="14161C"/>
+                </a:solidFill>
+                <a:latin typeface="Be Vietnam Pro" pitchFamily="34" charset="0"/>
+                <a:ea typeface="Be Vietnam Pro" pitchFamily="34" charset="-122"/>
+                <a:cs typeface="Be Vietnam Pro" pitchFamily="34" charset="-120"/>
+              </a:rPr>
+              <a:t> tuần</a:t>
+            </a:r>
+            <a:r>
+              <a:rPr lang="en-US" sz="2100" b="1" dirty="0" spc="-4" kern="0">
+                <a:solidFill>
+                  <a:srgbClr val="14161C"/>
+                </a:solidFill>
+                <a:latin typeface="Be Vietnam Pro" pitchFamily="34" charset="0"/>
+                <a:ea typeface="Be Vietnam Pro" pitchFamily="34" charset="-122"/>
+                <a:cs typeface="Be Vietnam Pro" pitchFamily="34" charset="-120"/>
+              </a:rPr>
+              <a:t> tự</a:t>
             </a:r>
             <a:endParaRPr lang="en-US" sz="2100" dirty="0"/>
           </a:p>
@@ -8357,7 +8390,7 @@
               <a:t> là</a:t>
             </a:r>
             <a:r>
-              <a:rPr lang="en-US" sz="2700" dirty="0" spc="-15" kern="0">
+              <a:rPr lang="en-US" sz="2700" dirty="0" spc="-3" kern="0">
                 <a:solidFill>
                   <a:srgbClr val="F3EEE3"/>
                 </a:solidFill>
@@ -8365,10 +8398,10 @@
                 <a:ea typeface="Be Vietnam Pro" pitchFamily="34" charset="-122"/>
                 <a:cs typeface="Be Vietnam Pro" pitchFamily="34" charset="-120"/>
               </a:rPr>
-              <a:t> interface</a:t>
-            </a:r>
-            <a:r>
-              <a:rPr lang="en-US" sz="2700" dirty="0" spc="-18" kern="0">
+              <a:t> hợp</a:t>
+            </a:r>
+            <a:r>
+              <a:rPr lang="en-US" sz="2700" dirty="0" spc="9" kern="0">
                 <a:solidFill>
                   <a:srgbClr val="F3EEE3"/>
                 </a:solidFill>
@@ -8376,7 +8409,18 @@
                 <a:ea typeface="Be Vietnam Pro" pitchFamily="34" charset="-122"/>
                 <a:cs typeface="Be Vietnam Pro" pitchFamily="34" charset="-120"/>
               </a:rPr>
-              <a:t> gốc</a:t>
+              <a:t> đồng</a:t>
+            </a:r>
+            <a:r>
+              <a:rPr lang="en-US" sz="2700" dirty="0" spc="0" kern="0">
+                <a:solidFill>
+                  <a:srgbClr val="F3EEE3"/>
+                </a:solidFill>
+                <a:latin typeface="Be Vietnam Pro" pitchFamily="34" charset="0"/>
+                <a:ea typeface="Be Vietnam Pro" pitchFamily="34" charset="-122"/>
+                <a:cs typeface="Be Vietnam Pro" pitchFamily="34" charset="-120"/>
+              </a:rPr>
+              <a:t> chung</a:t>
             </a:r>
             <a:endParaRPr lang="en-US" sz="2700" dirty="0"/>
           </a:p>
@@ -8399,7 +8443,7 @@
               <a:t>của</a:t>
             </a:r>
             <a:r>
-              <a:rPr lang="en-US" sz="2700" dirty="0" spc="2" kern="0">
+              <a:rPr lang="en-US" sz="2700" dirty="0" spc="-7" kern="0">
                 <a:solidFill>
                   <a:srgbClr val="F3EEE3"/>
                 </a:solidFill>
@@ -8407,10 +8451,10 @@
                 <a:ea typeface="Be Vietnam Pro" pitchFamily="34" charset="-122"/>
                 <a:cs typeface="Be Vietnam Pro" pitchFamily="34" charset="-120"/>
               </a:rPr>
-              <a:t> các</a:t>
-            </a:r>
-            <a:r>
-              <a:rPr lang="en-US" sz="2700" dirty="0" spc="-14" kern="0">
+              <a:t> một</a:t>
+            </a:r>
+            <a:r>
+              <a:rPr lang="en-US" sz="2700" dirty="0" spc="-2" kern="0">
                 <a:solidFill>
                   <a:srgbClr val="F3EEE3"/>
                 </a:solidFill>
@@ -8418,18 +8462,7 @@
                 <a:ea typeface="Be Vietnam Pro" pitchFamily="34" charset="-122"/>
                 <a:cs typeface="Be Vietnam Pro" pitchFamily="34" charset="-120"/>
               </a:rPr>
-              <a:t> tập</a:t>
-            </a:r>
-            <a:r>
-              <a:rPr lang="en-US" sz="2700" dirty="0" spc="-2" kern="0">
-                <a:solidFill>
-                  <a:srgbClr val="F3EEE3"/>
-                </a:solidFill>
-                <a:latin typeface="Be Vietnam Pro" pitchFamily="34" charset="0"/>
-                <a:ea typeface="Be Vietnam Pro" pitchFamily="34" charset="-122"/>
-                <a:cs typeface="Be Vietnam Pro" pitchFamily="34" charset="-120"/>
-              </a:rPr>
-              <a:t> hợp.</a:t>
+              <a:t> nhóm phần tử.</a:t>
             </a:r>
             <a:endParaRPr lang="en-US" sz="2700" dirty="0"/>
           </a:p>
@@ -8468,7 +8501,7 @@
               <a:buChar char="•"/>
             </a:pPr>
             <a:r>
-              <a:rPr lang="en-US" sz="2550" dirty="0" spc="-19" kern="0">
+              <a:rPr lang="en-US" sz="2550" dirty="0" spc="-16" kern="0">
                 <a:solidFill>
                   <a:srgbClr val="C4C8D6"/>
                 </a:solidFill>
@@ -8476,10 +8509,10 @@
                 <a:ea typeface="Be Vietnam Pro" pitchFamily="34" charset="-122"/>
                 <a:cs typeface="Be Vietnam Pro" pitchFamily="34" charset="-120"/>
               </a:rPr>
-              <a:t>Iterable</a:t>
-            </a:r>
-            <a:r>
-              <a:rPr lang="en-US" sz="2550" dirty="0" spc="0" kern="0">
+              <a:t>Iterable:</a:t>
+            </a:r>
+            <a:r>
+              <a:rPr lang="en-US" sz="2550" dirty="0" spc="33" kern="0">
                 <a:solidFill>
                   <a:srgbClr val="C4C8D6"/>
                 </a:solidFill>
@@ -8487,10 +8520,10 @@
                 <a:ea typeface="Be Vietnam Pro" pitchFamily="34" charset="-122"/>
                 <a:cs typeface="Be Vietnam Pro" pitchFamily="34" charset="-120"/>
               </a:rPr>
-              <a:t> cho phép</a:t>
-            </a:r>
-            <a:r>
-              <a:rPr lang="en-US" sz="2550" dirty="0" spc="-17" kern="0">
+              <a:t> đi</a:t>
+            </a:r>
+            <a:r>
+              <a:rPr lang="en-US" sz="2550" dirty="0" spc="1" kern="0">
                 <a:solidFill>
                   <a:srgbClr val="C4C8D6"/>
                 </a:solidFill>
@@ -8498,7 +8531,7 @@
                 <a:ea typeface="Be Vietnam Pro" pitchFamily="34" charset="-122"/>
                 <a:cs typeface="Be Vietnam Pro" pitchFamily="34" charset="-120"/>
               </a:rPr>
-              <a:t> duyệt</a:t>
+              <a:t> qua</a:t>
             </a:r>
             <a:r>
               <a:rPr lang="en-US" sz="2550" dirty="0" spc="20" kern="0">
@@ -8545,6 +8578,17 @@
               <a:buChar char="•"/>
             </a:pPr>
             <a:r>
+              <a:rPr lang="en-US" sz="2550" dirty="0" spc="0" kern="0">
+                <a:solidFill>
+                  <a:srgbClr val="C4C8D6"/>
+                </a:solidFill>
+                <a:latin typeface="Be Vietnam Pro" pitchFamily="34" charset="0"/>
+                <a:ea typeface="Be Vietnam Pro" pitchFamily="34" charset="-122"/>
+                <a:cs typeface="Be Vietnam Pro" pitchFamily="34" charset="-120"/>
+              </a:rPr>
+              <a:t>Collection:</a:t>
+            </a:r>
+            <a:r>
               <a:rPr lang="en-US" sz="2550" dirty="0" spc="-1" kern="0">
                 <a:solidFill>
                   <a:srgbClr val="C4C8D6"/>
@@ -8553,7 +8597,40 @@
                 <a:ea typeface="Be Vietnam Pro" pitchFamily="34" charset="-122"/>
                 <a:cs typeface="Be Vietnam Pro" pitchFamily="34" charset="-120"/>
               </a:rPr>
-              <a:t>Collection</a:t>
+              <a:t> hợp</a:t>
+            </a:r>
+            <a:r>
+              <a:rPr lang="en-US" sz="2550" dirty="0" spc="10" kern="0">
+                <a:solidFill>
+                  <a:srgbClr val="C4C8D6"/>
+                </a:solidFill>
+                <a:latin typeface="Be Vietnam Pro" pitchFamily="34" charset="0"/>
+                <a:ea typeface="Be Vietnam Pro" pitchFamily="34" charset="-122"/>
+                <a:cs typeface="Be Vietnam Pro" pitchFamily="34" charset="-120"/>
+              </a:rPr>
+              <a:t> đồng</a:t>
+            </a:r>
+            <a:r>
+              <a:rPr lang="en-US" sz="2550" dirty="0" spc="1" kern="0">
+                <a:solidFill>
+                  <a:srgbClr val="C4C8D6"/>
+                </a:solidFill>
+                <a:latin typeface="Be Vietnam Pro" pitchFamily="34" charset="0"/>
+                <a:ea typeface="Be Vietnam Pro" pitchFamily="34" charset="-122"/>
+                <a:cs typeface="Be Vietnam Pro" pitchFamily="34" charset="-120"/>
+              </a:rPr>
+              <a:t> chung</a:t>
+            </a:r>
+            <a:r>
+              <a:rPr lang="en-US" sz="2550" dirty="0" spc="-2" kern="0">
+                <a:solidFill>
+                  <a:srgbClr val="C4C8D6"/>
+                </a:solidFill>
+                <a:latin typeface="Be Vietnam Pro" pitchFamily="34" charset="0"/>
+                <a:ea typeface="Be Vietnam Pro" pitchFamily="34" charset="-122"/>
+                <a:cs typeface="Be Vietnam Pro" pitchFamily="34" charset="-120"/>
+              </a:rPr>
+              <a:t> của</a:t>
             </a:r>
             <a:r>
               <a:rPr lang="en-US" sz="2550" dirty="0" spc="0" kern="0">
@@ -8564,62 +8641,7 @@
                 <a:ea typeface="Be Vietnam Pro" pitchFamily="34" charset="-122"/>
                 <a:cs typeface="Be Vietnam Pro" pitchFamily="34" charset="-120"/>
               </a:rPr>
-              <a:t> khai</a:t>
-            </a:r>
-            <a:r>
-              <a:rPr lang="en-US" sz="2550" dirty="0" spc="-3" kern="0">
-                <a:solidFill>
-                  <a:srgbClr val="C4C8D6"/>
-                </a:solidFill>
-                <a:latin typeface="Be Vietnam Pro" pitchFamily="34" charset="0"/>
-                <a:ea typeface="Be Vietnam Pro" pitchFamily="34" charset="-122"/>
-                <a:cs typeface="Be Vietnam Pro" pitchFamily="34" charset="-120"/>
-              </a:rPr>
-              <a:t> báo</a:t>
-            </a:r>
-            <a:r>
-              <a:rPr lang="en-US" sz="2550" dirty="0" spc="1" kern="0">
-                <a:solidFill>
-                  <a:srgbClr val="C4C8D6"/>
-                </a:solidFill>
-                <a:latin typeface="Be Vietnam Pro" pitchFamily="34" charset="0"/>
-                <a:ea typeface="Be Vietnam Pro" pitchFamily="34" charset="-122"/>
-                <a:cs typeface="Be Vietnam Pro" pitchFamily="34" charset="-120"/>
-              </a:rPr>
-              <a:t> thêm,</a:t>
-            </a:r>
-            <a:r>
-              <a:rPr lang="en-US" sz="2550" dirty="0" spc="-22" kern="0">
-                <a:solidFill>
-                  <a:srgbClr val="C4C8D6"/>
-                </a:solidFill>
-                <a:latin typeface="Be Vietnam Pro" pitchFamily="34" charset="0"/>
-                <a:ea typeface="Be Vietnam Pro" pitchFamily="34" charset="-122"/>
-                <a:cs typeface="Be Vietnam Pro" pitchFamily="34" charset="-120"/>
-              </a:rPr>
-              <a:t> xóa</a:t>
-            </a:r>
-            <a:r>
-              <a:rPr lang="en-US" sz="2550" dirty="0" spc="-2" kern="0">
-                <a:solidFill>
-                  <a:srgbClr val="C4C8D6"/>
-                </a:solidFill>
-                <a:latin typeface="Be Vietnam Pro" pitchFamily="34" charset="0"/>
-                <a:ea typeface="Be Vietnam Pro" pitchFamily="34" charset="-122"/>
-                <a:cs typeface="Be Vietnam Pro" pitchFamily="34" charset="-120"/>
-              </a:rPr>
-              <a:t> (tùy chọn),</a:t>
-            </a:r>
-            <a:r>
-              <a:rPr lang="en-US" sz="2550" dirty="0" spc="0" kern="0">
-                <a:solidFill>
-                  <a:srgbClr val="C4C8D6"/>
-                </a:solidFill>
-                <a:latin typeface="Be Vietnam Pro" pitchFamily="34" charset="0"/>
-                <a:ea typeface="Be Vietnam Pro" pitchFamily="34" charset="-122"/>
-                <a:cs typeface="Be Vietnam Pro" pitchFamily="34" charset="-120"/>
-              </a:rPr>
-              <a:t> hỏi</a:t>
+              <a:t> nhóm</a:t>
             </a:r>
             <a:endParaRPr lang="en-US" sz="2550" dirty="0"/>
           </a:p>
@@ -8650,6 +8672,39 @@
               <a:buNone/>
             </a:pPr>
             <a:r>
+              <a:rPr lang="en-US" sz="1950" dirty="0" spc="-4" kern="0">
+                <a:solidFill>
+                  <a:srgbClr val="14161C"/>
+                </a:solidFill>
+                <a:latin typeface="Be Vietnam Pro" pitchFamily="34" charset="0"/>
+                <a:ea typeface="Be Vietnam Pro" pitchFamily="34" charset="-122"/>
+                <a:cs typeface="Be Vietnam Pro" pitchFamily="34" charset="-120"/>
+              </a:rPr>
+              <a:t>JDK</a:t>
+            </a:r>
+            <a:r>
+              <a:rPr lang="en-US" sz="1950" dirty="0" spc="0" kern="0">
+                <a:solidFill>
+                  <a:srgbClr val="14161C"/>
+                </a:solidFill>
+                <a:latin typeface="Be Vietnam Pro" pitchFamily="34" charset="0"/>
+                <a:ea typeface="Be Vietnam Pro" pitchFamily="34" charset="-122"/>
+                <a:cs typeface="Be Vietnam Pro" pitchFamily="34" charset="-120"/>
+              </a:rPr>
+              <a:t> không</a:t>
+            </a:r>
+            <a:r>
+              <a:rPr lang="en-US" sz="1950" dirty="0" spc="-2" kern="0">
+                <a:solidFill>
+                  <a:srgbClr val="14161C"/>
+                </a:solidFill>
+                <a:latin typeface="Be Vietnam Pro" pitchFamily="34" charset="0"/>
+                <a:ea typeface="Be Vietnam Pro" pitchFamily="34" charset="-122"/>
+                <a:cs typeface="Be Vietnam Pro" pitchFamily="34" charset="-120"/>
+              </a:rPr>
+              <a:t> cài</a:t>
+            </a:r>
+            <a:r>
               <a:rPr lang="en-US" sz="1950" dirty="0" spc="-1" kern="0">
                 <a:solidFill>
                   <a:srgbClr val="14161C"/>
@@ -8658,10 +8713,10 @@
                 <a:ea typeface="Be Vietnam Pro" pitchFamily="34" charset="-122"/>
                 <a:cs typeface="Be Vietnam Pro" pitchFamily="34" charset="-120"/>
               </a:rPr>
-              <a:t>hỏi</a:t>
-            </a:r>
-            <a:r>
-              <a:rPr lang="en-US" sz="1950" dirty="0" spc="-2" kern="0">
+              <a:t> đặt</a:t>
+            </a:r>
+            <a:r>
+              <a:rPr lang="en-US" sz="1950" dirty="0" spc="5" kern="0">
                 <a:solidFill>
                   <a:srgbClr val="14161C"/>
                 </a:solidFill>
@@ -8669,10 +8724,10 @@
                 <a:ea typeface="Be Vietnam Pro" pitchFamily="34" charset="-122"/>
                 <a:cs typeface="Be Vietnam Pro" pitchFamily="34" charset="-120"/>
               </a:rPr>
-              <a:t> ·</a:t>
-            </a:r>
-            <a:r>
-              <a:rPr lang="en-US" sz="1950" dirty="0" spc="0" kern="0">
+              <a:t> trực</a:t>
+            </a:r>
+            <a:r>
+              <a:rPr lang="en-US" sz="1950" dirty="0" spc="-1" kern="0">
                 <a:solidFill>
                   <a:srgbClr val="14161C"/>
                 </a:solidFill>
@@ -8680,40 +8735,7 @@
                 <a:ea typeface="Be Vietnam Pro" pitchFamily="34" charset="-122"/>
                 <a:cs typeface="Be Vietnam Pro" pitchFamily="34" charset="-120"/>
               </a:rPr>
-              <a:t> thêm</a:t>
-            </a:r>
-            <a:r>
-              <a:rPr lang="en-US" sz="1950" dirty="0" spc="-15" kern="0">
-                <a:solidFill>
-                  <a:srgbClr val="14161C"/>
-                </a:solidFill>
-                <a:latin typeface="Be Vietnam Pro" pitchFamily="34" charset="0"/>
-                <a:ea typeface="Be Vietnam Pro" pitchFamily="34" charset="-122"/>
-                <a:cs typeface="Be Vietnam Pro" pitchFamily="34" charset="-120"/>
-              </a:rPr>
-              <a:t> và</a:t>
-            </a:r>
-            <a:r>
-              <a:rPr lang="en-US" sz="1950" dirty="0" spc="-17" kern="0">
-                <a:solidFill>
-                  <a:srgbClr val="14161C"/>
-                </a:solidFill>
-                <a:latin typeface="Be Vietnam Pro" pitchFamily="34" charset="0"/>
-                <a:ea typeface="Be Vietnam Pro" pitchFamily="34" charset="-122"/>
-                <a:cs typeface="Be Vietnam Pro" pitchFamily="34" charset="-120"/>
-              </a:rPr>
-              <a:t> xóa</a:t>
-            </a:r>
-            <a:r>
-              <a:rPr lang="en-US" sz="1950" dirty="0" spc="-1" kern="0">
-                <a:solidFill>
-                  <a:srgbClr val="14161C"/>
-                </a:solidFill>
-                <a:latin typeface="Be Vietnam Pro" pitchFamily="34" charset="0"/>
-                <a:ea typeface="Be Vietnam Pro" pitchFamily="34" charset="-122"/>
-                <a:cs typeface="Be Vietnam Pro" pitchFamily="34" charset="-120"/>
-              </a:rPr>
-              <a:t> tùy chọn</a:t>
+              <a:t> tiếp</a:t>
             </a:r>
             <a:endParaRPr lang="en-US" sz="1950" dirty="0"/>
           </a:p>
@@ -8934,7 +8956,7 @@
               <a:buNone/>
             </a:pPr>
             <a:r>
-              <a:rPr lang="en-US" sz="3300" b="1" dirty="0" spc="-2" kern="0">
+              <a:rPr lang="en-US" sz="3300" b="1" dirty="0" spc="-5" kern="0">
                 <a:solidFill>
                   <a:srgbClr val="1F3FD1"/>
                 </a:solidFill>
@@ -8942,7 +8964,18 @@
                 <a:ea typeface="Be Vietnam Pro" pitchFamily="34" charset="-122"/>
                 <a:cs typeface="Be Vietnam Pro" pitchFamily="34" charset="-120"/>
               </a:rPr>
-              <a:t>Có</a:t>
+              <a:t>Mỗi</a:t>
+            </a:r>
+            <a:r>
+              <a:rPr lang="en-US" sz="3300" b="1" dirty="0" spc="-7" kern="0">
+                <a:solidFill>
+                  <a:srgbClr val="1F3FD1"/>
+                </a:solidFill>
+                <a:latin typeface="Be Vietnam Pro" pitchFamily="34" charset="0"/>
+                <a:ea typeface="Be Vietnam Pro" pitchFamily="34" charset="-122"/>
+                <a:cs typeface="Be Vietnam Pro" pitchFamily="34" charset="-120"/>
+              </a:rPr>
+              <a:t> phần</a:t>
             </a:r>
             <a:r>
               <a:rPr lang="en-US" sz="3300" b="1" dirty="0" spc="-5" kern="0">
@@ -8953,10 +8986,10 @@
                 <a:ea typeface="Be Vietnam Pro" pitchFamily="34" charset="-122"/>
                 <a:cs typeface="Be Vietnam Pro" pitchFamily="34" charset="-120"/>
               </a:rPr>
-              <a:t> thứ</a:t>
-            </a:r>
-            <a:r>
-              <a:rPr lang="en-US" sz="3300" b="1" dirty="0" spc="-4" kern="0">
+              <a:t> tử</a:t>
+            </a:r>
+            <a:r>
+              <a:rPr lang="en-US" sz="3300" b="1" dirty="0" spc="-17" kern="0">
                 <a:solidFill>
                   <a:srgbClr val="1F3FD1"/>
                 </a:solidFill>
@@ -8964,18 +8997,7 @@
                 <a:ea typeface="Be Vietnam Pro" pitchFamily="34" charset="-122"/>
                 <a:cs typeface="Be Vietnam Pro" pitchFamily="34" charset="-120"/>
               </a:rPr>
-              <a:t> tự</a:t>
-            </a:r>
-            <a:r>
-              <a:rPr lang="en-US" sz="3300" b="1" dirty="0" spc="-10" kern="0">
-                <a:solidFill>
-                  <a:srgbClr val="1F3FD1"/>
-                </a:solidFill>
-                <a:latin typeface="Be Vietnam Pro" pitchFamily="34" charset="0"/>
-                <a:ea typeface="Be Vietnam Pro" pitchFamily="34" charset="-122"/>
-                <a:cs typeface="Be Vietnam Pro" pitchFamily="34" charset="-120"/>
-              </a:rPr>
-              <a:t> theo</a:t>
+              <a:t> một</a:t>
             </a:r>
             <a:r>
               <a:rPr lang="en-US" sz="3300" b="1" dirty="0" spc="-4" kern="0">
@@ -9129,7 +9151,7 @@
               <a:buNone/>
             </a:pPr>
             <a:r>
-              <a:rPr lang="en-US" sz="2250" b="1" dirty="0" spc="-3" kern="0">
+              <a:rPr lang="en-US" sz="2250" b="1" dirty="0" spc="5" kern="0">
                 <a:solidFill>
                   <a:srgbClr val="F3EEE3"/>
                 </a:solidFill>
@@ -9137,10 +9159,10 @@
                 <a:ea typeface="Be Vietnam Pro" pitchFamily="34" charset="-122"/>
                 <a:cs typeface="Be Vietnam Pro" pitchFamily="34" charset="-120"/>
               </a:rPr>
-              <a:t>theo</a:t>
-            </a:r>
-            <a:r>
-              <a:rPr lang="en-US" sz="2250" b="1" dirty="0" spc="3" kern="0">
+              <a:t>đọc</a:t>
+            </a:r>
+            <a:r>
+              <a:rPr lang="en-US" sz="2250" b="1" dirty="0" spc="-1" kern="0">
                 <a:solidFill>
                   <a:srgbClr val="F3EEE3"/>
                 </a:solidFill>
@@ -9148,10 +9170,10 @@
                 <a:ea typeface="Be Vietnam Pro" pitchFamily="34" charset="-122"/>
                 <a:cs typeface="Be Vietnam Pro" pitchFamily="34" charset="-120"/>
               </a:rPr>
-              <a:t> vị</a:t>
-            </a:r>
-            <a:r>
-              <a:rPr lang="en-US" sz="2250" b="1" dirty="0" spc="10" kern="0">
+              <a:t> theo</a:t>
+            </a:r>
+            <a:r>
+              <a:rPr lang="en-US" sz="2250" b="1" dirty="0" spc="4" kern="0">
                 <a:solidFill>
                   <a:srgbClr val="F3EEE3"/>
                 </a:solidFill>
@@ -9159,7 +9181,18 @@
                 <a:ea typeface="Be Vietnam Pro" pitchFamily="34" charset="-122"/>
                 <a:cs typeface="Be Vietnam Pro" pitchFamily="34" charset="-120"/>
               </a:rPr>
-              <a:t> trí</a:t>
+              <a:t> chỉ</a:t>
+            </a:r>
+            <a:r>
+              <a:rPr lang="en-US" sz="2250" b="1" dirty="0" spc="-1" kern="0">
+                <a:solidFill>
+                  <a:srgbClr val="F3EEE3"/>
+                </a:solidFill>
+                <a:latin typeface="Be Vietnam Pro" pitchFamily="34" charset="0"/>
+                <a:ea typeface="Be Vietnam Pro" pitchFamily="34" charset="-122"/>
+                <a:cs typeface="Be Vietnam Pro" pitchFamily="34" charset="-120"/>
+              </a:rPr>
+              <a:t> số</a:t>
             </a:r>
             <a:endParaRPr lang="en-US" sz="2250" dirty="0"/>
           </a:p>
@@ -9341,6 +9374,28 @@
               <a:buNone/>
             </a:pPr>
             <a:r>
+              <a:rPr lang="en-US" sz="2700" dirty="0" spc="9" kern="0">
+                <a:solidFill>
+                  <a:srgbClr val="14161C"/>
+                </a:solidFill>
+                <a:latin typeface="Be Vietnam Pro" pitchFamily="34" charset="0"/>
+                <a:ea typeface="Be Vietnam Pro" pitchFamily="34" charset="-122"/>
+                <a:cs typeface="Be Vietnam Pro" pitchFamily="34" charset="-120"/>
+              </a:rPr>
+              <a:t>Người</a:t>
+            </a:r>
+            <a:r>
+              <a:rPr lang="en-US" sz="2700" dirty="0" spc="-3" kern="0">
+                <a:solidFill>
+                  <a:srgbClr val="14161C"/>
+                </a:solidFill>
+                <a:latin typeface="Be Vietnam Pro" pitchFamily="34" charset="0"/>
+                <a:ea typeface="Be Vietnam Pro" pitchFamily="34" charset="-122"/>
+                <a:cs typeface="Be Vietnam Pro" pitchFamily="34" charset="-120"/>
+              </a:rPr>
+              <a:t> dùng</a:t>
+            </a:r>
+            <a:r>
               <a:rPr lang="en-US" sz="2700" dirty="0" spc="-1" kern="0">
                 <a:solidFill>
                   <a:srgbClr val="14161C"/>
@@ -9349,10 +9404,10 @@
                 <a:ea typeface="Be Vietnam Pro" pitchFamily="34" charset="-122"/>
                 <a:cs typeface="Be Vietnam Pro" pitchFamily="34" charset="-120"/>
               </a:rPr>
-              <a:t>Hai</a:t>
-            </a:r>
-            <a:r>
-              <a:rPr lang="en-US" sz="2700" dirty="0" spc="14" kern="0">
+              <a:t> chọn chỗ chèn</a:t>
+            </a:r>
+            <a:r>
+              <a:rPr lang="en-US" sz="2700" dirty="0" spc="-18" kern="0">
                 <a:solidFill>
                   <a:srgbClr val="14161C"/>
                 </a:solidFill>
@@ -9360,10 +9415,10 @@
                 <a:ea typeface="Be Vietnam Pro" pitchFamily="34" charset="-122"/>
                 <a:cs typeface="Be Vietnam Pro" pitchFamily="34" charset="-120"/>
               </a:rPr>
-              <a:t> đặc</a:t>
-            </a:r>
-            <a:r>
-              <a:rPr lang="en-US" sz="2700" dirty="0" spc="16" kern="0">
+              <a:t> và</a:t>
+            </a:r>
+            <a:r>
+              <a:rPr lang="en-US" sz="2700" dirty="0" spc="10" kern="0">
                 <a:solidFill>
                   <a:srgbClr val="14161C"/>
                 </a:solidFill>
@@ -9371,7 +9426,7 @@
                 <a:ea typeface="Be Vietnam Pro" pitchFamily="34" charset="-122"/>
                 <a:cs typeface="Be Vietnam Pro" pitchFamily="34" charset="-120"/>
               </a:rPr>
-              <a:t> điểm:</a:t>
+              <a:t> đọc</a:t>
             </a:r>
             <a:r>
               <a:rPr lang="en-US" sz="2700" dirty="0" spc="-1" kern="0">
@@ -9382,10 +9437,10 @@
                 <a:ea typeface="Be Vietnam Pro" pitchFamily="34" charset="-122"/>
                 <a:cs typeface="Be Vietnam Pro" pitchFamily="34" charset="-120"/>
               </a:rPr>
-              <a:t> có thứ</a:t>
-            </a:r>
-            <a:r>
-              <a:rPr lang="en-US" sz="2700" dirty="0" spc="0" kern="0">
+              <a:t> lại</a:t>
+            </a:r>
+            <a:r>
+              <a:rPr lang="en-US" sz="2700" dirty="0" spc="-4" kern="0">
                 <a:solidFill>
                   <a:srgbClr val="14161C"/>
                 </a:solidFill>
@@ -9393,10 +9448,10 @@
                 <a:ea typeface="Be Vietnam Pro" pitchFamily="34" charset="-122"/>
                 <a:cs typeface="Be Vietnam Pro" pitchFamily="34" charset="-120"/>
               </a:rPr>
-              <a:t> tự</a:t>
-            </a:r>
-            <a:r>
-              <a:rPr lang="en-US" sz="2700" dirty="0" spc="-3" kern="0">
+              <a:t> bằng</a:t>
+            </a:r>
+            <a:r>
+              <a:rPr lang="en-US" sz="2700" dirty="0" spc="-2" kern="0">
                 <a:solidFill>
                   <a:srgbClr val="14161C"/>
                 </a:solidFill>
@@ -9404,7 +9459,18 @@
                 <a:ea typeface="Be Vietnam Pro" pitchFamily="34" charset="-122"/>
                 <a:cs typeface="Be Vietnam Pro" pitchFamily="34" charset="-120"/>
               </a:rPr>
-              <a:t> theo</a:t>
+              <a:t> chỉ</a:t>
+            </a:r>
+            <a:r>
+              <a:rPr lang="en-US" sz="2700" dirty="0" spc="-12" kern="0">
+                <a:solidFill>
+                  <a:srgbClr val="14161C"/>
+                </a:solidFill>
+                <a:latin typeface="Be Vietnam Pro" pitchFamily="34" charset="0"/>
+                <a:ea typeface="Be Vietnam Pro" pitchFamily="34" charset="-122"/>
+                <a:cs typeface="Be Vietnam Pro" pitchFamily="34" charset="-120"/>
+              </a:rPr>
+              <a:t> số</a:t>
             </a:r>
             <a:r>
               <a:rPr lang="en-US" sz="2700" dirty="0" spc="-1" kern="0">
@@ -9415,10 +9481,10 @@
                 <a:ea typeface="Be Vietnam Pro" pitchFamily="34" charset="-122"/>
                 <a:cs typeface="Be Vietnam Pro" pitchFamily="34" charset="-120"/>
               </a:rPr>
-              <a:t> vị</a:t>
-            </a:r>
-            <a:r>
-              <a:rPr lang="en-US" sz="2700" dirty="0" spc="12" kern="0">
+              <a:t> từ</a:t>
+            </a:r>
+            <a:r>
+              <a:rPr lang="en-US" sz="2700" dirty="0" spc="-2" kern="0">
                 <a:solidFill>
                   <a:srgbClr val="14161C"/>
                 </a:solidFill>
@@ -9426,62 +9492,7 @@
                 <a:ea typeface="Be Vietnam Pro" pitchFamily="34" charset="-122"/>
                 <a:cs typeface="Be Vietnam Pro" pitchFamily="34" charset="-120"/>
               </a:rPr>
-              <a:t> trí</a:t>
-            </a:r>
-            <a:r>
-              <a:rPr lang="en-US" sz="2700" dirty="0" spc="-18" kern="0">
-                <a:solidFill>
-                  <a:srgbClr val="14161C"/>
-                </a:solidFill>
-                <a:latin typeface="Be Vietnam Pro" pitchFamily="34" charset="0"/>
-                <a:ea typeface="Be Vietnam Pro" pitchFamily="34" charset="-122"/>
-                <a:cs typeface="Be Vietnam Pro" pitchFamily="34" charset="-120"/>
-              </a:rPr>
-              <a:t> và</a:t>
-            </a:r>
-            <a:r>
-              <a:rPr lang="en-US" sz="2700" dirty="0" spc="6" kern="0">
-                <a:solidFill>
-                  <a:srgbClr val="14161C"/>
-                </a:solidFill>
-                <a:latin typeface="Be Vietnam Pro" pitchFamily="34" charset="0"/>
-                <a:ea typeface="Be Vietnam Pro" pitchFamily="34" charset="-122"/>
-                <a:cs typeface="Be Vietnam Pro" pitchFamily="34" charset="-120"/>
-              </a:rPr>
-              <a:t> thường</a:t>
-            </a:r>
-            <a:r>
-              <a:rPr lang="en-US" sz="2700" dirty="0" spc="-1" kern="0">
-                <a:solidFill>
-                  <a:srgbClr val="14161C"/>
-                </a:solidFill>
-                <a:latin typeface="Be Vietnam Pro" pitchFamily="34" charset="0"/>
-                <a:ea typeface="Be Vietnam Pro" pitchFamily="34" charset="-122"/>
-                <a:cs typeface="Be Vietnam Pro" pitchFamily="34" charset="-120"/>
-              </a:rPr>
-              <a:t> cho</a:t>
-            </a:r>
-            <a:r>
-              <a:rPr lang="en-US" sz="2700" dirty="0" spc="-3" kern="0">
-                <a:solidFill>
-                  <a:srgbClr val="14161C"/>
-                </a:solidFill>
-                <a:latin typeface="Be Vietnam Pro" pitchFamily="34" charset="0"/>
-                <a:ea typeface="Be Vietnam Pro" pitchFamily="34" charset="-122"/>
-                <a:cs typeface="Be Vietnam Pro" pitchFamily="34" charset="-120"/>
-              </a:rPr>
-              <a:t> phép</a:t>
-            </a:r>
-            <a:r>
-              <a:rPr lang="en-US" sz="2700" dirty="0" spc="-2" kern="0">
-                <a:solidFill>
-                  <a:srgbClr val="14161C"/>
-                </a:solidFill>
-                <a:latin typeface="Be Vietnam Pro" pitchFamily="34" charset="0"/>
-                <a:ea typeface="Be Vietnam Pro" pitchFamily="34" charset="-122"/>
-                <a:cs typeface="Be Vietnam Pro" pitchFamily="34" charset="-120"/>
-              </a:rPr>
-              <a:t> trùng.</a:t>
+              <a:t> 0.</a:t>
             </a:r>
             <a:endParaRPr lang="en-US" sz="2700" dirty="0"/>
           </a:p>
@@ -9539,6 +9550,72 @@
               <a:buNone/>
             </a:pPr>
             <a:r>
+              <a:rPr lang="en-US" sz="1800" b="1" spc="226" kern="0" dirty="0">
+                <a:solidFill>
+                  <a:srgbClr val="6B6A66"/>
+                </a:solidFill>
+                <a:latin typeface="Be Vietnam Pro" pitchFamily="34" charset="0"/>
+                <a:ea typeface="Be Vietnam Pro" pitchFamily="34" charset="-122"/>
+                <a:cs typeface="Be Vietnam Pro" pitchFamily="34" charset="-120"/>
+              </a:rPr>
+              <a:t>VỊ</a:t>
+            </a:r>
+            <a:r>
+              <a:rPr lang="en-US" sz="1800" b="1" spc="223" kern="0" dirty="0">
+                <a:solidFill>
+                  <a:srgbClr val="6B6A66"/>
+                </a:solidFill>
+                <a:latin typeface="Be Vietnam Pro" pitchFamily="34" charset="0"/>
+                <a:ea typeface="Be Vietnam Pro" pitchFamily="34" charset="-122"/>
+                <a:cs typeface="Be Vietnam Pro" pitchFamily="34" charset="-120"/>
+              </a:rPr>
+              <a:t> TRÍ</a:t>
+            </a:r>
+            <a:r>
+              <a:rPr lang="en-US" sz="1800" b="1" spc="179" kern="0" dirty="0">
+                <a:solidFill>
+                  <a:srgbClr val="6B6A66"/>
+                </a:solidFill>
+                <a:latin typeface="Be Vietnam Pro" pitchFamily="34" charset="0"/>
+                <a:ea typeface="Be Vietnam Pro" pitchFamily="34" charset="-122"/>
+                <a:cs typeface="Be Vietnam Pro" pitchFamily="34" charset="-120"/>
+              </a:rPr>
+              <a:t> VÀ</a:t>
+            </a:r>
+            <a:r>
+              <a:rPr lang="en-US" sz="1800" b="1" spc="227" kern="0" dirty="0">
+                <a:solidFill>
+                  <a:srgbClr val="6B6A66"/>
+                </a:solidFill>
+                <a:latin typeface="Be Vietnam Pro" pitchFamily="34" charset="0"/>
+                <a:ea typeface="Be Vietnam Pro" pitchFamily="34" charset="-122"/>
+                <a:cs typeface="Be Vietnam Pro" pitchFamily="34" charset="-120"/>
+              </a:rPr>
+              <a:t> CHỈ</a:t>
+            </a:r>
+            <a:r>
+              <a:rPr lang="en-US" sz="1800" b="1" spc="231" kern="0" dirty="0">
+                <a:solidFill>
+                  <a:srgbClr val="6B6A66"/>
+                </a:solidFill>
+                <a:latin typeface="Be Vietnam Pro" pitchFamily="34" charset="0"/>
+                <a:ea typeface="Be Vietnam Pro" pitchFamily="34" charset="-122"/>
+                <a:cs typeface="Be Vietnam Pro" pitchFamily="34" charset="-120"/>
+              </a:rPr>
+              <a:t> SỐ,</a:t>
+            </a:r>
+            <a:r>
+              <a:rPr lang="en-US" sz="1800" b="1" spc="226" kern="0" dirty="0">
+                <a:solidFill>
+                  <a:srgbClr val="6B6A66"/>
+                </a:solidFill>
+                <a:latin typeface="Be Vietnam Pro" pitchFamily="34" charset="0"/>
+                <a:ea typeface="Be Vietnam Pro" pitchFamily="34" charset="-122"/>
+                <a:cs typeface="Be Vietnam Pro" pitchFamily="34" charset="-120"/>
+              </a:rPr>
+              <a:t> THƯỜNG</a:t>
+            </a:r>
+            <a:r>
               <a:rPr lang="en-US" sz="1800" b="1" spc="228" kern="0" dirty="0">
                 <a:solidFill>
                   <a:srgbClr val="6B6A66"/>
@@ -9547,7 +9624,7 @@
                 <a:ea typeface="Be Vietnam Pro" pitchFamily="34" charset="-122"/>
                 <a:cs typeface="Be Vietnam Pro" pitchFamily="34" charset="-120"/>
               </a:rPr>
-              <a:t>THỨ</a:t>
+              <a:t> CHO</a:t>
             </a:r>
             <a:r>
               <a:rPr lang="en-US" sz="1800" b="1" spc="226" kern="0" dirty="0">
@@ -9558,76 +9635,10 @@
                 <a:ea typeface="Be Vietnam Pro" pitchFamily="34" charset="-122"/>
                 <a:cs typeface="Be Vietnam Pro" pitchFamily="34" charset="-120"/>
               </a:rPr>
-              <a:t> TỰ</a:t>
-            </a:r>
-            <a:r>
-              <a:rPr lang="en-US" sz="1800" b="1" spc="223" kern="0" dirty="0">
-                <a:solidFill>
-                  <a:srgbClr val="6B6A66"/>
-                </a:solidFill>
-                <a:latin typeface="Be Vietnam Pro" pitchFamily="34" charset="0"/>
-                <a:ea typeface="Be Vietnam Pro" pitchFamily="34" charset="-122"/>
-                <a:cs typeface="Be Vietnam Pro" pitchFamily="34" charset="-120"/>
-              </a:rPr>
-              <a:t> THEO</a:t>
-            </a:r>
-            <a:r>
-              <a:rPr lang="en-US" sz="1800" b="1" spc="226" kern="0" dirty="0">
-                <a:solidFill>
-                  <a:srgbClr val="6B6A66"/>
-                </a:solidFill>
-                <a:latin typeface="Be Vietnam Pro" pitchFamily="34" charset="0"/>
-                <a:ea typeface="Be Vietnam Pro" pitchFamily="34" charset="-122"/>
-                <a:cs typeface="Be Vietnam Pro" pitchFamily="34" charset="-120"/>
-              </a:rPr>
-              <a:t> VỊ</a:t>
-            </a:r>
-            <a:r>
-              <a:rPr lang="en-US" sz="1800" b="1" spc="223" kern="0" dirty="0">
-                <a:solidFill>
-                  <a:srgbClr val="6B6A66"/>
-                </a:solidFill>
-                <a:latin typeface="Be Vietnam Pro" pitchFamily="34" charset="0"/>
-                <a:ea typeface="Be Vietnam Pro" pitchFamily="34" charset="-122"/>
-                <a:cs typeface="Be Vietnam Pro" pitchFamily="34" charset="-120"/>
-              </a:rPr>
-              <a:t> TRÍ,</a:t>
-            </a:r>
-            <a:r>
-              <a:rPr lang="en-US" sz="1800" b="1" spc="226" kern="0" dirty="0">
-                <a:solidFill>
-                  <a:srgbClr val="6B6A66"/>
-                </a:solidFill>
-                <a:latin typeface="Be Vietnam Pro" pitchFamily="34" charset="0"/>
-                <a:ea typeface="Be Vietnam Pro" pitchFamily="34" charset="-122"/>
-                <a:cs typeface="Be Vietnam Pro" pitchFamily="34" charset="-120"/>
-              </a:rPr>
-              <a:t> THƯỜNG</a:t>
-            </a:r>
-            <a:r>
-              <a:rPr lang="en-US" sz="1800" b="1" spc="229" kern="0" dirty="0">
-                <a:solidFill>
-                  <a:srgbClr val="6B6A66"/>
-                </a:solidFill>
-                <a:latin typeface="Be Vietnam Pro" pitchFamily="34" charset="0"/>
-                <a:ea typeface="Be Vietnam Pro" pitchFamily="34" charset="-122"/>
-                <a:cs typeface="Be Vietnam Pro" pitchFamily="34" charset="-120"/>
-              </a:rPr>
-              <a:t> CHO</a:t>
-            </a:r>
-            <a:r>
-              <a:rPr lang="en-US" sz="1800" b="1" spc="225" kern="0" dirty="0">
-                <a:solidFill>
-                  <a:srgbClr val="6B6A66"/>
-                </a:solidFill>
-                <a:latin typeface="Be Vietnam Pro" pitchFamily="34" charset="0"/>
-                <a:ea typeface="Be Vietnam Pro" pitchFamily="34" charset="-122"/>
-                <a:cs typeface="Be Vietnam Pro" pitchFamily="34" charset="-120"/>
-              </a:rPr>
               <a:t> PHÉP</a:t>
             </a:r>
             <a:r>
-              <a:rPr lang="en-US" sz="1800" b="1" spc="217" kern="0" dirty="0">
+              <a:rPr lang="en-US" sz="1800" b="1" spc="216" kern="0" dirty="0">
                 <a:solidFill>
                   <a:srgbClr val="6B6A66"/>
                 </a:solidFill>
@@ -9858,7 +9869,7 @@
               <a:buNone/>
             </a:pPr>
             <a:r>
-              <a:rPr lang="en-US" sz="1950" dirty="0" spc="-1" kern="0">
+              <a:rPr lang="en-US" sz="1950" dirty="0" spc="-2" kern="0">
                 <a:solidFill>
                   <a:srgbClr val="6B6A66"/>
                 </a:solidFill>
@@ -9866,10 +9877,10 @@
                 <a:ea typeface="Be Vietnam Pro" pitchFamily="34" charset="-122"/>
                 <a:cs typeface="Be Vietnam Pro" pitchFamily="34" charset="-120"/>
               </a:rPr>
-              <a:t>vị</a:t>
-            </a:r>
-            <a:r>
-              <a:rPr lang="en-US" sz="1950" dirty="0" spc="10" kern="0">
+              <a:t>chỉ</a:t>
+            </a:r>
+            <a:r>
+              <a:rPr lang="en-US" sz="1950" dirty="0" spc="-7" kern="0">
                 <a:solidFill>
                   <a:srgbClr val="6B6A66"/>
                 </a:solidFill>
@@ -9877,10 +9888,10 @@
                 <a:ea typeface="Be Vietnam Pro" pitchFamily="34" charset="-122"/>
                 <a:cs typeface="Be Vietnam Pro" pitchFamily="34" charset="-120"/>
               </a:rPr>
-              <a:t> trí</a:t>
-            </a:r>
-            <a:r>
-              <a:rPr lang="en-US" sz="1950" dirty="0" spc="-1" kern="0">
+              <a:t> số</a:t>
+            </a:r>
+            <a:r>
+              <a:rPr lang="en-US" sz="1950" dirty="0" spc="3" kern="0">
                 <a:solidFill>
                   <a:srgbClr val="6B6A66"/>
                 </a:solidFill>
@@ -9888,7 +9899,7 @@
                 <a:ea typeface="Be Vietnam Pro" pitchFamily="34" charset="-122"/>
                 <a:cs typeface="Be Vietnam Pro" pitchFamily="34" charset="-120"/>
               </a:rPr>
-              <a:t> 1</a:t>
+              <a:t> 0</a:t>
             </a:r>
             <a:endParaRPr lang="en-US" sz="1950" dirty="0"/>
           </a:p>
@@ -9919,7 +9930,7 @@
               <a:buNone/>
             </a:pPr>
             <a:r>
-              <a:rPr lang="en-US" sz="1950" dirty="0" spc="-1" kern="0">
+              <a:rPr lang="en-US" sz="1950" dirty="0" spc="-2" kern="0">
                 <a:solidFill>
                   <a:srgbClr val="6B6A66"/>
                 </a:solidFill>
@@ -9927,10 +9938,10 @@
                 <a:ea typeface="Be Vietnam Pro" pitchFamily="34" charset="-122"/>
                 <a:cs typeface="Be Vietnam Pro" pitchFamily="34" charset="-120"/>
               </a:rPr>
-              <a:t>vị</a:t>
-            </a:r>
-            <a:r>
-              <a:rPr lang="en-US" sz="1950" dirty="0" spc="10" kern="0">
+              <a:t>chỉ</a:t>
+            </a:r>
+            <a:r>
+              <a:rPr lang="en-US" sz="1950" dirty="0" spc="-7" kern="0">
                 <a:solidFill>
                   <a:srgbClr val="6B6A66"/>
                 </a:solidFill>
@@ -9938,10 +9949,10 @@
                 <a:ea typeface="Be Vietnam Pro" pitchFamily="34" charset="-122"/>
                 <a:cs typeface="Be Vietnam Pro" pitchFamily="34" charset="-120"/>
               </a:rPr>
-              <a:t> trí</a:t>
-            </a:r>
-            <a:r>
-              <a:rPr lang="en-US" sz="1950" dirty="0" spc="-4" kern="0">
+              <a:t> số</a:t>
+            </a:r>
+            <a:r>
+              <a:rPr lang="en-US" sz="1950" dirty="0" spc="0" kern="0">
                 <a:solidFill>
                   <a:srgbClr val="6B6A66"/>
                 </a:solidFill>
@@ -9949,7 +9960,7 @@
                 <a:ea typeface="Be Vietnam Pro" pitchFamily="34" charset="-122"/>
                 <a:cs typeface="Be Vietnam Pro" pitchFamily="34" charset="-120"/>
               </a:rPr>
-              <a:t> 2</a:t>
+              <a:t> 1</a:t>
             </a:r>
             <a:endParaRPr lang="en-US" sz="1950" dirty="0"/>
           </a:p>
@@ -9980,7 +9991,7 @@
               <a:buNone/>
             </a:pPr>
             <a:r>
-              <a:rPr lang="en-US" sz="1950" dirty="0" spc="-1" kern="0">
+              <a:rPr lang="en-US" sz="1950" dirty="0" spc="-2" kern="0">
                 <a:solidFill>
                   <a:srgbClr val="6B6A66"/>
                 </a:solidFill>
@@ -9988,10 +9999,10 @@
                 <a:ea typeface="Be Vietnam Pro" pitchFamily="34" charset="-122"/>
                 <a:cs typeface="Be Vietnam Pro" pitchFamily="34" charset="-120"/>
               </a:rPr>
-              <a:t>vị</a:t>
-            </a:r>
-            <a:r>
-              <a:rPr lang="en-US" sz="1950" dirty="0" spc="10" kern="0">
+              <a:t>chỉ</a:t>
+            </a:r>
+            <a:r>
+              <a:rPr lang="en-US" sz="1950" dirty="0" spc="-7" kern="0">
                 <a:solidFill>
                   <a:srgbClr val="6B6A66"/>
                 </a:solidFill>
@@ -9999,10 +10010,10 @@
                 <a:ea typeface="Be Vietnam Pro" pitchFamily="34" charset="-122"/>
                 <a:cs typeface="Be Vietnam Pro" pitchFamily="34" charset="-120"/>
               </a:rPr>
-              <a:t> trí</a:t>
-            </a:r>
-            <a:r>
-              <a:rPr lang="en-US" sz="1950" dirty="0" spc="-2" kern="0">
+              <a:t> số</a:t>
+            </a:r>
+            <a:r>
+              <a:rPr lang="en-US" sz="1950" dirty="0" spc="-3" kern="0">
                 <a:solidFill>
                   <a:srgbClr val="6B6A66"/>
                 </a:solidFill>
@@ -10010,7 +10021,7 @@
                 <a:ea typeface="Be Vietnam Pro" pitchFamily="34" charset="-122"/>
                 <a:cs typeface="Be Vietnam Pro" pitchFamily="34" charset="-120"/>
               </a:rPr>
-              <a:t> 3</a:t>
+              <a:t> 2</a:t>
             </a:r>
             <a:endParaRPr lang="en-US" sz="1950" dirty="0"/>
           </a:p>
@@ -10041,6 +10052,28 @@
               <a:buNone/>
             </a:pPr>
             <a:r>
+              <a:rPr lang="en-US" sz="1950" dirty="0" spc="-2" kern="0">
+                <a:solidFill>
+                  <a:srgbClr val="6B6A66"/>
+                </a:solidFill>
+                <a:latin typeface="Be Vietnam Pro" pitchFamily="34" charset="0"/>
+                <a:ea typeface="Be Vietnam Pro" pitchFamily="34" charset="-122"/>
+                <a:cs typeface="Be Vietnam Pro" pitchFamily="34" charset="-120"/>
+              </a:rPr>
+              <a:t>chỉ</a:t>
+            </a:r>
+            <a:r>
+              <a:rPr lang="en-US" sz="1950" dirty="0" spc="-7" kern="0">
+                <a:solidFill>
+                  <a:srgbClr val="6B6A66"/>
+                </a:solidFill>
+                <a:latin typeface="Be Vietnam Pro" pitchFamily="34" charset="0"/>
+                <a:ea typeface="Be Vietnam Pro" pitchFamily="34" charset="-122"/>
+                <a:cs typeface="Be Vietnam Pro" pitchFamily="34" charset="-120"/>
+              </a:rPr>
+              <a:t> số</a:t>
+            </a:r>
+            <a:r>
               <a:rPr lang="en-US" sz="1950" dirty="0" spc="-1" kern="0">
                 <a:solidFill>
                   <a:srgbClr val="6B6A66"/>
@@ -10049,29 +10082,7 @@
                 <a:ea typeface="Be Vietnam Pro" pitchFamily="34" charset="-122"/>
                 <a:cs typeface="Be Vietnam Pro" pitchFamily="34" charset="-120"/>
               </a:rPr>
-              <a:t>vị</a:t>
-            </a:r>
-            <a:r>
-              <a:rPr lang="en-US" sz="1950" dirty="0" spc="10" kern="0">
-                <a:solidFill>
-                  <a:srgbClr val="6B6A66"/>
-                </a:solidFill>
-                <a:latin typeface="Be Vietnam Pro" pitchFamily="34" charset="0"/>
-                <a:ea typeface="Be Vietnam Pro" pitchFamily="34" charset="-122"/>
-                <a:cs typeface="Be Vietnam Pro" pitchFamily="34" charset="-120"/>
-              </a:rPr>
-              <a:t> trí</a:t>
-            </a:r>
-            <a:r>
-              <a:rPr lang="en-US" sz="1950" dirty="0" spc="-3" kern="0">
-                <a:solidFill>
-                  <a:srgbClr val="6B6A66"/>
-                </a:solidFill>
-                <a:latin typeface="Be Vietnam Pro" pitchFamily="34" charset="0"/>
-                <a:ea typeface="Be Vietnam Pro" pitchFamily="34" charset="-122"/>
-                <a:cs typeface="Be Vietnam Pro" pitchFamily="34" charset="-120"/>
-              </a:rPr>
-              <a:t> 4</a:t>
+              <a:t> 3</a:t>
             </a:r>
             <a:endParaRPr lang="en-US" sz="1950" dirty="0"/>
           </a:p>
@@ -11113,7 +11124,7 @@
               <a:t>Không</a:t>
             </a:r>
             <a:r>
-              <a:rPr lang="en-US" sz="3300" b="1" dirty="0" spc="10" kern="0">
+              <a:rPr lang="en-US" sz="3300" b="1" dirty="0" spc="-9" kern="0">
                 <a:solidFill>
                   <a:srgbClr val="3DD6A0"/>
                 </a:solidFill>
@@ -11121,7 +11132,18 @@
                 <a:ea typeface="Be Vietnam Pro" pitchFamily="34" charset="-122"/>
                 <a:cs typeface="Be Vietnam Pro" pitchFamily="34" charset="-120"/>
               </a:rPr>
-              <a:t> chứa</a:t>
+              <a:t> có</a:t>
+            </a:r>
+            <a:r>
+              <a:rPr lang="en-US" sz="3300" b="1" dirty="0" spc="-5" kern="0">
+                <a:solidFill>
+                  <a:srgbClr val="3DD6A0"/>
+                </a:solidFill>
+                <a:latin typeface="Be Vietnam Pro" pitchFamily="34" charset="0"/>
+                <a:ea typeface="Be Vietnam Pro" pitchFamily="34" charset="-122"/>
+                <a:cs typeface="Be Vietnam Pro" pitchFamily="34" charset="-120"/>
+              </a:rPr>
+              <a:t> hai</a:t>
             </a:r>
             <a:r>
               <a:rPr lang="en-US" sz="3300" b="1" dirty="0" spc="-7" kern="0">
@@ -11135,7 +11157,7 @@
               <a:t> phần</a:t>
             </a:r>
             <a:r>
-              <a:rPr lang="en-US" sz="3300" b="1" dirty="0" spc="-4" kern="0">
+              <a:rPr lang="en-US" sz="3300" b="1" dirty="0" spc="-5" kern="0">
                 <a:solidFill>
                   <a:srgbClr val="3DD6A0"/>
                 </a:solidFill>
@@ -11143,10 +11165,10 @@
                 <a:ea typeface="Be Vietnam Pro" pitchFamily="34" charset="-122"/>
                 <a:cs typeface="Be Vietnam Pro" pitchFamily="34" charset="-120"/>
               </a:rPr>
-              <a:t> tử</a:t>
-            </a:r>
-            <a:r>
-              <a:rPr lang="en-US" sz="3300" b="1" dirty="0" spc="-5" kern="0">
+              <a:t> tử bằng</a:t>
+            </a:r>
+            <a:r>
+              <a:rPr lang="en-US" sz="3300" b="1" dirty="0" spc="-3" kern="0">
                 <a:solidFill>
                   <a:srgbClr val="3DD6A0"/>
                 </a:solidFill>
@@ -11154,7 +11176,7 @@
                 <a:ea typeface="Be Vietnam Pro" pitchFamily="34" charset="-122"/>
                 <a:cs typeface="Be Vietnam Pro" pitchFamily="34" charset="-120"/>
               </a:rPr>
-              <a:t> trùng</a:t>
+              <a:t> nhau</a:t>
             </a:r>
             <a:endParaRPr lang="en-US" sz="3300" dirty="0"/>
           </a:p>
@@ -11297,7 +11319,7 @@
               <a:buNone/>
             </a:pPr>
             <a:r>
-              <a:rPr lang="en-US" sz="2250" b="1" dirty="0" spc="-8" kern="0">
+              <a:rPr lang="en-US" sz="2250" b="1" dirty="0" spc="-3" kern="0">
                 <a:solidFill>
                   <a:srgbClr val="14161C"/>
                 </a:solidFill>
@@ -11305,10 +11327,10 @@
                 <a:ea typeface="Be Vietnam Pro" pitchFamily="34" charset="-122"/>
                 <a:cs typeface="Be Vietnam Pro" pitchFamily="34" charset="-120"/>
               </a:rPr>
-              <a:t>không</a:t>
-            </a:r>
-            <a:r>
-              <a:rPr lang="en-US" sz="2250" b="1" dirty="0" spc="-3" kern="0">
+              <a:t>theo</a:t>
+            </a:r>
+            <a:r>
+              <a:rPr lang="en-US" sz="2250" b="1" dirty="0" spc="0" kern="0">
                 <a:solidFill>
                   <a:srgbClr val="14161C"/>
                 </a:solidFill>
@@ -11316,7 +11338,7 @@
                 <a:ea typeface="Be Vietnam Pro" pitchFamily="34" charset="-122"/>
                 <a:cs typeface="Be Vietnam Pro" pitchFamily="34" charset="-120"/>
               </a:rPr>
-              <a:t> trùng</a:t>
+              <a:t> equals</a:t>
             </a:r>
             <a:endParaRPr lang="en-US" sz="2250" dirty="0"/>
           </a:p>
@@ -11531,7 +11553,7 @@
               <a:buNone/>
             </a:pPr>
             <a:r>
-              <a:rPr lang="en-US" sz="2700" dirty="0" spc="0" kern="0">
+              <a:rPr lang="en-US" sz="2700" dirty="0" spc="-39" kern="0">
                 <a:solidFill>
                   <a:srgbClr val="F3EEE3"/>
                 </a:solidFill>
@@ -11539,10 +11561,10 @@
                 <a:ea typeface="Be Vietnam Pro" pitchFamily="34" charset="-122"/>
                 <a:cs typeface="Be Vietnam Pro" pitchFamily="34" charset="-120"/>
               </a:rPr>
-              <a:t>Khác</a:t>
-            </a:r>
-            <a:r>
-              <a:rPr lang="en-US" sz="2700" dirty="0" spc="-6" kern="0">
+              <a:t>Trùng</a:t>
+            </a:r>
+            <a:r>
+              <a:rPr lang="en-US" sz="2700" dirty="0" spc="-1" kern="0">
                 <a:solidFill>
                   <a:srgbClr val="F3EEE3"/>
                 </a:solidFill>
@@ -11550,10 +11572,10 @@
                 <a:ea typeface="Be Vietnam Pro" pitchFamily="34" charset="-122"/>
                 <a:cs typeface="Be Vietnam Pro" pitchFamily="34" charset="-120"/>
               </a:rPr>
-              <a:t> List:</a:t>
-            </a:r>
-            <a:r>
-              <a:rPr lang="en-US" sz="2700" dirty="0" spc="-4" kern="0">
+              <a:t> là</a:t>
+            </a:r>
+            <a:r>
+              <a:rPr lang="en-US" sz="2700" dirty="0" spc="-5" kern="0">
                 <a:solidFill>
                   <a:srgbClr val="F3EEE3"/>
                 </a:solidFill>
@@ -11561,7 +11583,7 @@
                 <a:ea typeface="Be Vietnam Pro" pitchFamily="34" charset="-122"/>
                 <a:cs typeface="Be Vietnam Pro" pitchFamily="34" charset="-120"/>
               </a:rPr>
-              <a:t> Set</a:t>
+              <a:t> bằng</a:t>
             </a:r>
             <a:r>
               <a:rPr lang="en-US" sz="2700" dirty="0" spc="-2" kern="0">
@@ -11572,10 +11594,10 @@
                 <a:ea typeface="Be Vietnam Pro" pitchFamily="34" charset="-122"/>
                 <a:cs typeface="Be Vietnam Pro" pitchFamily="34" charset="-120"/>
               </a:rPr>
-              <a:t> không</a:t>
-            </a:r>
-            <a:r>
-              <a:rPr lang="en-US" sz="2700" dirty="0" spc="6" kern="0">
+              <a:t> nhau theo equals, không</a:t>
+            </a:r>
+            <a:r>
+              <a:rPr lang="en-US" sz="2700" dirty="0" spc="-1" kern="0">
                 <a:solidFill>
                   <a:srgbClr val="F3EEE3"/>
                 </a:solidFill>
@@ -11583,10 +11605,10 @@
                 <a:ea typeface="Be Vietnam Pro" pitchFamily="34" charset="-122"/>
                 <a:cs typeface="Be Vietnam Pro" pitchFamily="34" charset="-120"/>
               </a:rPr>
-              <a:t> chứa</a:t>
-            </a:r>
-            <a:r>
-              <a:rPr lang="en-US" sz="2700" dirty="0" spc="-2" kern="0">
+              <a:t> phải cùng</a:t>
+            </a:r>
+            <a:r>
+              <a:rPr lang="en-US" sz="2700" dirty="0" spc="-7" kern="0">
                 <a:solidFill>
                   <a:srgbClr val="F3EEE3"/>
                 </a:solidFill>
@@ -11594,10 +11616,10 @@
                 <a:ea typeface="Be Vietnam Pro" pitchFamily="34" charset="-122"/>
                 <a:cs typeface="Be Vietnam Pro" pitchFamily="34" charset="-120"/>
               </a:rPr>
-              <a:t> phần</a:t>
-            </a:r>
-            <a:r>
-              <a:rPr lang="en-US" sz="2700" dirty="0" spc="0" kern="0">
+              <a:t> một</a:t>
+            </a:r>
+            <a:r>
+              <a:rPr lang="en-US" sz="2700" dirty="0" spc="12" kern="0">
                 <a:solidFill>
                   <a:srgbClr val="F3EEE3"/>
                 </a:solidFill>
@@ -11605,10 +11627,10 @@
                 <a:ea typeface="Be Vietnam Pro" pitchFamily="34" charset="-122"/>
                 <a:cs typeface="Be Vietnam Pro" pitchFamily="34" charset="-120"/>
               </a:rPr>
-              <a:t> tử</a:t>
-            </a:r>
-            <a:r>
-              <a:rPr lang="en-US" sz="2700" dirty="0" spc="-2" kern="0">
+              <a:t> đối</a:t>
+            </a:r>
+            <a:r>
+              <a:rPr lang="en-US" sz="2700" dirty="0" spc="5" kern="0">
                 <a:solidFill>
                   <a:srgbClr val="F3EEE3"/>
                 </a:solidFill>
@@ -11616,7 +11638,7 @@
                 <a:ea typeface="Be Vietnam Pro" pitchFamily="34" charset="-122"/>
                 <a:cs typeface="Be Vietnam Pro" pitchFamily="34" charset="-120"/>
               </a:rPr>
-              <a:t> trùng.</a:t>
+              <a:t> tượng.</a:t>
             </a:r>
             <a:endParaRPr lang="en-US" sz="2700" dirty="0"/>
           </a:p>
@@ -13255,7 +13277,7 @@
               <a:buNone/>
             </a:pPr>
             <a:r>
-              <a:rPr lang="en-US" sz="2250" b="1" dirty="0" spc="5" kern="0">
+              <a:rPr lang="en-US" sz="2250" b="1" dirty="0" spc="0" kern="0">
                 <a:solidFill>
                   <a:srgbClr val="F3EEE3"/>
                 </a:solidFill>
@@ -13263,10 +13285,10 @@
                 <a:ea typeface="Be Vietnam Pro" pitchFamily="34" charset="-122"/>
                 <a:cs typeface="Be Vietnam Pro" pitchFamily="34" charset="-120"/>
               </a:rPr>
-              <a:t>thường</a:t>
-            </a:r>
-            <a:r>
-              <a:rPr lang="en-US" sz="2250" b="1" dirty="0" spc="-8" kern="0">
+              <a:t>mỗi</a:t>
+            </a:r>
+            <a:r>
+              <a:rPr lang="en-US" sz="2250" b="1" dirty="0" spc="4" kern="0">
                 <a:solidFill>
                   <a:srgbClr val="F3EEE3"/>
                 </a:solidFill>
@@ -13274,10 +13296,10 @@
                 <a:ea typeface="Be Vietnam Pro" pitchFamily="34" charset="-122"/>
                 <a:cs typeface="Be Vietnam Pro" pitchFamily="34" charset="-120"/>
               </a:rPr>
-              <a:t> vào</a:t>
-            </a:r>
-            <a:r>
-              <a:rPr lang="en-US" sz="2250" b="1" dirty="0" spc="9" kern="0">
+              <a:t> thao</a:t>
+            </a:r>
+            <a:r>
+              <a:rPr lang="en-US" sz="2250" b="1" dirty="0" spc="1" kern="0">
                 <a:solidFill>
                   <a:srgbClr val="F3EEE3"/>
                 </a:solidFill>
@@ -13285,10 +13307,10 @@
                 <a:ea typeface="Be Vietnam Pro" pitchFamily="34" charset="-122"/>
                 <a:cs typeface="Be Vietnam Pro" pitchFamily="34" charset="-120"/>
               </a:rPr>
-              <a:t> trước</a:t>
-            </a:r>
-            <a:r>
-              <a:rPr lang="en-US" sz="2250" b="1" dirty="0" spc="-12" kern="0">
+              <a:t> tác</a:t>
+            </a:r>
+            <a:r>
+              <a:rPr lang="en-US" sz="2250" b="1" dirty="0" spc="3" kern="0">
                 <a:solidFill>
                   <a:srgbClr val="F3EEE3"/>
                 </a:solidFill>
@@ -13296,10 +13318,10 @@
                 <a:ea typeface="Be Vietnam Pro" pitchFamily="34" charset="-122"/>
                 <a:cs typeface="Be Vietnam Pro" pitchFamily="34" charset="-120"/>
               </a:rPr>
-              <a:t> ra</a:t>
-            </a:r>
-            <a:r>
-              <a:rPr lang="en-US" sz="2250" b="1" dirty="0" spc="9" kern="0">
+              <a:t> hai</a:t>
+            </a:r>
+            <a:r>
+              <a:rPr lang="en-US" sz="2250" b="1" dirty="0" spc="-3" kern="0">
                 <a:solidFill>
                   <a:srgbClr val="F3EEE3"/>
                 </a:solidFill>
@@ -13307,7 +13329,7 @@
                 <a:ea typeface="Be Vietnam Pro" pitchFamily="34" charset="-122"/>
                 <a:cs typeface="Be Vietnam Pro" pitchFamily="34" charset="-120"/>
               </a:rPr>
-              <a:t> trước</a:t>
+              <a:t> dạng</a:t>
             </a:r>
             <a:endParaRPr lang="en-US" sz="2250" dirty="0"/>
           </a:p>
@@ -14982,7 +15004,7 @@
               <a:t>Map</a:t>
             </a:r>
             <a:r>
-              <a:rPr lang="en-US" sz="2850" dirty="0" spc="-4" kern="0">
+              <a:rPr lang="en-US" sz="2850" dirty="0" spc="0" kern="0">
                 <a:solidFill>
                   <a:srgbClr val="C4C8D6"/>
                 </a:solidFill>
@@ -14990,10 +15012,10 @@
                 <a:ea typeface="Be Vietnam Pro" pitchFamily="34" charset="-122"/>
                 <a:cs typeface="Be Vietnam Pro" pitchFamily="34" charset="-120"/>
               </a:rPr>
-              <a:t> thuộc</a:t>
-            </a:r>
-            <a:r>
-              <a:rPr lang="en-US" sz="2850" dirty="0" spc="2" kern="0">
+              <a:t> ánh</a:t>
+            </a:r>
+            <a:r>
+              <a:rPr lang="en-US" sz="2850" dirty="0" spc="-26" kern="0">
                 <a:solidFill>
                   <a:srgbClr val="C4C8D6"/>
                 </a:solidFill>
@@ -15001,10 +15023,10 @@
                 <a:ea typeface="Be Vietnam Pro" pitchFamily="34" charset="-122"/>
                 <a:cs typeface="Be Vietnam Pro" pitchFamily="34" charset="-120"/>
               </a:rPr>
-              <a:t> JCF</a:t>
-            </a:r>
-            <a:r>
-              <a:rPr lang="en-US" sz="2850" dirty="0" spc="18" kern="0">
+              <a:t> xạ</a:t>
+            </a:r>
+            <a:r>
+              <a:rPr lang="en-US" sz="2850" dirty="0" spc="-3" kern="0">
                 <a:solidFill>
                   <a:srgbClr val="C4C8D6"/>
                 </a:solidFill>
@@ -15012,7 +15034,40 @@
                 <a:ea typeface="Be Vietnam Pro" pitchFamily="34" charset="-122"/>
                 <a:cs typeface="Be Vietnam Pro" pitchFamily="34" charset="-120"/>
               </a:rPr>
-              <a:t> nhưng</a:t>
+              <a:t> khóa</a:t>
+            </a:r>
+            <a:r>
+              <a:rPr lang="en-US" sz="2850" dirty="0" spc="-6" kern="0">
+                <a:solidFill>
+                  <a:srgbClr val="C4C8D6"/>
+                </a:solidFill>
+                <a:latin typeface="Be Vietnam Pro" pitchFamily="34" charset="0"/>
+                <a:ea typeface="Be Vietnam Pro" pitchFamily="34" charset="-122"/>
+                <a:cs typeface="Be Vietnam Pro" pitchFamily="34" charset="-120"/>
+              </a:rPr>
+              <a:t> sang</a:t>
+            </a:r>
+            <a:r>
+              <a:rPr lang="en-US" sz="2850" dirty="0" spc="1" kern="0">
+                <a:solidFill>
+                  <a:srgbClr val="C4C8D6"/>
+                </a:solidFill>
+                <a:latin typeface="Be Vietnam Pro" pitchFamily="34" charset="0"/>
+                <a:ea typeface="Be Vietnam Pro" pitchFamily="34" charset="-122"/>
+                <a:cs typeface="Be Vietnam Pro" pitchFamily="34" charset="-120"/>
+              </a:rPr>
+              <a:t> giá</a:t>
+            </a:r>
+            <a:r>
+              <a:rPr lang="en-US" sz="2850" dirty="0" spc="12" kern="0">
+                <a:solidFill>
+                  <a:srgbClr val="C4C8D6"/>
+                </a:solidFill>
+                <a:latin typeface="Be Vietnam Pro" pitchFamily="34" charset="0"/>
+                <a:ea typeface="Be Vietnam Pro" pitchFamily="34" charset="-122"/>
+                <a:cs typeface="Be Vietnam Pro" pitchFamily="34" charset="-120"/>
+              </a:rPr>
+              <a:t> trị,</a:t>
             </a:r>
             <a:r>
               <a:rPr lang="en-US" sz="2850" dirty="0" spc="-2" kern="0">
@@ -15026,7 +15081,7 @@
               <a:t> không</a:t>
             </a:r>
             <a:r>
-              <a:rPr lang="en-US" sz="2850" dirty="0" spc="-44" kern="0">
+              <a:rPr lang="en-US" sz="2850" dirty="0" spc="-1" kern="0">
                 <a:solidFill>
                   <a:srgbClr val="C4C8D6"/>
                 </a:solidFill>
@@ -15034,10 +15089,10 @@
                 <a:ea typeface="Be Vietnam Pro" pitchFamily="34" charset="-122"/>
                 <a:cs typeface="Be Vietnam Pro" pitchFamily="34" charset="-120"/>
               </a:rPr>
-              <a:t> kế</a:t>
-            </a:r>
-            <a:r>
-              <a:rPr lang="en-US" sz="2850" dirty="0" spc="9" kern="0">
+              <a:t> có</a:t>
+            </a:r>
+            <a:r>
+              <a:rPr lang="en-US" sz="2850" dirty="0" spc="-3" kern="0">
                 <a:solidFill>
                   <a:srgbClr val="C4C8D6"/>
                 </a:solidFill>
@@ -15045,7 +15100,7 @@
                 <a:ea typeface="Be Vietnam Pro" pitchFamily="34" charset="-122"/>
                 <a:cs typeface="Be Vietnam Pro" pitchFamily="34" charset="-120"/>
               </a:rPr>
-              <a:t> thừa</a:t>
+              <a:t> khóa</a:t>
             </a:r>
             <a:r>
               <a:rPr lang="en-US" sz="2850" dirty="0" spc="-1" kern="0">
@@ -15056,7 +15111,7 @@
                 <a:ea typeface="Be Vietnam Pro" pitchFamily="34" charset="-122"/>
                 <a:cs typeface="Be Vietnam Pro" pitchFamily="34" charset="-120"/>
               </a:rPr>
-              <a:t> Collection.</a:t>
+              <a:t> trùng.</a:t>
             </a:r>
             <a:endParaRPr lang="en-US" sz="2850" dirty="0"/>
           </a:p>
@@ -15091,7 +15146,7 @@
               <a:buNone/>
             </a:pPr>
             <a:r>
-              <a:rPr lang="en-US" sz="2250" b="1" dirty="0" spc="0" kern="0">
+              <a:rPr lang="en-US" sz="2250" b="1" dirty="0">
                 <a:solidFill>
                   <a:srgbClr val="14161C"/>
                 </a:solidFill>
@@ -15099,18 +15154,7 @@
                 <a:ea typeface="Be Vietnam Pro" pitchFamily="34" charset="-122"/>
                 <a:cs typeface="Be Vietnam Pro" pitchFamily="34" charset="-120"/>
               </a:rPr>
-              <a:t>thuộc</a:t>
-            </a:r>
-            <a:r>
-              <a:rPr lang="en-US" sz="2250" b="1" dirty="0" spc="3" kern="0">
-                <a:solidFill>
-                  <a:srgbClr val="14161C"/>
-                </a:solidFill>
-                <a:latin typeface="Be Vietnam Pro" pitchFamily="34" charset="0"/>
-                <a:ea typeface="Be Vietnam Pro" pitchFamily="34" charset="-122"/>
-                <a:cs typeface="Be Vietnam Pro" pitchFamily="34" charset="-120"/>
-              </a:rPr>
-              <a:t> JCF</a:t>
+              <a:t>khóa → giá trị</a:t>
             </a:r>
             <a:endParaRPr lang="en-US" sz="2250" dirty="0"/>
           </a:p>
@@ -15145,7 +15189,7 @@
               <a:buNone/>
             </a:pPr>
             <a:r>
-              <a:rPr lang="en-US" sz="2250" b="1" dirty="0" spc="-1" kern="0">
+              <a:rPr lang="en-US" sz="2250" b="1" dirty="0" spc="-3" kern="0">
                 <a:solidFill>
                   <a:srgbClr val="14161C"/>
                 </a:solidFill>
@@ -15153,10 +15197,10 @@
                 <a:ea typeface="Be Vietnam Pro" pitchFamily="34" charset="-122"/>
                 <a:cs typeface="Be Vietnam Pro" pitchFamily="34" charset="-120"/>
               </a:rPr>
-              <a:t>họ</a:t>
-            </a:r>
-            <a:r>
-              <a:rPr lang="en-US" sz="2250" b="1" dirty="0" spc="-5" kern="0">
+              <a:t>khóa</a:t>
+            </a:r>
+            <a:r>
+              <a:rPr lang="en-US" sz="2250" b="1" dirty="0" spc="-6" kern="0">
                 <a:solidFill>
                   <a:srgbClr val="14161C"/>
                 </a:solidFill>
@@ -15164,10 +15208,10 @@
                 <a:ea typeface="Be Vietnam Pro" pitchFamily="34" charset="-122"/>
                 <a:cs typeface="Be Vietnam Pro" pitchFamily="34" charset="-120"/>
               </a:rPr>
-              <a:t> interface</a:t>
-            </a:r>
-            <a:r>
-              <a:rPr lang="en-US" sz="2250" b="1" dirty="0" spc="1" kern="0">
+              <a:t> không</a:t>
+            </a:r>
+            <a:r>
+              <a:rPr lang="en-US" sz="2250" b="1" dirty="0" spc="-2" kern="0">
                 <a:solidFill>
                   <a:srgbClr val="14161C"/>
                 </a:solidFill>
@@ -15175,7 +15219,7 @@
                 <a:ea typeface="Be Vietnam Pro" pitchFamily="34" charset="-122"/>
                 <a:cs typeface="Be Vietnam Pro" pitchFamily="34" charset="-120"/>
               </a:rPr>
-              <a:t> riêng</a:t>
+              <a:t> trùng</a:t>
             </a:r>
             <a:endParaRPr lang="en-US" sz="2250" dirty="0"/>
           </a:p>
@@ -15311,7 +15355,7 @@
                 <a:ea typeface="Be Vietnam Pro" pitchFamily="34" charset="-122"/>
                 <a:cs typeface="Be Vietnam Pro" pitchFamily="34" charset="-120"/>
               </a:rPr>
-              <a:t>Map</a:t>
+              <a:t>Map là</a:t>
             </a:r>
             <a:r>
               <a:rPr lang="en-US" sz="2700" dirty="0" spc="-2" kern="0">
@@ -15322,9 +15366,64 @@
                 <a:ea typeface="Be Vietnam Pro" pitchFamily="34" charset="-122"/>
                 <a:cs typeface="Be Vietnam Pro" pitchFamily="34" charset="-120"/>
               </a:rPr>
+              <a:t> hợp</a:t>
+            </a:r>
+            <a:r>
+              <a:rPr lang="en-US" sz="2700" dirty="0" spc="9" kern="0">
+                <a:solidFill>
+                  <a:srgbClr val="F3EEE3"/>
+                </a:solidFill>
+                <a:latin typeface="Be Vietnam Pro" pitchFamily="34" charset="0"/>
+                <a:ea typeface="Be Vietnam Pro" pitchFamily="34" charset="-122"/>
+                <a:cs typeface="Be Vietnam Pro" pitchFamily="34" charset="-120"/>
+              </a:rPr>
+              <a:t> đồng</a:t>
+            </a:r>
+            <a:r>
+              <a:rPr lang="en-US" sz="2700" dirty="0" spc="6" kern="0">
+                <a:solidFill>
+                  <a:srgbClr val="F3EEE3"/>
+                </a:solidFill>
+                <a:latin typeface="Be Vietnam Pro" pitchFamily="34" charset="0"/>
+                <a:ea typeface="Be Vietnam Pro" pitchFamily="34" charset="-122"/>
+                <a:cs typeface="Be Vietnam Pro" pitchFamily="34" charset="-120"/>
+              </a:rPr>
+              <a:t> riêng,</a:t>
+            </a:r>
+            <a:r>
+              <a:rPr lang="en-US" sz="2700" dirty="0" spc="-3" kern="0">
+                <a:solidFill>
+                  <a:srgbClr val="F3EEE3"/>
+                </a:solidFill>
+                <a:latin typeface="Be Vietnam Pro" pitchFamily="34" charset="0"/>
+                <a:ea typeface="Be Vietnam Pro" pitchFamily="34" charset="-122"/>
+                <a:cs typeface="Be Vietnam Pro" pitchFamily="34" charset="-120"/>
+              </a:rPr>
               <a:t> không</a:t>
             </a:r>
             <a:r>
+              <a:rPr lang="en-US" sz="2700" dirty="0" spc="-43" kern="0">
+                <a:solidFill>
+                  <a:srgbClr val="F3EEE3"/>
+                </a:solidFill>
+                <a:latin typeface="Be Vietnam Pro" pitchFamily="34" charset="0"/>
+                <a:ea typeface="Be Vietnam Pro" pitchFamily="34" charset="-122"/>
+                <a:cs typeface="Be Vietnam Pro" pitchFamily="34" charset="-120"/>
+              </a:rPr>
+              <a:t> kế</a:t>
+            </a:r>
+            <a:r>
+              <a:rPr lang="en-US" sz="2700" dirty="0" spc="6" kern="0">
+                <a:solidFill>
+                  <a:srgbClr val="F3EEE3"/>
+                </a:solidFill>
+                <a:latin typeface="Be Vietnam Pro" pitchFamily="34" charset="0"/>
+                <a:ea typeface="Be Vietnam Pro" pitchFamily="34" charset="-122"/>
+                <a:cs typeface="Be Vietnam Pro" pitchFamily="34" charset="-120"/>
+              </a:rPr>
+              <a:t> thừa</a:t>
+            </a:r>
+            <a:r>
               <a:rPr lang="en-US" sz="2700" dirty="0" spc="-1" kern="0">
                 <a:solidFill>
                   <a:srgbClr val="F3EEE3"/>
@@ -15333,84 +15432,7 @@
                 <a:ea typeface="Be Vietnam Pro" pitchFamily="34" charset="-122"/>
                 <a:cs typeface="Be Vietnam Pro" pitchFamily="34" charset="-120"/>
               </a:rPr>
-              <a:t> phải</a:t>
-            </a:r>
-            <a:r>
-              <a:rPr lang="en-US" sz="2700" dirty="0" spc="-2" kern="0">
-                <a:solidFill>
-                  <a:srgbClr val="F3EEE3"/>
-                </a:solidFill>
-                <a:latin typeface="Be Vietnam Pro" pitchFamily="34" charset="0"/>
-                <a:ea typeface="Be Vietnam Pro" pitchFamily="34" charset="-122"/>
-                <a:cs typeface="Be Vietnam Pro" pitchFamily="34" charset="-120"/>
-              </a:rPr>
-              <a:t> nhánh của</a:t>
-            </a:r>
-            <a:r>
-              <a:rPr lang="en-US" sz="2700" dirty="0" spc="0" kern="0">
-                <a:solidFill>
-                  <a:srgbClr val="F3EEE3"/>
-                </a:solidFill>
-                <a:latin typeface="Be Vietnam Pro" pitchFamily="34" charset="0"/>
-                <a:ea typeface="Be Vietnam Pro" pitchFamily="34" charset="-122"/>
-                <a:cs typeface="Be Vietnam Pro" pitchFamily="34" charset="-120"/>
-              </a:rPr>
-              <a:t> Collection,</a:t>
-            </a:r>
-            <a:r>
-              <a:rPr lang="en-US" sz="2700" dirty="0" spc="-2" kern="0">
-                <a:solidFill>
-                  <a:srgbClr val="F3EEE3"/>
-                </a:solidFill>
-                <a:latin typeface="Be Vietnam Pro" pitchFamily="34" charset="0"/>
-                <a:ea typeface="Be Vietnam Pro" pitchFamily="34" charset="-122"/>
-                <a:cs typeface="Be Vietnam Pro" pitchFamily="34" charset="-120"/>
-              </a:rPr>
-              <a:t> mà</a:t>
-            </a:r>
-            <a:r>
-              <a:rPr lang="en-US" sz="2700" dirty="0" spc="-1" kern="0">
-                <a:solidFill>
-                  <a:srgbClr val="F3EEE3"/>
-                </a:solidFill>
-                <a:latin typeface="Be Vietnam Pro" pitchFamily="34" charset="0"/>
-                <a:ea typeface="Be Vietnam Pro" pitchFamily="34" charset="-122"/>
-                <a:cs typeface="Be Vietnam Pro" pitchFamily="34" charset="-120"/>
-              </a:rPr>
-              <a:t> là</a:t>
-            </a:r>
-            <a:r>
-              <a:rPr lang="en-US" sz="2700" dirty="0" spc="-2" kern="0">
-                <a:solidFill>
-                  <a:srgbClr val="F3EEE3"/>
-                </a:solidFill>
-                <a:latin typeface="Be Vietnam Pro" pitchFamily="34" charset="0"/>
-                <a:ea typeface="Be Vietnam Pro" pitchFamily="34" charset="-122"/>
-                <a:cs typeface="Be Vietnam Pro" pitchFamily="34" charset="-120"/>
-              </a:rPr>
-              <a:t> họ</a:t>
-            </a:r>
-            <a:r>
-              <a:rPr lang="en-US" sz="2700" dirty="0" spc="-15" kern="0">
-                <a:solidFill>
-                  <a:srgbClr val="F3EEE3"/>
-                </a:solidFill>
-                <a:latin typeface="Be Vietnam Pro" pitchFamily="34" charset="0"/>
-                <a:ea typeface="Be Vietnam Pro" pitchFamily="34" charset="-122"/>
-                <a:cs typeface="Be Vietnam Pro" pitchFamily="34" charset="-120"/>
-              </a:rPr>
-              <a:t> interface</a:t>
-            </a:r>
-            <a:r>
-              <a:rPr lang="en-US" sz="2700" dirty="0" spc="5" kern="0">
-                <a:solidFill>
-                  <a:srgbClr val="F3EEE3"/>
-                </a:solidFill>
-                <a:latin typeface="Be Vietnam Pro" pitchFamily="34" charset="0"/>
-                <a:ea typeface="Be Vietnam Pro" pitchFamily="34" charset="-122"/>
-                <a:cs typeface="Be Vietnam Pro" pitchFamily="34" charset="-120"/>
-              </a:rPr>
-              <a:t> riêng.</a:t>
+              <a:t> Collection.</a:t>
             </a:r>
             <a:endParaRPr lang="en-US" sz="2700" dirty="0"/>
           </a:p>
@@ -15556,7 +15578,7 @@
               <a:buNone/>
             </a:pPr>
             <a:r>
-              <a:rPr lang="en-US" sz="2100" b="1" dirty="0" spc="3" kern="0">
+              <a:rPr lang="en-US" sz="2100" b="1" dirty="0" spc="-15" kern="0">
                 <a:solidFill>
                   <a:srgbClr val="9AA0B5"/>
                 </a:solidFill>
@@ -15564,7 +15586,7 @@
                 <a:ea typeface="Be Vietnam Pro" pitchFamily="34" charset="-122"/>
                 <a:cs typeface="Be Vietnam Pro" pitchFamily="34" charset="-120"/>
               </a:rPr>
-              <a:t>JCF</a:t>
+              <a:t>java.util</a:t>
             </a:r>
             <a:endParaRPr lang="en-US" sz="2100" dirty="0"/>
           </a:p>
@@ -16014,7 +16036,7 @@
               <a:buNone/>
             </a:pPr>
             <a:r>
-              <a:rPr lang="en-US" sz="2100" b="1" dirty="0" spc="-8" kern="0">
+              <a:rPr lang="en-US" sz="2100" b="1" dirty="0" spc="-5" kern="0">
                 <a:solidFill>
                   <a:srgbClr val="FF6A4D"/>
                 </a:solidFill>
@@ -16022,10 +16044,10 @@
                 <a:ea typeface="Be Vietnam Pro" pitchFamily="34" charset="-122"/>
                 <a:cs typeface="Be Vietnam Pro" pitchFamily="34" charset="-120"/>
               </a:rPr>
-              <a:t>họ</a:t>
-            </a:r>
-            <a:r>
-              <a:rPr lang="en-US" sz="2100" b="1" dirty="0" spc="-9" kern="0">
+              <a:t>hợp</a:t>
+            </a:r>
+            <a:r>
+              <a:rPr lang="en-US" sz="2100" b="1" dirty="0" spc="-3" kern="0">
                 <a:solidFill>
                   <a:srgbClr val="FF6A4D"/>
                 </a:solidFill>
@@ -16033,10 +16055,10 @@
                 <a:ea typeface="Be Vietnam Pro" pitchFamily="34" charset="-122"/>
                 <a:cs typeface="Be Vietnam Pro" pitchFamily="34" charset="-120"/>
               </a:rPr>
-              <a:t> interface</a:t>
-            </a:r>
-            <a:r>
-              <a:rPr lang="en-US" sz="2100" b="1" dirty="0" spc="0" kern="0">
+              <a:t> đồng</a:t>
+            </a:r>
+            <a:r>
+              <a:rPr lang="en-US" sz="2100" b="1" dirty="0" spc="-1" kern="0">
                 <a:solidFill>
                   <a:srgbClr val="FF6A4D"/>
                 </a:solidFill>
@@ -16684,10 +16706,10 @@
                 <a:ea typeface="Be Vietnam Pro" pitchFamily="34" charset="-122"/>
                 <a:cs typeface="Be Vietnam Pro" pitchFamily="34" charset="-120"/>
               </a:rPr>
-              <a:t>Chỉ</a:t>
-            </a:r>
-            <a:r>
-              <a:rPr lang="en-US" sz="3000" b="1" dirty="0" spc="10" kern="0">
+              <a:t>Để</a:t>
+            </a:r>
+            <a:r>
+              <a:rPr lang="en-US" sz="3000" b="1" dirty="0" spc="-9" kern="0">
                 <a:solidFill>
                   <a:srgbClr val="E8472B"/>
                 </a:solidFill>
@@ -16695,10 +16717,10 @@
                 <a:ea typeface="Be Vietnam Pro" pitchFamily="34" charset="-122"/>
                 <a:cs typeface="Be Vietnam Pro" pitchFamily="34" charset="-120"/>
               </a:rPr>
-              <a:t> để</a:t>
-            </a:r>
-            <a:r>
-              <a:rPr lang="en-US" sz="3000" b="1" dirty="0" spc="-9" kern="0">
+              <a:t> thấy</a:t>
+            </a:r>
+            <a:r>
+              <a:rPr lang="en-US" sz="3000" b="1" dirty="0" spc="-4" kern="0">
                 <a:solidFill>
                   <a:srgbClr val="E8472B"/>
                 </a:solidFill>
@@ -16706,7 +16728,7 @@
                 <a:ea typeface="Be Vietnam Pro" pitchFamily="34" charset="-122"/>
                 <a:cs typeface="Be Vietnam Pro" pitchFamily="34" charset="-120"/>
               </a:rPr>
-              <a:t> thấy</a:t>
+              <a:t> ba</a:t>
             </a:r>
             <a:r>
               <a:rPr lang="en-US" sz="3000" b="1" dirty="0" spc="-3" kern="0">
@@ -16717,7 +16739,7 @@
                 <a:ea typeface="Be Vietnam Pro" pitchFamily="34" charset="-122"/>
                 <a:cs typeface="Be Vietnam Pro" pitchFamily="34" charset="-120"/>
               </a:rPr>
-              <a:t> ba nhánh</a:t>
+              <a:t> hợp đồng</a:t>
             </a:r>
             <a:r>
               <a:rPr lang="en-US" sz="3000" b="1" dirty="0" spc="0" kern="0">
@@ -16847,7 +16869,7 @@
               <a:buChar char="•"/>
             </a:pPr>
             <a:r>
-              <a:rPr lang="en-US" sz="2550" dirty="0" spc="-33" kern="0">
+              <a:rPr lang="en-US" sz="2550" dirty="0" spc="-2" kern="0">
                 <a:solidFill>
                   <a:srgbClr val="14161C"/>
                 </a:solidFill>
@@ -16855,10 +16877,10 @@
                 <a:ea typeface="Be Vietnam Pro" pitchFamily="34" charset="-122"/>
                 <a:cs typeface="Be Vietnam Pro" pitchFamily="34" charset="-120"/>
               </a:rPr>
-              <a:t>Lớp</a:t>
-            </a:r>
-            <a:r>
-              <a:rPr lang="en-US" sz="2550" dirty="0" spc="-2" kern="0">
+              <a:t>Deque</a:t>
+            </a:r>
+            <a:r>
+              <a:rPr lang="en-US" sz="2550" dirty="0" spc="1" kern="0">
                 <a:solidFill>
                   <a:srgbClr val="14161C"/>
                 </a:solidFill>
@@ -16866,7 +16888,18 @@
                 <a:ea typeface="Be Vietnam Pro" pitchFamily="34" charset="-122"/>
                 <a:cs typeface="Be Vietnam Pro" pitchFamily="34" charset="-120"/>
               </a:rPr>
-              <a:t> cụ</a:t>
+              <a:t> nằm</a:t>
+            </a:r>
+            <a:r>
+              <a:rPr lang="en-US" sz="2550" dirty="0" spc="6" kern="0">
+                <a:solidFill>
+                  <a:srgbClr val="14161C"/>
+                </a:solidFill>
+                <a:latin typeface="Be Vietnam Pro" pitchFamily="34" charset="0"/>
+                <a:ea typeface="Be Vietnam Pro" pitchFamily="34" charset="-122"/>
+                <a:cs typeface="Be Vietnam Pro" pitchFamily="34" charset="-120"/>
+              </a:rPr>
+              <a:t> giữa</a:t>
             </a:r>
             <a:r>
               <a:rPr lang="en-US" sz="2550" dirty="0" spc="2" kern="0">
@@ -16877,10 +16910,10 @@
                 <a:ea typeface="Be Vietnam Pro" pitchFamily="34" charset="-122"/>
                 <a:cs typeface="Be Vietnam Pro" pitchFamily="34" charset="-120"/>
               </a:rPr>
-              <a:t> thể</a:t>
-            </a:r>
-            <a:r>
-              <a:rPr lang="en-US" sz="2550" dirty="0" spc="-1" kern="0">
+              <a:t> Queue</a:t>
+            </a:r>
+            <a:r>
+              <a:rPr lang="en-US" sz="2550" dirty="0" spc="-18" kern="0">
                 <a:solidFill>
                   <a:srgbClr val="14161C"/>
                 </a:solidFill>
@@ -16888,10 +16921,10 @@
                 <a:ea typeface="Be Vietnam Pro" pitchFamily="34" charset="-122"/>
                 <a:cs typeface="Be Vietnam Pro" pitchFamily="34" charset="-120"/>
               </a:rPr>
-              <a:t> còn</a:t>
-            </a:r>
-            <a:r>
-              <a:rPr lang="en-US" sz="2550" dirty="0" spc="1" kern="0">
+              <a:t> và</a:t>
+            </a:r>
+            <a:r>
+              <a:rPr lang="en-US" sz="2550" dirty="0" spc="-14" kern="0">
                 <a:solidFill>
                   <a:srgbClr val="14161C"/>
                 </a:solidFill>
@@ -16899,29 +16932,7 @@
                 <a:ea typeface="Be Vietnam Pro" pitchFamily="34" charset="-122"/>
                 <a:cs typeface="Be Vietnam Pro" pitchFamily="34" charset="-120"/>
               </a:rPr>
-              <a:t> nhiều</a:t>
-            </a:r>
-            <a:r>
-              <a:rPr lang="en-US" sz="2550" dirty="0" spc="-15" kern="0">
-                <a:solidFill>
-                  <a:srgbClr val="14161C"/>
-                </a:solidFill>
-                <a:latin typeface="Be Vietnam Pro" pitchFamily="34" charset="0"/>
-                <a:ea typeface="Be Vietnam Pro" pitchFamily="34" charset="-122"/>
-                <a:cs typeface="Be Vietnam Pro" pitchFamily="34" charset="-120"/>
-              </a:rPr>
-              <a:t> interface</a:t>
-            </a:r>
-            <a:r>
-              <a:rPr lang="en-US" sz="2550" dirty="0" spc="0" kern="0">
-                <a:solidFill>
-                  <a:srgbClr val="14161C"/>
-                </a:solidFill>
-                <a:latin typeface="Be Vietnam Pro" pitchFamily="34" charset="0"/>
-                <a:ea typeface="Be Vietnam Pro" pitchFamily="34" charset="-122"/>
-                <a:cs typeface="Be Vietnam Pro" pitchFamily="34" charset="-120"/>
-              </a:rPr>
-              <a:t> khác</a:t>
+              <a:t> ArrayDeque</a:t>
             </a:r>
             <a:endParaRPr lang="en-US" sz="2550" dirty="0"/>
           </a:p>
@@ -16935,7 +16946,7 @@
               <a:buChar char="•"/>
             </a:pPr>
             <a:r>
-              <a:rPr lang="en-US" sz="2550" dirty="0" spc="-6" kern="0">
+              <a:rPr lang="en-US" sz="2550" dirty="0" spc="-4" kern="0">
                 <a:solidFill>
                   <a:srgbClr val="14161C"/>
                 </a:solidFill>
@@ -16943,7 +16954,73 @@
                 <a:ea typeface="Be Vietnam Pro" pitchFamily="34" charset="-122"/>
                 <a:cs typeface="Be Vietnam Pro" pitchFamily="34" charset="-120"/>
               </a:rPr>
-              <a:t>List</a:t>
+              <a:t>Thứ</a:t>
+            </a:r>
+            <a:r>
+              <a:rPr lang="en-US" sz="2550" dirty="0" spc="-1" kern="0">
+                <a:solidFill>
+                  <a:srgbClr val="14161C"/>
+                </a:solidFill>
+                <a:latin typeface="Be Vietnam Pro" pitchFamily="34" charset="0"/>
+                <a:ea typeface="Be Vietnam Pro" pitchFamily="34" charset="-122"/>
+                <a:cs typeface="Be Vietnam Pro" pitchFamily="34" charset="-120"/>
+              </a:rPr>
+              <a:t> tự</a:t>
+            </a:r>
+            <a:r>
+              <a:rPr lang="en-US" sz="2550" dirty="0" spc="-9" kern="0">
+                <a:solidFill>
+                  <a:srgbClr val="14161C"/>
+                </a:solidFill>
+                <a:latin typeface="Be Vietnam Pro" pitchFamily="34" charset="0"/>
+                <a:ea typeface="Be Vietnam Pro" pitchFamily="34" charset="-122"/>
+                <a:cs typeface="Be Vietnam Pro" pitchFamily="34" charset="-120"/>
+              </a:rPr>
+              <a:t> lấy</a:t>
+            </a:r>
+            <a:r>
+              <a:rPr lang="en-US" sz="2550" dirty="0" spc="-35" kern="0">
+                <a:solidFill>
+                  <a:srgbClr val="14161C"/>
+                </a:solidFill>
+                <a:latin typeface="Be Vietnam Pro" pitchFamily="34" charset="0"/>
+                <a:ea typeface="Be Vietnam Pro" pitchFamily="34" charset="-122"/>
+                <a:cs typeface="Be Vietnam Pro" pitchFamily="34" charset="-120"/>
+              </a:rPr>
+              <a:t> ra</a:t>
+            </a:r>
+            <a:r>
+              <a:rPr lang="en-US" sz="2550" dirty="0" spc="0" kern="0">
+                <a:solidFill>
+                  <a:srgbClr val="14161C"/>
+                </a:solidFill>
+                <a:latin typeface="Be Vietnam Pro" pitchFamily="34" charset="0"/>
+                <a:ea typeface="Be Vietnam Pro" pitchFamily="34" charset="-122"/>
+                <a:cs typeface="Be Vietnam Pro" pitchFamily="34" charset="-120"/>
+              </a:rPr>
+              <a:t> do</a:t>
+            </a:r>
+            <a:r>
+              <a:rPr lang="en-US" sz="2550" dirty="0" spc="20" kern="0">
+                <a:solidFill>
+                  <a:srgbClr val="14161C"/>
+                </a:solidFill>
+                <a:latin typeface="Be Vietnam Pro" pitchFamily="34" charset="0"/>
+                <a:ea typeface="Be Vietnam Pro" pitchFamily="34" charset="-122"/>
+                <a:cs typeface="Be Vietnam Pro" pitchFamily="34" charset="-120"/>
+              </a:rPr>
+              <a:t> từng</a:t>
+            </a:r>
+            <a:r>
+              <a:rPr lang="en-US" sz="2550" dirty="0" spc="0" kern="0">
+                <a:solidFill>
+                  <a:srgbClr val="14161C"/>
+                </a:solidFill>
+                <a:latin typeface="Be Vietnam Pro" pitchFamily="34" charset="0"/>
+                <a:ea typeface="Be Vietnam Pro" pitchFamily="34" charset="-122"/>
+                <a:cs typeface="Be Vietnam Pro" pitchFamily="34" charset="-120"/>
+              </a:rPr>
+              <a:t> lớp</a:t>
             </a:r>
             <a:r>
               <a:rPr lang="en-US" sz="2550" dirty="0" spc="1" kern="0">
@@ -16954,10 +17031,10 @@
                 <a:ea typeface="Be Vietnam Pro" pitchFamily="34" charset="-122"/>
                 <a:cs typeface="Be Vietnam Pro" pitchFamily="34" charset="-120"/>
               </a:rPr>
-              <a:t> chỉ</a:t>
-            </a:r>
-            <a:r>
-              <a:rPr lang="en-US" sz="2550" dirty="0" spc="5" kern="0">
+              <a:t> quy</a:t>
+            </a:r>
+            <a:r>
+              <a:rPr lang="en-US" sz="2550" dirty="0" spc="18" kern="0">
                 <a:solidFill>
                   <a:srgbClr val="14161C"/>
                 </a:solidFill>
@@ -16965,106 +17042,7 @@
                 <a:ea typeface="Be Vietnam Pro" pitchFamily="34" charset="-122"/>
                 <a:cs typeface="Be Vietnam Pro" pitchFamily="34" charset="-120"/>
               </a:rPr>
-              <a:t> thường</a:t>
-            </a:r>
-            <a:r>
-              <a:rPr lang="en-US" sz="2550" dirty="0" spc="-1" kern="0">
-                <a:solidFill>
-                  <a:srgbClr val="14161C"/>
-                </a:solidFill>
-                <a:latin typeface="Be Vietnam Pro" pitchFamily="34" charset="0"/>
-                <a:ea typeface="Be Vietnam Pro" pitchFamily="34" charset="-122"/>
-                <a:cs typeface="Be Vietnam Pro" pitchFamily="34" charset="-120"/>
-              </a:rPr>
-              <a:t> cho</a:t>
-            </a:r>
-            <a:r>
-              <a:rPr lang="en-US" sz="2550" dirty="0" spc="0" kern="0">
-                <a:solidFill>
-                  <a:srgbClr val="14161C"/>
-                </a:solidFill>
-                <a:latin typeface="Be Vietnam Pro" pitchFamily="34" charset="0"/>
-                <a:ea typeface="Be Vietnam Pro" pitchFamily="34" charset="-122"/>
-                <a:cs typeface="Be Vietnam Pro" pitchFamily="34" charset="-120"/>
-              </a:rPr>
-              <a:t> phép trùng;</a:t>
-            </a:r>
-            <a:r>
-              <a:rPr lang="en-US" sz="2550" dirty="0" spc="-6" kern="0">
-                <a:solidFill>
-                  <a:srgbClr val="14161C"/>
-                </a:solidFill>
-                <a:latin typeface="Be Vietnam Pro" pitchFamily="34" charset="0"/>
-                <a:ea typeface="Be Vietnam Pro" pitchFamily="34" charset="-122"/>
-                <a:cs typeface="Be Vietnam Pro" pitchFamily="34" charset="-120"/>
-              </a:rPr>
-              <a:t> một</a:t>
-            </a:r>
-            <a:r>
-              <a:rPr lang="en-US" sz="2550" dirty="0" spc="0" kern="0">
-                <a:solidFill>
-                  <a:srgbClr val="14161C"/>
-                </a:solidFill>
-                <a:latin typeface="Be Vietnam Pro" pitchFamily="34" charset="0"/>
-                <a:ea typeface="Be Vietnam Pro" pitchFamily="34" charset="-122"/>
-                <a:cs typeface="Be Vietnam Pro" pitchFamily="34" charset="-120"/>
-              </a:rPr>
-              <a:t> cài</a:t>
-            </a:r>
-            <a:r>
-              <a:rPr lang="en-US" sz="2550" dirty="0" spc="2" kern="0">
-                <a:solidFill>
-                  <a:srgbClr val="14161C"/>
-                </a:solidFill>
-                <a:latin typeface="Be Vietnam Pro" pitchFamily="34" charset="0"/>
-                <a:ea typeface="Be Vietnam Pro" pitchFamily="34" charset="-122"/>
-                <a:cs typeface="Be Vietnam Pro" pitchFamily="34" charset="-120"/>
-              </a:rPr>
-              <a:t> đặt</a:t>
-            </a:r>
-            <a:r>
-              <a:rPr lang="en-US" sz="2550" dirty="0" spc="0" kern="0">
-                <a:solidFill>
-                  <a:srgbClr val="14161C"/>
-                </a:solidFill>
-                <a:latin typeface="Be Vietnam Pro" pitchFamily="34" charset="0"/>
-                <a:ea typeface="Be Vietnam Pro" pitchFamily="34" charset="-122"/>
-                <a:cs typeface="Be Vietnam Pro" pitchFamily="34" charset="-120"/>
-              </a:rPr>
-              <a:t> có</a:t>
-            </a:r>
-            <a:r>
-              <a:rPr lang="en-US" sz="2550" dirty="0" spc="1" kern="0">
-                <a:solidFill>
-                  <a:srgbClr val="14161C"/>
-                </a:solidFill>
-                <a:latin typeface="Be Vietnam Pro" pitchFamily="34" charset="0"/>
-                <a:ea typeface="Be Vietnam Pro" pitchFamily="34" charset="-122"/>
-                <a:cs typeface="Be Vietnam Pro" pitchFamily="34" charset="-120"/>
-              </a:rPr>
-              <a:t> thể</a:t>
-            </a:r>
-            <a:r>
-              <a:rPr lang="en-US" sz="2550" dirty="0" spc="-1" kern="0">
-                <a:solidFill>
-                  <a:srgbClr val="14161C"/>
-                </a:solidFill>
-                <a:latin typeface="Be Vietnam Pro" pitchFamily="34" charset="0"/>
-                <a:ea typeface="Be Vietnam Pro" pitchFamily="34" charset="-122"/>
-                <a:cs typeface="Be Vietnam Pro" pitchFamily="34" charset="-120"/>
-              </a:rPr>
-              <a:t> từ</a:t>
-            </a:r>
-            <a:r>
-              <a:rPr lang="en-US" sz="2550" dirty="0" spc="0" kern="0">
-                <a:solidFill>
-                  <a:srgbClr val="14161C"/>
-                </a:solidFill>
-                <a:latin typeface="Be Vietnam Pro" pitchFamily="34" charset="0"/>
-                <a:ea typeface="Be Vietnam Pro" pitchFamily="34" charset="-122"/>
-                <a:cs typeface="Be Vietnam Pro" pitchFamily="34" charset="-120"/>
-              </a:rPr>
-              <a:t> chối.</a:t>
+              <a:t> định.</a:t>
             </a:r>
             <a:endParaRPr lang="en-US" sz="2550" dirty="0"/>
           </a:p>
@@ -17949,7 +17927,7 @@
               <a:t> ba</a:t>
             </a:r>
             <a:r>
-              <a:rPr lang="en-US" sz="1950" dirty="0" spc="1" kern="0">
+              <a:rPr lang="en-US" sz="1950" dirty="0" spc="-2" kern="0">
                 <a:solidFill>
                   <a:srgbClr val="6B6A66"/>
                 </a:solidFill>
@@ -17957,7 +17935,18 @@
                 <a:ea typeface="Be Vietnam Pro" pitchFamily="34" charset="-122"/>
                 <a:cs typeface="Be Vietnam Pro" pitchFamily="34" charset="-120"/>
               </a:rPr>
-              <a:t> nhánh</a:t>
+              <a:t> hợp</a:t>
+            </a:r>
+            <a:r>
+              <a:rPr lang="en-US" sz="1950" dirty="0" spc="9" kern="0">
+                <a:solidFill>
+                  <a:srgbClr val="6B6A66"/>
+                </a:solidFill>
+                <a:latin typeface="Be Vietnam Pro" pitchFamily="34" charset="0"/>
+                <a:ea typeface="Be Vietnam Pro" pitchFamily="34" charset="-122"/>
+                <a:cs typeface="Be Vietnam Pro" pitchFamily="34" charset="-120"/>
+              </a:rPr>
+              <a:t> đồng</a:t>
             </a:r>
             <a:r>
               <a:rPr lang="en-US" sz="1950" dirty="0" spc="0" kern="0">
@@ -18509,14 +18498,14 @@
           <a:ln/>
         </p:spPr>
         <p:txBody>
-          <a:bodyPr wrap="square" lIns="0" tIns="0" rIns="0" bIns="0" rtlCol="0" anchor="ctr"/>
+          <a:bodyPr wrap="square" lIns="0" tIns="0" rIns="0" bIns="0" rtlCol="0" anchor="t"/>
           <a:lstStyle/>
           <a:p>
             <a:pPr algn="l" indent="0" marL="0">
               <a:buNone/>
             </a:pPr>
             <a:r>
-              <a:rPr lang="en-US" sz="6900" dirty="0" spc="6" kern="0">
+              <a:rPr lang="en-US" sz="6900" dirty="0" spc="0" kern="0">
                 <a:solidFill>
                   <a:srgbClr val="F3EEE3"/>
                 </a:solidFill>
@@ -18524,10 +18513,10 @@
                 <a:ea typeface="Bricolage Grotesque ExtraBold" pitchFamily="34" charset="-122"/>
                 <a:cs typeface="Bricolage Grotesque ExtraBold" pitchFamily="34" charset="-120"/>
               </a:rPr>
-              <a:t>Chọn</a:t>
-            </a:r>
-            <a:r>
-              <a:rPr lang="en-US" sz="6900" dirty="0" spc="2" kern="0">
+              <a:t>Mỗi thứ</a:t>
+            </a:r>
+            <a:r>
+              <a:rPr lang="en-US" sz="6900" dirty="0" spc="-1" kern="0">
                 <a:solidFill>
                   <a:srgbClr val="F3EEE3"/>
                 </a:solidFill>
@@ -18535,10 +18524,10 @@
                 <a:ea typeface="Bricolage Grotesque ExtraBold" pitchFamily="34" charset="-122"/>
                 <a:cs typeface="Bricolage Grotesque ExtraBold" pitchFamily="34" charset="-120"/>
               </a:rPr>
-              <a:t> nhánh</a:t>
-            </a:r>
-            <a:r>
-              <a:rPr lang="en-US" sz="6900" dirty="0" spc="-39" kern="0">
+              <a:t> ở</a:t>
+            </a:r>
+            <a:r>
+              <a:rPr lang="en-US" sz="6900" dirty="0" spc="4" kern="0">
                 <a:solidFill>
                   <a:srgbClr val="F3EEE3"/>
                 </a:solidFill>
@@ -18546,7 +18535,7 @@
                 <a:ea typeface="Bricolage Grotesque ExtraBold" pitchFamily="34" charset="-122"/>
                 <a:cs typeface="Bricolage Grotesque ExtraBold" pitchFamily="34" charset="-120"/>
               </a:rPr>
-              <a:t> nào?</a:t>
+              <a:t> đâu?</a:t>
             </a:r>
             <a:endParaRPr lang="en-US" sz="6900" dirty="0"/>
           </a:p>
@@ -18580,7 +18569,7 @@
               <a:buNone/>
             </a:pPr>
             <a:r>
-              <a:rPr lang="en-US" sz="2850" dirty="0" spc="-3" kern="0">
+              <a:rPr lang="en-US" sz="2850" dirty="0">
                 <a:solidFill>
                   <a:srgbClr val="C4C8D6"/>
                 </a:solidFill>
@@ -18588,194 +18577,7 @@
                 <a:ea typeface="Be Vietnam Pro" pitchFamily="34" charset="-122"/>
                 <a:cs typeface="Be Vietnam Pro" pitchFamily="34" charset="-120"/>
               </a:rPr>
-              <a:t>Bạn</a:t>
-            </a:r>
-            <a:r>
-              <a:rPr lang="en-US" sz="2850" dirty="0" spc="-1" kern="0">
-                <a:solidFill>
-                  <a:srgbClr val="C4C8D6"/>
-                </a:solidFill>
-                <a:latin typeface="Be Vietnam Pro" pitchFamily="34" charset="0"/>
-                <a:ea typeface="Be Vietnam Pro" pitchFamily="34" charset="-122"/>
-                <a:cs typeface="Be Vietnam Pro" pitchFamily="34" charset="-120"/>
-              </a:rPr>
-              <a:t> cần</a:t>
-            </a:r>
-            <a:r>
-              <a:rPr lang="en-US" sz="2850" dirty="0" spc="24" kern="0">
-                <a:solidFill>
-                  <a:srgbClr val="C4C8D6"/>
-                </a:solidFill>
-                <a:latin typeface="Be Vietnam Pro" pitchFamily="34" charset="0"/>
-                <a:ea typeface="Be Vietnam Pro" pitchFamily="34" charset="-122"/>
-                <a:cs typeface="Be Vietnam Pro" pitchFamily="34" charset="-120"/>
-              </a:rPr>
-              <a:t> lưu</a:t>
-            </a:r>
-            <a:r>
-              <a:rPr lang="en-US" sz="2850" dirty="0" spc="0" kern="0">
-                <a:solidFill>
-                  <a:srgbClr val="C4C8D6"/>
-                </a:solidFill>
-                <a:latin typeface="Be Vietnam Pro" pitchFamily="34" charset="0"/>
-                <a:ea typeface="Be Vietnam Pro" pitchFamily="34" charset="-122"/>
-                <a:cs typeface="Be Vietnam Pro" pitchFamily="34" charset="-120"/>
-              </a:rPr>
-              <a:t> danh</a:t>
-            </a:r>
-            <a:r>
-              <a:rPr lang="en-US" sz="2850" dirty="0" spc="-6" kern="0">
-                <a:solidFill>
-                  <a:srgbClr val="C4C8D6"/>
-                </a:solidFill>
-                <a:latin typeface="Be Vietnam Pro" pitchFamily="34" charset="0"/>
-                <a:ea typeface="Be Vietnam Pro" pitchFamily="34" charset="-122"/>
-                <a:cs typeface="Be Vietnam Pro" pitchFamily="34" charset="-120"/>
-              </a:rPr>
-              <a:t> sách</a:t>
-            </a:r>
-            <a:r>
-              <a:rPr lang="en-US" sz="2850" dirty="0" spc="0" kern="0">
-                <a:solidFill>
-                  <a:srgbClr val="C4C8D6"/>
-                </a:solidFill>
-                <a:latin typeface="Be Vietnam Pro" pitchFamily="34" charset="0"/>
-                <a:ea typeface="Be Vietnam Pro" pitchFamily="34" charset="-122"/>
-                <a:cs typeface="Be Vietnam Pro" pitchFamily="34" charset="-120"/>
-              </a:rPr>
-              <a:t> mã</a:t>
-            </a:r>
-            <a:r>
-              <a:rPr lang="en-US" sz="2850" dirty="0" spc="16" kern="0">
-                <a:solidFill>
-                  <a:srgbClr val="C4C8D6"/>
-                </a:solidFill>
-                <a:latin typeface="Be Vietnam Pro" pitchFamily="34" charset="0"/>
-                <a:ea typeface="Be Vietnam Pro" pitchFamily="34" charset="-122"/>
-                <a:cs typeface="Be Vietnam Pro" pitchFamily="34" charset="-120"/>
-              </a:rPr>
-              <a:t> đơn</a:t>
-            </a:r>
-            <a:r>
-              <a:rPr lang="en-US" sz="2850" dirty="0" spc="-2" kern="0">
-                <a:solidFill>
-                  <a:srgbClr val="C4C8D6"/>
-                </a:solidFill>
-                <a:latin typeface="Be Vietnam Pro" pitchFamily="34" charset="0"/>
-                <a:ea typeface="Be Vietnam Pro" pitchFamily="34" charset="-122"/>
-                <a:cs typeface="Be Vietnam Pro" pitchFamily="34" charset="-120"/>
-              </a:rPr>
-              <a:t> hàng</a:t>
-            </a:r>
-            <a:r>
-              <a:rPr lang="en-US" sz="2850" dirty="0" spc="21" kern="0">
-                <a:solidFill>
-                  <a:srgbClr val="C4C8D6"/>
-                </a:solidFill>
-                <a:latin typeface="Be Vietnam Pro" pitchFamily="34" charset="0"/>
-                <a:ea typeface="Be Vietnam Pro" pitchFamily="34" charset="-122"/>
-                <a:cs typeface="Be Vietnam Pro" pitchFamily="34" charset="-120"/>
-              </a:rPr>
-              <a:t> đã</a:t>
-            </a:r>
-            <a:r>
-              <a:rPr lang="en-US" sz="2850" dirty="0" spc="2" kern="0">
-                <a:solidFill>
-                  <a:srgbClr val="C4C8D6"/>
-                </a:solidFill>
-                <a:latin typeface="Be Vietnam Pro" pitchFamily="34" charset="0"/>
-                <a:ea typeface="Be Vietnam Pro" pitchFamily="34" charset="-122"/>
-                <a:cs typeface="Be Vietnam Pro" pitchFamily="34" charset="-120"/>
-              </a:rPr>
-              <a:t> xử lý</a:t>
-            </a:r>
-            <a:r>
-              <a:rPr lang="en-US" sz="2850" dirty="0" spc="-16" kern="0">
-                <a:solidFill>
-                  <a:srgbClr val="C4C8D6"/>
-                </a:solidFill>
-                <a:latin typeface="Be Vietnam Pro" pitchFamily="34" charset="0"/>
-                <a:ea typeface="Be Vietnam Pro" pitchFamily="34" charset="-122"/>
-                <a:cs typeface="Be Vietnam Pro" pitchFamily="34" charset="-120"/>
-              </a:rPr>
-              <a:t> và</a:t>
-            </a:r>
-            <a:r>
-              <a:rPr lang="en-US" sz="2850" dirty="0" spc="-2" kern="0">
-                <a:solidFill>
-                  <a:srgbClr val="C4C8D6"/>
-                </a:solidFill>
-                <a:latin typeface="Be Vietnam Pro" pitchFamily="34" charset="0"/>
-                <a:ea typeface="Be Vietnam Pro" pitchFamily="34" charset="-122"/>
-                <a:cs typeface="Be Vietnam Pro" pitchFamily="34" charset="-120"/>
-              </a:rPr>
-              <a:t> không muốn</a:t>
-            </a:r>
-            <a:r>
-              <a:rPr lang="en-US" sz="2850" dirty="0" spc="-9" kern="0">
-                <a:solidFill>
-                  <a:srgbClr val="C4C8D6"/>
-                </a:solidFill>
-                <a:latin typeface="Be Vietnam Pro" pitchFamily="34" charset="0"/>
-                <a:ea typeface="Be Vietnam Pro" pitchFamily="34" charset="-122"/>
-                <a:cs typeface="Be Vietnam Pro" pitchFamily="34" charset="-120"/>
-              </a:rPr>
-              <a:t> một</a:t>
-            </a:r>
-            <a:r>
-              <a:rPr lang="en-US" sz="2850" dirty="0" spc="-1" kern="0">
-                <a:solidFill>
-                  <a:srgbClr val="C4C8D6"/>
-                </a:solidFill>
-                <a:latin typeface="Be Vietnam Pro" pitchFamily="34" charset="0"/>
-                <a:ea typeface="Be Vietnam Pro" pitchFamily="34" charset="-122"/>
-                <a:cs typeface="Be Vietnam Pro" pitchFamily="34" charset="-120"/>
-              </a:rPr>
-              <a:t> mã</a:t>
-            </a:r>
-            <a:r>
-              <a:rPr lang="en-US" sz="2850" dirty="0" spc="-10" kern="0">
-                <a:solidFill>
-                  <a:srgbClr val="C4C8D6"/>
-                </a:solidFill>
-                <a:latin typeface="Be Vietnam Pro" pitchFamily="34" charset="0"/>
-                <a:ea typeface="Be Vietnam Pro" pitchFamily="34" charset="-122"/>
-                <a:cs typeface="Be Vietnam Pro" pitchFamily="34" charset="-120"/>
-              </a:rPr>
-              <a:t> xuất</a:t>
-            </a:r>
-            <a:r>
-              <a:rPr lang="en-US" sz="2850" dirty="0" spc="0" kern="0">
-                <a:solidFill>
-                  <a:srgbClr val="C4C8D6"/>
-                </a:solidFill>
-                <a:latin typeface="Be Vietnam Pro" pitchFamily="34" charset="0"/>
-                <a:ea typeface="Be Vietnam Pro" pitchFamily="34" charset="-122"/>
-                <a:cs typeface="Be Vietnam Pro" pitchFamily="34" charset="-120"/>
-              </a:rPr>
-              <a:t> hiện</a:t>
-            </a:r>
-            <a:r>
-              <a:rPr lang="en-US" sz="2850" dirty="0" spc="3" kern="0">
-                <a:solidFill>
-                  <a:srgbClr val="C4C8D6"/>
-                </a:solidFill>
-                <a:latin typeface="Be Vietnam Pro" pitchFamily="34" charset="0"/>
-                <a:ea typeface="Be Vietnam Pro" pitchFamily="34" charset="-122"/>
-                <a:cs typeface="Be Vietnam Pro" pitchFamily="34" charset="-120"/>
-              </a:rPr>
-              <a:t> hai</a:t>
-            </a:r>
-            <a:r>
-              <a:rPr lang="en-US" sz="2850" dirty="0" spc="1" kern="0">
-                <a:solidFill>
-                  <a:srgbClr val="C4C8D6"/>
-                </a:solidFill>
-                <a:latin typeface="Be Vietnam Pro" pitchFamily="34" charset="0"/>
-                <a:ea typeface="Be Vietnam Pro" pitchFamily="34" charset="-122"/>
-                <a:cs typeface="Be Vietnam Pro" pitchFamily="34" charset="-120"/>
-              </a:rPr>
-              <a:t> lần.</a:t>
+              <a:t>Cần ba thứ: mã khách đã xử lý không trùng, việc chờ lấy việc gấp trước, bảng tra mã khách → số lần.</a:t>
             </a:r>
             <a:endParaRPr lang="en-US" sz="2850" dirty="0"/>
           </a:p>
@@ -18903,7 +18705,7 @@
               <a:buNone/>
             </a:pPr>
             <a:r>
-              <a:rPr lang="en-US" sz="2700" b="1" dirty="0" spc="-5" kern="0">
+              <a:rPr lang="en-US" sz="2700" b="1" dirty="0" spc="-6" kern="0">
                 <a:solidFill>
                   <a:srgbClr val="F3EEE3"/>
                 </a:solidFill>
@@ -18911,7 +18713,51 @@
                 <a:ea typeface="Be Vietnam Pro" pitchFamily="34" charset="-122"/>
                 <a:cs typeface="Be Vietnam Pro" pitchFamily="34" charset="-120"/>
               </a:rPr>
-              <a:t>Chọn</a:t>
+              <a:t>Mỗi</a:t>
+            </a:r>
+            <a:r>
+              <a:rPr lang="en-US" sz="2700" b="1" dirty="0" spc="-2" kern="0">
+                <a:solidFill>
+                  <a:srgbClr val="F3EEE3"/>
+                </a:solidFill>
+                <a:latin typeface="Be Vietnam Pro" pitchFamily="34" charset="0"/>
+                <a:ea typeface="Be Vietnam Pro" pitchFamily="34" charset="-122"/>
+                <a:cs typeface="Be Vietnam Pro" pitchFamily="34" charset="-120"/>
+              </a:rPr>
+              <a:t> thứ</a:t>
+            </a:r>
+            <a:r>
+              <a:rPr lang="en-US" sz="2700" b="1" dirty="0" spc="-6" kern="0">
+                <a:solidFill>
+                  <a:srgbClr val="F3EEE3"/>
+                </a:solidFill>
+                <a:latin typeface="Be Vietnam Pro" pitchFamily="34" charset="0"/>
+                <a:ea typeface="Be Vietnam Pro" pitchFamily="34" charset="-122"/>
+                <a:cs typeface="Be Vietnam Pro" pitchFamily="34" charset="-120"/>
+              </a:rPr>
+              <a:t> nên</a:t>
+            </a:r>
+            <a:r>
+              <a:rPr lang="en-US" sz="2700" b="1" dirty="0" spc="-4" kern="0">
+                <a:solidFill>
+                  <a:srgbClr val="F3EEE3"/>
+                </a:solidFill>
+                <a:latin typeface="Be Vietnam Pro" pitchFamily="34" charset="0"/>
+                <a:ea typeface="Be Vietnam Pro" pitchFamily="34" charset="-122"/>
+                <a:cs typeface="Be Vietnam Pro" pitchFamily="34" charset="-120"/>
+              </a:rPr>
+              <a:t> nằm</a:t>
+            </a:r>
+            <a:r>
+              <a:rPr lang="en-US" sz="2700" b="1" dirty="0" spc="0" kern="0">
+                <a:solidFill>
+                  <a:srgbClr val="F3EEE3"/>
+                </a:solidFill>
+                <a:latin typeface="Be Vietnam Pro" pitchFamily="34" charset="0"/>
+                <a:ea typeface="Be Vietnam Pro" pitchFamily="34" charset="-122"/>
+                <a:cs typeface="Be Vietnam Pro" pitchFamily="34" charset="-120"/>
+              </a:rPr>
+              <a:t> ở nhánh</a:t>
             </a:r>
             <a:r>
               <a:rPr lang="en-US" sz="2700" b="1" dirty="0" spc="1" kern="0">
@@ -18922,10 +18768,10 @@
                 <a:ea typeface="Be Vietnam Pro" pitchFamily="34" charset="-122"/>
                 <a:cs typeface="Be Vietnam Pro" pitchFamily="34" charset="-120"/>
               </a:rPr>
-              <a:t> nhánh</a:t>
-            </a:r>
-            <a:r>
-              <a:rPr lang="en-US" sz="2700" b="1" dirty="0" spc="0" kern="0">
+              <a:t> nào</a:t>
+            </a:r>
+            <a:r>
+              <a:rPr lang="en-US" sz="2700" b="1" dirty="0" spc="-1" kern="0">
                 <a:solidFill>
                   <a:srgbClr val="F3EEE3"/>
                 </a:solidFill>
@@ -18933,10 +18779,10 @@
                 <a:ea typeface="Be Vietnam Pro" pitchFamily="34" charset="-122"/>
                 <a:cs typeface="Be Vietnam Pro" pitchFamily="34" charset="-120"/>
               </a:rPr>
-              <a:t> nào</a:t>
-            </a:r>
-            <a:r>
-              <a:rPr lang="en-US" sz="2700" b="1" dirty="0" spc="-1" kern="0">
+              <a:t> của</a:t>
+            </a:r>
+            <a:r>
+              <a:rPr lang="en-US" sz="2700" b="1" dirty="0" spc="-10" kern="0">
                 <a:solidFill>
                   <a:srgbClr val="F3EEE3"/>
                 </a:solidFill>
@@ -18944,106 +18790,7 @@
                 <a:ea typeface="Be Vietnam Pro" pitchFamily="34" charset="-122"/>
                 <a:cs typeface="Be Vietnam Pro" pitchFamily="34" charset="-120"/>
               </a:rPr>
-              <a:t> của</a:t>
-            </a:r>
-            <a:r>
-              <a:rPr lang="en-US" sz="2700" b="1" dirty="0" spc="-10" kern="0">
-                <a:solidFill>
-                  <a:srgbClr val="F3EEE3"/>
-                </a:solidFill>
-                <a:latin typeface="Be Vietnam Pro" pitchFamily="34" charset="0"/>
-                <a:ea typeface="Be Vietnam Pro" pitchFamily="34" charset="-122"/>
-                <a:cs typeface="Be Vietnam Pro" pitchFamily="34" charset="-120"/>
-              </a:rPr>
               <a:t> cây?</a:t>
-            </a:r>
-            <a:r>
-              <a:rPr lang="en-US" sz="2700" b="1" dirty="0" spc="-3" kern="0">
-                <a:solidFill>
-                  <a:srgbClr val="F3EEE3"/>
-                </a:solidFill>
-                <a:latin typeface="Be Vietnam Pro" pitchFamily="34" charset="0"/>
-                <a:ea typeface="Be Vietnam Pro" pitchFamily="34" charset="-122"/>
-                <a:cs typeface="Be Vietnam Pro" pitchFamily="34" charset="-120"/>
-              </a:rPr>
-              <a:t> Map</a:t>
-            </a:r>
-            <a:r>
-              <a:rPr lang="en-US" sz="2700" b="1" dirty="0" spc="-7" kern="0">
-                <a:solidFill>
-                  <a:srgbClr val="F3EEE3"/>
-                </a:solidFill>
-                <a:latin typeface="Be Vietnam Pro" pitchFamily="34" charset="0"/>
-                <a:ea typeface="Be Vietnam Pro" pitchFamily="34" charset="-122"/>
-                <a:cs typeface="Be Vietnam Pro" pitchFamily="34" charset="-120"/>
-              </a:rPr>
-              <a:t> có</a:t>
-            </a:r>
-            <a:r>
-              <a:rPr lang="en-US" sz="2700" b="1" dirty="0" spc="-4" kern="0">
-                <a:solidFill>
-                  <a:srgbClr val="F3EEE3"/>
-                </a:solidFill>
-                <a:latin typeface="Be Vietnam Pro" pitchFamily="34" charset="0"/>
-                <a:ea typeface="Be Vietnam Pro" pitchFamily="34" charset="-122"/>
-                <a:cs typeface="Be Vietnam Pro" pitchFamily="34" charset="-120"/>
-              </a:rPr>
-              <a:t> phải</a:t>
-            </a:r>
-            <a:r>
-              <a:rPr lang="en-US" sz="2700" b="1" dirty="0" spc="14" kern="0">
-                <a:solidFill>
-                  <a:srgbClr val="F3EEE3"/>
-                </a:solidFill>
-                <a:latin typeface="Be Vietnam Pro" pitchFamily="34" charset="0"/>
-                <a:ea typeface="Be Vietnam Pro" pitchFamily="34" charset="-122"/>
-                <a:cs typeface="Be Vietnam Pro" pitchFamily="34" charset="-120"/>
-              </a:rPr>
-              <a:t> lựa</a:t>
-            </a:r>
-            <a:r>
-              <a:rPr lang="en-US" sz="2700" b="1" dirty="0" spc="-6" kern="0">
-                <a:solidFill>
-                  <a:srgbClr val="F3EEE3"/>
-                </a:solidFill>
-                <a:latin typeface="Be Vietnam Pro" pitchFamily="34" charset="0"/>
-                <a:ea typeface="Be Vietnam Pro" pitchFamily="34" charset="-122"/>
-                <a:cs typeface="Be Vietnam Pro" pitchFamily="34" charset="-120"/>
-              </a:rPr>
-              <a:t> chọn</a:t>
-            </a:r>
-            <a:r>
-              <a:rPr lang="en-US" sz="2700" b="1" dirty="0" spc="-4" kern="0">
-                <a:solidFill>
-                  <a:srgbClr val="F3EEE3"/>
-                </a:solidFill>
-                <a:latin typeface="Be Vietnam Pro" pitchFamily="34" charset="0"/>
-                <a:ea typeface="Be Vietnam Pro" pitchFamily="34" charset="-122"/>
-                <a:cs typeface="Be Vietnam Pro" pitchFamily="34" charset="-120"/>
-              </a:rPr>
-              <a:t> tự</a:t>
-            </a:r>
-            <a:r>
-              <a:rPr lang="en-US" sz="2700" b="1" dirty="0" spc="-1" kern="0">
-                <a:solidFill>
-                  <a:srgbClr val="F3EEE3"/>
-                </a:solidFill>
-                <a:latin typeface="Be Vietnam Pro" pitchFamily="34" charset="0"/>
-                <a:ea typeface="Be Vietnam Pro" pitchFamily="34" charset="-122"/>
-                <a:cs typeface="Be Vietnam Pro" pitchFamily="34" charset="-120"/>
-              </a:rPr>
-              <a:t> nhiên</a:t>
-            </a:r>
-            <a:r>
-              <a:rPr lang="en-US" sz="2700" b="1" dirty="0" spc="-5" kern="0">
-                <a:solidFill>
-                  <a:srgbClr val="F3EEE3"/>
-                </a:solidFill>
-                <a:latin typeface="Be Vietnam Pro" pitchFamily="34" charset="0"/>
-                <a:ea typeface="Be Vietnam Pro" pitchFamily="34" charset="-122"/>
-                <a:cs typeface="Be Vietnam Pro" pitchFamily="34" charset="-120"/>
-              </a:rPr>
-              <a:t> không?</a:t>
             </a:r>
             <a:endParaRPr lang="en-US" sz="2700" dirty="0"/>
           </a:p>
@@ -19221,7 +18968,7 @@
               <a:buNone/>
             </a:pPr>
             <a:r>
-              <a:rPr lang="en-US" sz="2850" b="1" dirty="0" spc="-9" kern="0">
+              <a:rPr lang="en-US" sz="2850" b="1" dirty="0" spc="-5" kern="0">
                 <a:solidFill>
                   <a:srgbClr val="3DD6A0"/>
                 </a:solidFill>
@@ -19229,10 +18976,10 @@
                 <a:ea typeface="Be Vietnam Pro" pitchFamily="34" charset="-122"/>
                 <a:cs typeface="Be Vietnam Pro" pitchFamily="34" charset="-120"/>
               </a:rPr>
-              <a:t>Chọn</a:t>
-            </a:r>
-            <a:r>
-              <a:rPr lang="en-US" sz="2850" b="1" dirty="0" spc="0" kern="0">
+              <a:t>Mã</a:t>
+            </a:r>
+            <a:r>
+              <a:rPr lang="en-US" sz="2850" b="1" dirty="0" spc="10" kern="0">
                 <a:solidFill>
                   <a:srgbClr val="3DD6A0"/>
                 </a:solidFill>
@@ -19240,7 +18987,29 @@
                 <a:ea typeface="Be Vietnam Pro" pitchFamily="34" charset="-122"/>
                 <a:cs typeface="Be Vietnam Pro" pitchFamily="34" charset="-120"/>
               </a:rPr>
-              <a:t> nhánh</a:t>
+              <a:t> đã</a:t>
+            </a:r>
+            <a:r>
+              <a:rPr lang="en-US" sz="2850" b="1" dirty="0" spc="1" kern="0">
+                <a:solidFill>
+                  <a:srgbClr val="3DD6A0"/>
+                </a:solidFill>
+                <a:latin typeface="Be Vietnam Pro" pitchFamily="34" charset="0"/>
+                <a:ea typeface="Be Vietnam Pro" pitchFamily="34" charset="-122"/>
+                <a:cs typeface="Be Vietnam Pro" pitchFamily="34" charset="-120"/>
+              </a:rPr>
+              <a:t> xử</a:t>
+            </a:r>
+            <a:r>
+              <a:rPr lang="en-US" sz="2850" b="1" dirty="0" spc="2" kern="0">
+                <a:solidFill>
+                  <a:srgbClr val="3DD6A0"/>
+                </a:solidFill>
+                <a:latin typeface="Be Vietnam Pro" pitchFamily="34" charset="0"/>
+                <a:ea typeface="Be Vietnam Pro" pitchFamily="34" charset="-122"/>
+                <a:cs typeface="Be Vietnam Pro" pitchFamily="34" charset="-120"/>
+              </a:rPr>
+              <a:t> lý:</a:t>
             </a:r>
             <a:r>
               <a:rPr lang="en-US" sz="2850" b="1" dirty="0" spc="-7" kern="0">
@@ -19285,7 +19054,7 @@
               <a:buNone/>
             </a:pPr>
             <a:r>
-              <a:rPr lang="en-US" sz="2250" dirty="0" spc="-7" kern="0">
+              <a:rPr lang="en-US" sz="2250" dirty="0" spc="1" kern="0">
                 <a:solidFill>
                   <a:srgbClr val="F3EEE3"/>
                 </a:solidFill>
@@ -19293,7 +19062,29 @@
                 <a:ea typeface="Be Vietnam Pro" pitchFamily="34" charset="-122"/>
                 <a:cs typeface="Be Vietnam Pro" pitchFamily="34" charset="-120"/>
               </a:rPr>
-              <a:t>Set</a:t>
+              <a:t>Không</a:t>
+            </a:r>
+            <a:r>
+              <a:rPr lang="en-US" sz="2250" dirty="0" spc="5" kern="0">
+                <a:solidFill>
+                  <a:srgbClr val="F3EEE3"/>
+                </a:solidFill>
+                <a:latin typeface="Be Vietnam Pro" pitchFamily="34" charset="0"/>
+                <a:ea typeface="Be Vietnam Pro" pitchFamily="34" charset="-122"/>
+                <a:cs typeface="Be Vietnam Pro" pitchFamily="34" charset="-120"/>
+              </a:rPr>
+              <a:t> có</a:t>
+            </a:r>
+            <a:r>
+              <a:rPr lang="en-US" sz="2250" dirty="0" spc="-2" kern="0">
+                <a:solidFill>
+                  <a:srgbClr val="F3EEE3"/>
+                </a:solidFill>
+                <a:latin typeface="Be Vietnam Pro" pitchFamily="34" charset="0"/>
+                <a:ea typeface="Be Vietnam Pro" pitchFamily="34" charset="-122"/>
+                <a:cs typeface="Be Vietnam Pro" pitchFamily="34" charset="-120"/>
+              </a:rPr>
+              <a:t> hai</a:t>
             </a:r>
             <a:r>
               <a:rPr lang="en-US" sz="2250" dirty="0" spc="1" kern="0">
@@ -19304,10 +19095,10 @@
                 <a:ea typeface="Be Vietnam Pro" pitchFamily="34" charset="-122"/>
                 <a:cs typeface="Be Vietnam Pro" pitchFamily="34" charset="-120"/>
               </a:rPr>
-              <a:t> không</a:t>
-            </a:r>
-            <a:r>
-              <a:rPr lang="en-US" sz="2250" dirty="0" spc="8" kern="0">
+              <a:t> phần</a:t>
+            </a:r>
+            <a:r>
+              <a:rPr lang="en-US" sz="2250" dirty="0" spc="3" kern="0">
                 <a:solidFill>
                   <a:srgbClr val="F3EEE3"/>
                 </a:solidFill>
@@ -19315,10 +19106,10 @@
                 <a:ea typeface="Be Vietnam Pro" pitchFamily="34" charset="-122"/>
                 <a:cs typeface="Be Vietnam Pro" pitchFamily="34" charset="-120"/>
               </a:rPr>
-              <a:t> chứa</a:t>
-            </a:r>
-            <a:r>
-              <a:rPr lang="en-US" sz="2250" dirty="0" spc="1" kern="0">
+              <a:t> tử</a:t>
+            </a:r>
+            <a:r>
+              <a:rPr lang="en-US" sz="2250" dirty="0" spc="-2" kern="0">
                 <a:solidFill>
                   <a:srgbClr val="F3EEE3"/>
                 </a:solidFill>
@@ -19326,10 +19117,10 @@
                 <a:ea typeface="Be Vietnam Pro" pitchFamily="34" charset="-122"/>
                 <a:cs typeface="Be Vietnam Pro" pitchFamily="34" charset="-120"/>
               </a:rPr>
-              <a:t> phần</a:t>
-            </a:r>
-            <a:r>
-              <a:rPr lang="en-US" sz="2250" dirty="0" spc="4" kern="0">
+              <a:t> bằng</a:t>
+            </a:r>
+            <a:r>
+              <a:rPr lang="en-US" sz="2250" dirty="0" spc="0" kern="0">
                 <a:solidFill>
                   <a:srgbClr val="F3EEE3"/>
                 </a:solidFill>
@@ -19337,10 +19128,10 @@
                 <a:ea typeface="Be Vietnam Pro" pitchFamily="34" charset="-122"/>
                 <a:cs typeface="Be Vietnam Pro" pitchFamily="34" charset="-120"/>
               </a:rPr>
-              <a:t> tử</a:t>
-            </a:r>
-            <a:r>
-              <a:rPr lang="en-US" sz="2250" dirty="0" spc="1" kern="0">
+              <a:t> nhau</a:t>
+            </a:r>
+            <a:r>
+              <a:rPr lang="en-US" sz="2250" dirty="0" spc="-3" kern="0">
                 <a:solidFill>
                   <a:srgbClr val="F3EEE3"/>
                 </a:solidFill>
@@ -19348,7 +19139,18 @@
                 <a:ea typeface="Be Vietnam Pro" pitchFamily="34" charset="-122"/>
                 <a:cs typeface="Be Vietnam Pro" pitchFamily="34" charset="-120"/>
               </a:rPr>
-              <a:t> trùng.</a:t>
+              <a:t> theo</a:t>
+            </a:r>
+            <a:r>
+              <a:rPr lang="en-US" sz="2250" dirty="0" spc="0" kern="0">
+                <a:solidFill>
+                  <a:srgbClr val="F3EEE3"/>
+                </a:solidFill>
+                <a:latin typeface="Be Vietnam Pro" pitchFamily="34" charset="0"/>
+                <a:ea typeface="Be Vietnam Pro" pitchFamily="34" charset="-122"/>
+                <a:cs typeface="Be Vietnam Pro" pitchFamily="34" charset="-120"/>
+              </a:rPr>
+              <a:t> equals.</a:t>
             </a:r>
             <a:endParaRPr lang="en-US" sz="2250" dirty="0"/>
           </a:p>
@@ -19449,7 +19251,7 @@
               <a:buNone/>
             </a:pPr>
             <a:r>
-              <a:rPr lang="en-US" sz="2850" b="1" dirty="0" spc="-27" kern="0">
+              <a:rPr lang="en-US" sz="2850" b="1" dirty="0" spc="-1" kern="0">
                 <a:solidFill>
                   <a:srgbClr val="3DD6A0"/>
                 </a:solidFill>
@@ -19457,10 +19259,10 @@
                 <a:ea typeface="Be Vietnam Pro" pitchFamily="34" charset="-122"/>
                 <a:cs typeface="Be Vietnam Pro" pitchFamily="34" charset="-120"/>
               </a:rPr>
-              <a:t>Lớp</a:t>
-            </a:r>
-            <a:r>
-              <a:rPr lang="en-US" sz="2850" b="1" dirty="0" spc="7" kern="0">
+              <a:t>Việc</a:t>
+            </a:r>
+            <a:r>
+              <a:rPr lang="en-US" sz="2850" b="1" dirty="0" spc="-2" kern="0">
                 <a:solidFill>
                   <a:srgbClr val="3DD6A0"/>
                 </a:solidFill>
@@ -19468,10 +19270,10 @@
                 <a:ea typeface="Be Vietnam Pro" pitchFamily="34" charset="-122"/>
                 <a:cs typeface="Be Vietnam Pro" pitchFamily="34" charset="-120"/>
               </a:rPr>
-              <a:t> thường</a:t>
-            </a:r>
-            <a:r>
-              <a:rPr lang="en-US" sz="2850" b="1" dirty="0" spc="1" kern="0">
+              <a:t> chờ:</a:t>
+            </a:r>
+            <a:r>
+              <a:rPr lang="en-US" sz="2850" b="1" dirty="0" spc="6" kern="0">
                 <a:solidFill>
                   <a:srgbClr val="3DD6A0"/>
                 </a:solidFill>
@@ -19479,18 +19281,7 @@
                 <a:ea typeface="Be Vietnam Pro" pitchFamily="34" charset="-122"/>
                 <a:cs typeface="Be Vietnam Pro" pitchFamily="34" charset="-120"/>
               </a:rPr>
-              <a:t> gặp:</a:t>
-            </a:r>
-            <a:r>
-              <a:rPr lang="en-US" sz="2850" b="1" dirty="0" spc="-8" kern="0">
-                <a:solidFill>
-                  <a:srgbClr val="3DD6A0"/>
-                </a:solidFill>
-                <a:latin typeface="Be Vietnam Pro" pitchFamily="34" charset="0"/>
-                <a:ea typeface="Be Vietnam Pro" pitchFamily="34" charset="-122"/>
-                <a:cs typeface="Be Vietnam Pro" pitchFamily="34" charset="-120"/>
-              </a:rPr>
-              <a:t> HashSet</a:t>
+              <a:t> PriorityQueue</a:t>
             </a:r>
             <a:endParaRPr lang="en-US" sz="2850" dirty="0"/>
           </a:p>
@@ -19524,7 +19315,7 @@
               <a:buNone/>
             </a:pPr>
             <a:r>
-              <a:rPr lang="en-US" sz="2250" dirty="0" spc="-4" kern="0">
+              <a:rPr lang="en-US" sz="2250" dirty="0" spc="-3" kern="0">
                 <a:solidFill>
                   <a:srgbClr val="F3EEE3"/>
                 </a:solidFill>
@@ -19532,7 +19323,18 @@
                 <a:ea typeface="Be Vietnam Pro" pitchFamily="34" charset="-122"/>
                 <a:cs typeface="Be Vietnam Pro" pitchFamily="34" charset="-120"/>
               </a:rPr>
-              <a:t>HashSet</a:t>
+              <a:t>Đầu</a:t>
+            </a:r>
+            <a:r>
+              <a:rPr lang="en-US" sz="2250" dirty="0" spc="-1" kern="0">
+                <a:solidFill>
+                  <a:srgbClr val="F3EEE3"/>
+                </a:solidFill>
+                <a:latin typeface="Be Vietnam Pro" pitchFamily="34" charset="0"/>
+                <a:ea typeface="Be Vietnam Pro" pitchFamily="34" charset="-122"/>
+                <a:cs typeface="Be Vietnam Pro" pitchFamily="34" charset="-120"/>
+              </a:rPr>
+              <a:t> hàng</a:t>
             </a:r>
             <a:r>
               <a:rPr lang="en-US" sz="2250" dirty="0" spc="0" kern="0">
@@ -19546,7 +19348,7 @@
               <a:t> là</a:t>
             </a:r>
             <a:r>
-              <a:rPr lang="en-US" sz="2250" dirty="0" spc="-4" kern="0">
+              <a:rPr lang="en-US" sz="2250" dirty="0" spc="1" kern="0">
                 <a:solidFill>
                   <a:srgbClr val="F3EEE3"/>
                 </a:solidFill>
@@ -19554,7 +19356,7 @@
                 <a:ea typeface="Be Vietnam Pro" pitchFamily="34" charset="-122"/>
                 <a:cs typeface="Be Vietnam Pro" pitchFamily="34" charset="-120"/>
               </a:rPr>
-              <a:t> một</a:t>
+              <a:t> phần</a:t>
             </a:r>
             <a:r>
               <a:rPr lang="en-US" sz="2250" dirty="0" spc="3" kern="0">
@@ -19565,7 +19367,51 @@
                 <a:ea typeface="Be Vietnam Pro" pitchFamily="34" charset="-122"/>
                 <a:cs typeface="Be Vietnam Pro" pitchFamily="34" charset="-120"/>
               </a:rPr>
-              <a:t> lớp</a:t>
+              <a:t> tử nhỏ</a:t>
+            </a:r>
+            <a:r>
+              <a:rPr lang="en-US" sz="2250" dirty="0" spc="-9" kern="0">
+                <a:solidFill>
+                  <a:srgbClr val="F3EEE3"/>
+                </a:solidFill>
+                <a:latin typeface="Be Vietnam Pro" pitchFamily="34" charset="0"/>
+                <a:ea typeface="Be Vietnam Pro" pitchFamily="34" charset="-122"/>
+                <a:cs typeface="Be Vietnam Pro" pitchFamily="34" charset="-120"/>
+              </a:rPr>
+              <a:t> nhất</a:t>
+            </a:r>
+            <a:r>
+              <a:rPr lang="en-US" sz="2250" dirty="0" spc="-3" kern="0">
+                <a:solidFill>
+                  <a:srgbClr val="F3EEE3"/>
+                </a:solidFill>
+                <a:latin typeface="Be Vietnam Pro" pitchFamily="34" charset="0"/>
+                <a:ea typeface="Be Vietnam Pro" pitchFamily="34" charset="-122"/>
+                <a:cs typeface="Be Vietnam Pro" pitchFamily="34" charset="-120"/>
+              </a:rPr>
+              <a:t> theo</a:t>
+            </a:r>
+            <a:r>
+              <a:rPr lang="en-US" sz="2250" dirty="0" spc="3" kern="0">
+                <a:solidFill>
+                  <a:srgbClr val="F3EEE3"/>
+                </a:solidFill>
+                <a:latin typeface="Be Vietnam Pro" pitchFamily="34" charset="0"/>
+                <a:ea typeface="Be Vietnam Pro" pitchFamily="34" charset="-122"/>
+                <a:cs typeface="Be Vietnam Pro" pitchFamily="34" charset="-120"/>
+              </a:rPr>
+              <a:t> thứ tự</a:t>
+            </a:r>
+            <a:r>
+              <a:rPr lang="en-US" sz="2250" dirty="0" spc="22" kern="0">
+                <a:solidFill>
+                  <a:srgbClr val="F3EEE3"/>
+                </a:solidFill>
+                <a:latin typeface="Be Vietnam Pro" pitchFamily="34" charset="0"/>
+                <a:ea typeface="Be Vietnam Pro" pitchFamily="34" charset="-122"/>
+                <a:cs typeface="Be Vietnam Pro" pitchFamily="34" charset="-120"/>
+              </a:rPr>
+              <a:t> ưu</a:t>
             </a:r>
             <a:r>
               <a:rPr lang="en-US" sz="2250" dirty="0" spc="0" kern="0">
@@ -19576,51 +19422,7 @@
                 <a:ea typeface="Be Vietnam Pro" pitchFamily="34" charset="-122"/>
                 <a:cs typeface="Be Vietnam Pro" pitchFamily="34" charset="-120"/>
               </a:rPr>
-              <a:t> cài đặt</a:t>
-            </a:r>
-            <a:r>
-              <a:rPr lang="en-US" sz="2250" dirty="0" spc="5" kern="0">
-                <a:solidFill>
-                  <a:srgbClr val="F3EEE3"/>
-                </a:solidFill>
-                <a:latin typeface="Be Vietnam Pro" pitchFamily="34" charset="0"/>
-                <a:ea typeface="Be Vietnam Pro" pitchFamily="34" charset="-122"/>
-                <a:cs typeface="Be Vietnam Pro" pitchFamily="34" charset="-120"/>
-              </a:rPr>
-              <a:t> thường</a:t>
-            </a:r>
-            <a:r>
-              <a:rPr lang="en-US" sz="2250" dirty="0" spc="-10" kern="0">
-                <a:solidFill>
-                  <a:srgbClr val="F3EEE3"/>
-                </a:solidFill>
-                <a:latin typeface="Be Vietnam Pro" pitchFamily="34" charset="0"/>
-                <a:ea typeface="Be Vietnam Pro" pitchFamily="34" charset="-122"/>
-                <a:cs typeface="Be Vietnam Pro" pitchFamily="34" charset="-120"/>
-              </a:rPr>
-              <a:t> gặp</a:t>
-            </a:r>
-            <a:r>
-              <a:rPr lang="en-US" sz="2250" dirty="0" spc="2" kern="0">
-                <a:solidFill>
-                  <a:srgbClr val="F3EEE3"/>
-                </a:solidFill>
-                <a:latin typeface="Be Vietnam Pro" pitchFamily="34" charset="0"/>
-                <a:ea typeface="Be Vietnam Pro" pitchFamily="34" charset="-122"/>
-                <a:cs typeface="Be Vietnam Pro" pitchFamily="34" charset="-120"/>
-              </a:rPr>
-              <a:t> của</a:t>
-            </a:r>
-            <a:r>
-              <a:rPr lang="en-US" sz="2250" dirty="0" spc="-2" kern="0">
-                <a:solidFill>
-                  <a:srgbClr val="F3EEE3"/>
-                </a:solidFill>
-                <a:latin typeface="Be Vietnam Pro" pitchFamily="34" charset="0"/>
-                <a:ea typeface="Be Vietnam Pro" pitchFamily="34" charset="-122"/>
-                <a:cs typeface="Be Vietnam Pro" pitchFamily="34" charset="-120"/>
-              </a:rPr>
-              <a:t> Set.</a:t>
+              <a:t> tiên.</a:t>
             </a:r>
             <a:endParaRPr lang="en-US" sz="2250" dirty="0"/>
           </a:p>
@@ -19721,7 +19523,7 @@
               <a:buNone/>
             </a:pPr>
             <a:r>
-              <a:rPr lang="en-US" sz="2850" b="1" dirty="0" spc="52" kern="0">
+              <a:rPr lang="en-US" sz="2850" b="1" dirty="0" spc="-1" kern="0">
                 <a:solidFill>
                   <a:srgbClr val="FF6A4D"/>
                 </a:solidFill>
@@ -19729,10 +19531,10 @@
                 <a:ea typeface="Be Vietnam Pro" pitchFamily="34" charset="-122"/>
                 <a:cs typeface="Be Vietnam Pro" pitchFamily="34" charset="-120"/>
               </a:rPr>
-              <a:t>Vì</a:t>
-            </a:r>
-            <a:r>
-              <a:rPr lang="en-US" sz="2850" b="1" dirty="0" spc="4" kern="0">
+              <a:t>Bảng</a:t>
+            </a:r>
+            <a:r>
+              <a:rPr lang="en-US" sz="2850" b="1" dirty="0" spc="-11" kern="0">
                 <a:solidFill>
                   <a:srgbClr val="FF6A4D"/>
                 </a:solidFill>
@@ -19740,32 +19542,10 @@
                 <a:ea typeface="Be Vietnam Pro" pitchFamily="34" charset="-122"/>
                 <a:cs typeface="Be Vietnam Pro" pitchFamily="34" charset="-120"/>
               </a:rPr>
-              <a:t> sao</a:t>
-            </a:r>
-            <a:r>
-              <a:rPr lang="en-US" sz="2850" b="1" dirty="0" spc="-8" kern="0">
-                <a:solidFill>
-                  <a:srgbClr val="FF6A4D"/>
-                </a:solidFill>
-                <a:latin typeface="Be Vietnam Pro" pitchFamily="34" charset="0"/>
-                <a:ea typeface="Be Vietnam Pro" pitchFamily="34" charset="-122"/>
-                <a:cs typeface="Be Vietnam Pro" pitchFamily="34" charset="-120"/>
-              </a:rPr>
-              <a:t> không</a:t>
-            </a:r>
-            <a:r>
-              <a:rPr lang="en-US" sz="2850" b="1" dirty="0" spc="-2" kern="0">
-                <a:solidFill>
-                  <a:srgbClr val="FF6A4D"/>
-                </a:solidFill>
-                <a:latin typeface="Be Vietnam Pro" pitchFamily="34" charset="0"/>
-                <a:ea typeface="Be Vietnam Pro" pitchFamily="34" charset="-122"/>
-                <a:cs typeface="Be Vietnam Pro" pitchFamily="34" charset="-120"/>
-              </a:rPr>
-              <a:t> phải</a:t>
-            </a:r>
-            <a:r>
-              <a:rPr lang="en-US" sz="2850" b="1" dirty="0" spc="1" kern="0">
+              <a:t> tra:</a:t>
+            </a:r>
+            <a:r>
+              <a:rPr lang="en-US" sz="2850" b="1" dirty="0" spc="2" kern="0">
                 <a:solidFill>
                   <a:srgbClr val="FF6A4D"/>
                 </a:solidFill>
@@ -20178,7 +19958,7 @@
               <a:buChar char="•"/>
             </a:pPr>
             <a:r>
-              <a:rPr lang="en-US" sz="2250" dirty="0" spc="-2" kern="0">
+              <a:rPr lang="en-US" sz="2250" dirty="0" spc="-3" kern="0">
                 <a:solidFill>
                   <a:srgbClr val="F3EEE3"/>
                 </a:solidFill>
@@ -20186,10 +19966,10 @@
                 <a:ea typeface="Be Vietnam Pro" pitchFamily="34" charset="-122"/>
                 <a:cs typeface="Be Vietnam Pro" pitchFamily="34" charset="-120"/>
               </a:rPr>
-              <a:t>Map</a:t>
-            </a:r>
-            <a:r>
-              <a:rPr lang="en-US" sz="2250" dirty="0" spc="16" kern="0">
+              <a:t>Khóa</a:t>
+            </a:r>
+            <a:r>
+              <a:rPr lang="en-US" sz="2250" dirty="0" spc="-21" kern="0">
                 <a:solidFill>
                   <a:srgbClr val="F3EEE3"/>
                 </a:solidFill>
@@ -20197,10 +19977,10 @@
                 <a:ea typeface="Be Vietnam Pro" pitchFamily="34" charset="-122"/>
                 <a:cs typeface="Be Vietnam Pro" pitchFamily="34" charset="-120"/>
               </a:rPr>
-              <a:t> lưu</a:t>
-            </a:r>
-            <a:r>
-              <a:rPr lang="en-US" sz="2250" dirty="0" spc="2" kern="0">
+              <a:t> trỏ</a:t>
+            </a:r>
+            <a:r>
+              <a:rPr lang="en-US" sz="2250" dirty="0" spc="-10" kern="0">
                 <a:solidFill>
                   <a:srgbClr val="F3EEE3"/>
                 </a:solidFill>
@@ -20208,29 +19988,7 @@
                 <a:ea typeface="Be Vietnam Pro" pitchFamily="34" charset="-122"/>
                 <a:cs typeface="Be Vietnam Pro" pitchFamily="34" charset="-120"/>
               </a:rPr>
-              <a:t> cặp</a:t>
-            </a:r>
-            <a:r>
-              <a:rPr lang="en-US" sz="2250" dirty="0" spc="-2" kern="0">
-                <a:solidFill>
-                  <a:srgbClr val="F3EEE3"/>
-                </a:solidFill>
-                <a:latin typeface="Be Vietnam Pro" pitchFamily="34" charset="0"/>
-                <a:ea typeface="Be Vietnam Pro" pitchFamily="34" charset="-122"/>
-                <a:cs typeface="Be Vietnam Pro" pitchFamily="34" charset="-120"/>
-              </a:rPr>
-              <a:t> khóa</a:t>
-            </a:r>
-            <a:r>
-              <a:rPr lang="en-US" sz="2250" dirty="0" spc="-16" kern="0">
-                <a:solidFill>
-                  <a:srgbClr val="F3EEE3"/>
-                </a:solidFill>
-                <a:latin typeface="Be Vietnam Pro" pitchFamily="34" charset="0"/>
-                <a:ea typeface="Be Vietnam Pro" pitchFamily="34" charset="-122"/>
-                <a:cs typeface="Be Vietnam Pro" pitchFamily="34" charset="-120"/>
-              </a:rPr>
-              <a:t> và</a:t>
+              <a:t> tới</a:t>
             </a:r>
             <a:r>
               <a:rPr lang="en-US" sz="2250" dirty="0" spc="-3" kern="0">
@@ -20269,7 +20027,7 @@
               <a:buChar char="•"/>
             </a:pPr>
             <a:r>
-              <a:rPr lang="en-US" sz="2250" dirty="0" spc="-4" kern="0">
+              <a:rPr lang="en-US" sz="2250" dirty="0" spc="-2" kern="0">
                 <a:solidFill>
                   <a:srgbClr val="F3EEE3"/>
                 </a:solidFill>
@@ -20277,7 +20035,18 @@
                 <a:ea typeface="Be Vietnam Pro" pitchFamily="34" charset="-122"/>
                 <a:cs typeface="Be Vietnam Pro" pitchFamily="34" charset="-120"/>
               </a:rPr>
-              <a:t>Nằm</a:t>
+              <a:t>Map</a:t>
+            </a:r>
+            <a:r>
+              <a:rPr lang="en-US" sz="2250" dirty="0" spc="-1" kern="0">
+                <a:solidFill>
+                  <a:srgbClr val="F3EEE3"/>
+                </a:solidFill>
+                <a:latin typeface="Be Vietnam Pro" pitchFamily="34" charset="0"/>
+                <a:ea typeface="Be Vietnam Pro" pitchFamily="34" charset="-122"/>
+                <a:cs typeface="Be Vietnam Pro" pitchFamily="34" charset="-120"/>
+              </a:rPr>
+              <a:t> nằm</a:t>
             </a:r>
             <a:r>
               <a:rPr lang="en-US" sz="2250" dirty="0" spc="-12" kern="0">
@@ -20324,6 +20093,39 @@
               <a:buChar char="•"/>
             </a:pPr>
             <a:r>
+              <a:rPr lang="en-US" sz="2250" dirty="0" spc="-2" kern="0">
+                <a:solidFill>
+                  <a:srgbClr val="F3EEE3"/>
+                </a:solidFill>
+                <a:latin typeface="Be Vietnam Pro" pitchFamily="34" charset="0"/>
+                <a:ea typeface="Be Vietnam Pro" pitchFamily="34" charset="-122"/>
+                <a:cs typeface="Be Vietnam Pro" pitchFamily="34" charset="-120"/>
+              </a:rPr>
+              <a:t>Mỗi khóa</a:t>
+            </a:r>
+            <a:r>
+              <a:rPr lang="en-US" sz="2250" dirty="0" spc="-10" kern="0">
+                <a:solidFill>
+                  <a:srgbClr val="F3EEE3"/>
+                </a:solidFill>
+                <a:latin typeface="Be Vietnam Pro" pitchFamily="34" charset="0"/>
+                <a:ea typeface="Be Vietnam Pro" pitchFamily="34" charset="-122"/>
+                <a:cs typeface="Be Vietnam Pro" pitchFamily="34" charset="-120"/>
+              </a:rPr>
+              <a:t> tối</a:t>
+            </a:r>
+            <a:r>
+              <a:rPr lang="en-US" sz="2250" dirty="0" spc="15" kern="0">
+                <a:solidFill>
+                  <a:srgbClr val="F3EEE3"/>
+                </a:solidFill>
+                <a:latin typeface="Be Vietnam Pro" pitchFamily="34" charset="0"/>
+                <a:ea typeface="Be Vietnam Pro" pitchFamily="34" charset="-122"/>
+                <a:cs typeface="Be Vietnam Pro" pitchFamily="34" charset="-120"/>
+              </a:rPr>
+              <a:t> đa</a:t>
+            </a:r>
+            <a:r>
               <a:rPr lang="en-US" sz="2250" dirty="0" spc="-4" kern="0">
                 <a:solidFill>
                   <a:srgbClr val="F3EEE3"/>
@@ -20332,10 +20134,10 @@
                 <a:ea typeface="Be Vietnam Pro" pitchFamily="34" charset="-122"/>
                 <a:cs typeface="Be Vietnam Pro" pitchFamily="34" charset="-120"/>
               </a:rPr>
-              <a:t>Chỉ</a:t>
-            </a:r>
-            <a:r>
-              <a:rPr lang="en-US" sz="2250" dirty="0" spc="1" kern="0">
+              <a:t> một</a:t>
+            </a:r>
+            <a:r>
+              <a:rPr lang="en-US" sz="2250" dirty="0" spc="-2" kern="0">
                 <a:solidFill>
                   <a:srgbClr val="F3EEE3"/>
                 </a:solidFill>
@@ -20343,10 +20145,10 @@
                 <a:ea typeface="Be Vietnam Pro" pitchFamily="34" charset="-122"/>
                 <a:cs typeface="Be Vietnam Pro" pitchFamily="34" charset="-120"/>
               </a:rPr>
-              <a:t> hỏi</a:t>
-            </a:r>
-            <a:r>
-              <a:rPr lang="en-US" sz="2250" dirty="0" spc="-1" kern="0">
+              <a:t> giá</a:t>
+            </a:r>
+            <a:r>
+              <a:rPr lang="en-US" sz="2250" dirty="0" spc="10" kern="0">
                 <a:solidFill>
                   <a:srgbClr val="F3EEE3"/>
                 </a:solidFill>
@@ -20354,73 +20156,7 @@
                 <a:ea typeface="Be Vietnam Pro" pitchFamily="34" charset="-122"/>
                 <a:cs typeface="Be Vietnam Pro" pitchFamily="34" charset="-120"/>
               </a:rPr>
-              <a:t> mã</a:t>
-            </a:r>
-            <a:r>
-              <a:rPr lang="en-US" sz="2250" dirty="0" spc="15" kern="0">
-                <a:solidFill>
-                  <a:srgbClr val="F3EEE3"/>
-                </a:solidFill>
-                <a:latin typeface="Be Vietnam Pro" pitchFamily="34" charset="0"/>
-                <a:ea typeface="Be Vietnam Pro" pitchFamily="34" charset="-122"/>
-                <a:cs typeface="Be Vietnam Pro" pitchFamily="34" charset="-120"/>
-              </a:rPr>
-              <a:t> đã</a:t>
-            </a:r>
-            <a:r>
-              <a:rPr lang="en-US" sz="2250" dirty="0" spc="5" kern="0">
-                <a:solidFill>
-                  <a:srgbClr val="F3EEE3"/>
-                </a:solidFill>
-                <a:latin typeface="Be Vietnam Pro" pitchFamily="34" charset="0"/>
-                <a:ea typeface="Be Vietnam Pro" pitchFamily="34" charset="-122"/>
-                <a:cs typeface="Be Vietnam Pro" pitchFamily="34" charset="-120"/>
-              </a:rPr>
-              <a:t> có</a:t>
-            </a:r>
-            <a:r>
-              <a:rPr lang="en-US" sz="2250" dirty="0" spc="6" kern="0">
-                <a:solidFill>
-                  <a:srgbClr val="F3EEE3"/>
-                </a:solidFill>
-                <a:latin typeface="Be Vietnam Pro" pitchFamily="34" charset="0"/>
-                <a:ea typeface="Be Vietnam Pro" pitchFamily="34" charset="-122"/>
-                <a:cs typeface="Be Vietnam Pro" pitchFamily="34" charset="-120"/>
-              </a:rPr>
-              <a:t> chưa:</a:t>
-            </a:r>
-            <a:r>
-              <a:rPr lang="en-US" sz="2250" dirty="0" spc="-4" kern="0">
-                <a:solidFill>
-                  <a:srgbClr val="F3EEE3"/>
-                </a:solidFill>
-                <a:latin typeface="Be Vietnam Pro" pitchFamily="34" charset="0"/>
-                <a:ea typeface="Be Vietnam Pro" pitchFamily="34" charset="-122"/>
-                <a:cs typeface="Be Vietnam Pro" pitchFamily="34" charset="-120"/>
-              </a:rPr>
-              <a:t> Set</a:t>
-            </a:r>
-            <a:r>
-              <a:rPr lang="en-US" sz="2250" dirty="0" spc="3" kern="0">
-                <a:solidFill>
-                  <a:srgbClr val="F3EEE3"/>
-                </a:solidFill>
-                <a:latin typeface="Be Vietnam Pro" pitchFamily="34" charset="0"/>
-                <a:ea typeface="Be Vietnam Pro" pitchFamily="34" charset="-122"/>
-                <a:cs typeface="Be Vietnam Pro" pitchFamily="34" charset="-120"/>
-              </a:rPr>
-              <a:t> khớp</a:t>
-            </a:r>
-            <a:r>
-              <a:rPr lang="en-US" sz="2250" dirty="0" spc="0" kern="0">
-                <a:solidFill>
-                  <a:srgbClr val="F3EEE3"/>
-                </a:solidFill>
-                <a:latin typeface="Be Vietnam Pro" pitchFamily="34" charset="0"/>
-                <a:ea typeface="Be Vietnam Pro" pitchFamily="34" charset="-122"/>
-                <a:cs typeface="Be Vietnam Pro" pitchFamily="34" charset="-120"/>
-              </a:rPr>
-              <a:t> hơn</a:t>
+              <a:t> trị</a:t>
             </a:r>
             <a:endParaRPr lang="en-US" sz="2250" dirty="0"/>
           </a:p>

</xml_diff>

<commit_message>
Lesson sd-10-005: limit the no-direct-implementation claim to concrete classes, with the figure, metadata and deck
Co-Authored-By: Claude Sonnet 5.5 <noreply@anthropic.com>
Claude-Session: https://claude.ai/code/session_01Y9NYFwg4CcDYEWi1zr53gi
</commit_message>
<xml_diff>
--- a/system-design-101/vi/lessons/sd-10-005/slides/sd-10-005.pptx
+++ b/system-design-101/vi/lessons/sd-10-005/slides/sd-10-005.pptx
@@ -8672,7 +8672,7 @@
               <a:buNone/>
             </a:pPr>
             <a:r>
-              <a:rPr lang="en-US" sz="1950" dirty="0" spc="-4" kern="0">
+              <a:rPr lang="en-US" sz="1650" dirty="0" spc="-2" kern="0">
                 <a:solidFill>
                   <a:srgbClr val="14161C"/>
                 </a:solidFill>
@@ -8680,10 +8680,10 @@
                 <a:ea typeface="Be Vietnam Pro" pitchFamily="34" charset="-122"/>
                 <a:cs typeface="Be Vietnam Pro" pitchFamily="34" charset="-120"/>
               </a:rPr>
-              <a:t>JDK</a:t>
-            </a:r>
-            <a:r>
-              <a:rPr lang="en-US" sz="1950" dirty="0" spc="0" kern="0">
+              <a:t>Không</a:t>
+            </a:r>
+            <a:r>
+              <a:rPr lang="en-US" sz="1650" dirty="0" spc="1" kern="0">
                 <a:solidFill>
                   <a:srgbClr val="14161C"/>
                 </a:solidFill>
@@ -8691,10 +8691,10 @@
                 <a:ea typeface="Be Vietnam Pro" pitchFamily="34" charset="-122"/>
                 <a:cs typeface="Be Vietnam Pro" pitchFamily="34" charset="-120"/>
               </a:rPr>
-              <a:t> không</a:t>
-            </a:r>
-            <a:r>
-              <a:rPr lang="en-US" sz="1950" dirty="0" spc="-2" kern="0">
+              <a:t> có lớp cụ</a:t>
+            </a:r>
+            <a:r>
+              <a:rPr lang="en-US" sz="1650" dirty="0" spc="4" kern="0">
                 <a:solidFill>
                   <a:srgbClr val="14161C"/>
                 </a:solidFill>
@@ -8702,10 +8702,21 @@
                 <a:ea typeface="Be Vietnam Pro" pitchFamily="34" charset="-122"/>
                 <a:cs typeface="Be Vietnam Pro" pitchFamily="34" charset="-120"/>
               </a:rPr>
+              <a:t> thể</a:t>
+            </a:r>
+            <a:r>
+              <a:rPr lang="en-US" sz="1650" dirty="0" spc="1" kern="0">
+                <a:solidFill>
+                  <a:srgbClr val="14161C"/>
+                </a:solidFill>
+                <a:latin typeface="Be Vietnam Pro" pitchFamily="34" charset="0"/>
+                <a:ea typeface="Be Vietnam Pro" pitchFamily="34" charset="-122"/>
+                <a:cs typeface="Be Vietnam Pro" pitchFamily="34" charset="-120"/>
+              </a:rPr>
               <a:t> cài</a:t>
             </a:r>
             <a:r>
-              <a:rPr lang="en-US" sz="1950" dirty="0" spc="-1" kern="0">
+              <a:rPr lang="en-US" sz="1650" dirty="0" spc="4" kern="0">
                 <a:solidFill>
                   <a:srgbClr val="14161C"/>
                 </a:solidFill>
@@ -8716,7 +8727,7 @@
               <a:t> đặt</a:t>
             </a:r>
             <a:r>
-              <a:rPr lang="en-US" sz="1950" dirty="0" spc="5" kern="0">
+              <a:rPr lang="en-US" sz="1650" dirty="0" spc="6" kern="0">
                 <a:solidFill>
                   <a:srgbClr val="14161C"/>
                 </a:solidFill>
@@ -8727,7 +8738,7 @@
               <a:t> trực</a:t>
             </a:r>
             <a:r>
-              <a:rPr lang="en-US" sz="1950" dirty="0" spc="-1" kern="0">
+              <a:rPr lang="en-US" sz="1650" dirty="0" spc="3" kern="0">
                 <a:solidFill>
                   <a:srgbClr val="14161C"/>
                 </a:solidFill>
@@ -8737,7 +8748,7 @@
               </a:rPr>
               <a:t> tiếp</a:t>
             </a:r>
-            <a:endParaRPr lang="en-US" sz="1950" dirty="0"/>
+            <a:endParaRPr lang="en-US" sz="1650" dirty="0"/>
           </a:p>
         </p:txBody>
       </p:sp>

</xml_diff>